<commit_message>
Re-cuantizar HelloWorld solo pesos
</commit_message>
<xml_diff>
--- a/Edge Computing para Control Biónico con Señales Cerebrales.pptx
+++ b/Edge Computing para Control Biónico con Señales Cerebrales.pptx
@@ -5,19 +5,16 @@
     <p:sldMasterId id="2147483648" r:id="rId4"/>
   </p:sldMasterIdLst>
   <p:notesMasterIdLst>
-    <p:notesMasterId r:id="rId15"/>
+    <p:notesMasterId r:id="rId12"/>
   </p:notesMasterIdLst>
   <p:sldIdLst>
     <p:sldId id="256" r:id="rId5"/>
     <p:sldId id="283" r:id="rId6"/>
-    <p:sldId id="275" r:id="rId7"/>
-    <p:sldId id="276" r:id="rId8"/>
-    <p:sldId id="277" r:id="rId9"/>
-    <p:sldId id="278" r:id="rId10"/>
-    <p:sldId id="279" r:id="rId11"/>
-    <p:sldId id="280" r:id="rId12"/>
-    <p:sldId id="281" r:id="rId13"/>
-    <p:sldId id="282" r:id="rId14"/>
+    <p:sldId id="279" r:id="rId7"/>
+    <p:sldId id="286" r:id="rId8"/>
+    <p:sldId id="285" r:id="rId9"/>
+    <p:sldId id="276" r:id="rId10"/>
+    <p:sldId id="284" r:id="rId11"/>
   </p:sldIdLst>
   <p:sldSz cx="12192000" cy="6858000"/>
   <p:notesSz cx="6858000" cy="9144000"/>
@@ -124,12 +121,2540 @@
 </p:presentation>
 </file>
 
-<file path=ppt/revisionInfo.xml><?xml version="1.0" encoding="utf-8"?>
-<p1510:revInfo xmlns:a="http://schemas.openxmlformats.org/drawingml/2006/main" xmlns:r="http://schemas.openxmlformats.org/officeDocument/2006/relationships" xmlns:p1510="http://schemas.microsoft.com/office/powerpoint/2015/10/main">
-  <p1510:revLst>
-    <p1510:client id="{9A0210F5-8819-4D58-ACDC-D792472D2FE5}" v="1" dt="2025-06-03T04:03:44.415"/>
-  </p1510:revLst>
-</p1510:revInfo>
+<file path=ppt/diagrams/colors1.xml><?xml version="1.0" encoding="utf-8"?>
+<dgm:colorsDef xmlns:dgm="http://schemas.openxmlformats.org/drawingml/2006/diagram" xmlns:a="http://schemas.openxmlformats.org/drawingml/2006/main" uniqueId="urn:microsoft.com/office/officeart/2005/8/colors/accent1_2">
+  <dgm:title val=""/>
+  <dgm:desc val=""/>
+  <dgm:catLst>
+    <dgm:cat type="accent1" pri="11200"/>
+  </dgm:catLst>
+  <dgm:styleLbl name="node0">
+    <dgm:fillClrLst meth="repeat">
+      <a:schemeClr val="accent1"/>
+    </dgm:fillClrLst>
+    <dgm:linClrLst meth="repeat">
+      <a:schemeClr val="lt1"/>
+    </dgm:linClrLst>
+    <dgm:effectClrLst/>
+    <dgm:txLinClrLst/>
+    <dgm:txFillClrLst/>
+    <dgm:txEffectClrLst/>
+  </dgm:styleLbl>
+  <dgm:styleLbl name="alignNode1">
+    <dgm:fillClrLst meth="repeat">
+      <a:schemeClr val="accent1"/>
+    </dgm:fillClrLst>
+    <dgm:linClrLst meth="repeat">
+      <a:schemeClr val="accent1"/>
+    </dgm:linClrLst>
+    <dgm:effectClrLst/>
+    <dgm:txLinClrLst/>
+    <dgm:txFillClrLst/>
+    <dgm:txEffectClrLst/>
+  </dgm:styleLbl>
+  <dgm:styleLbl name="node1">
+    <dgm:fillClrLst meth="repeat">
+      <a:schemeClr val="accent1"/>
+    </dgm:fillClrLst>
+    <dgm:linClrLst meth="repeat">
+      <a:schemeClr val="lt1"/>
+    </dgm:linClrLst>
+    <dgm:effectClrLst/>
+    <dgm:txLinClrLst/>
+    <dgm:txFillClrLst/>
+    <dgm:txEffectClrLst/>
+  </dgm:styleLbl>
+  <dgm:styleLbl name="lnNode1">
+    <dgm:fillClrLst meth="repeat">
+      <a:schemeClr val="accent1"/>
+    </dgm:fillClrLst>
+    <dgm:linClrLst meth="repeat">
+      <a:schemeClr val="lt1"/>
+    </dgm:linClrLst>
+    <dgm:effectClrLst/>
+    <dgm:txLinClrLst/>
+    <dgm:txFillClrLst/>
+    <dgm:txEffectClrLst/>
+  </dgm:styleLbl>
+  <dgm:styleLbl name="vennNode1">
+    <dgm:fillClrLst meth="repeat">
+      <a:schemeClr val="accent1">
+        <a:alpha val="50000"/>
+      </a:schemeClr>
+    </dgm:fillClrLst>
+    <dgm:linClrLst meth="repeat">
+      <a:schemeClr val="lt1"/>
+    </dgm:linClrLst>
+    <dgm:effectClrLst/>
+    <dgm:txLinClrLst/>
+    <dgm:txFillClrLst/>
+    <dgm:txEffectClrLst/>
+  </dgm:styleLbl>
+  <dgm:styleLbl name="node2">
+    <dgm:fillClrLst meth="repeat">
+      <a:schemeClr val="accent1"/>
+    </dgm:fillClrLst>
+    <dgm:linClrLst meth="repeat">
+      <a:schemeClr val="lt1"/>
+    </dgm:linClrLst>
+    <dgm:effectClrLst/>
+    <dgm:txLinClrLst/>
+    <dgm:txFillClrLst/>
+    <dgm:txEffectClrLst/>
+  </dgm:styleLbl>
+  <dgm:styleLbl name="node3">
+    <dgm:fillClrLst meth="repeat">
+      <a:schemeClr val="accent1"/>
+    </dgm:fillClrLst>
+    <dgm:linClrLst meth="repeat">
+      <a:schemeClr val="lt1"/>
+    </dgm:linClrLst>
+    <dgm:effectClrLst/>
+    <dgm:txLinClrLst/>
+    <dgm:txFillClrLst/>
+    <dgm:txEffectClrLst/>
+  </dgm:styleLbl>
+  <dgm:styleLbl name="node4">
+    <dgm:fillClrLst meth="repeat">
+      <a:schemeClr val="accent1"/>
+    </dgm:fillClrLst>
+    <dgm:linClrLst meth="repeat">
+      <a:schemeClr val="lt1"/>
+    </dgm:linClrLst>
+    <dgm:effectClrLst/>
+    <dgm:txLinClrLst/>
+    <dgm:txFillClrLst/>
+    <dgm:txEffectClrLst/>
+  </dgm:styleLbl>
+  <dgm:styleLbl name="fgImgPlace1">
+    <dgm:fillClrLst meth="repeat">
+      <a:schemeClr val="accent1">
+        <a:tint val="50000"/>
+      </a:schemeClr>
+    </dgm:fillClrLst>
+    <dgm:linClrLst meth="repeat">
+      <a:schemeClr val="lt1"/>
+    </dgm:linClrLst>
+    <dgm:effectClrLst/>
+    <dgm:txLinClrLst/>
+    <dgm:txFillClrLst meth="repeat">
+      <a:schemeClr val="lt1"/>
+    </dgm:txFillClrLst>
+    <dgm:txEffectClrLst/>
+  </dgm:styleLbl>
+  <dgm:styleLbl name="alignImgPlace1">
+    <dgm:fillClrLst meth="repeat">
+      <a:schemeClr val="accent1">
+        <a:tint val="50000"/>
+      </a:schemeClr>
+    </dgm:fillClrLst>
+    <dgm:linClrLst meth="repeat">
+      <a:schemeClr val="lt1"/>
+    </dgm:linClrLst>
+    <dgm:effectClrLst/>
+    <dgm:txLinClrLst/>
+    <dgm:txFillClrLst meth="repeat">
+      <a:schemeClr val="lt1"/>
+    </dgm:txFillClrLst>
+    <dgm:txEffectClrLst/>
+  </dgm:styleLbl>
+  <dgm:styleLbl name="bgImgPlace1">
+    <dgm:fillClrLst meth="repeat">
+      <a:schemeClr val="accent1">
+        <a:tint val="50000"/>
+      </a:schemeClr>
+    </dgm:fillClrLst>
+    <dgm:linClrLst meth="repeat">
+      <a:schemeClr val="lt1"/>
+    </dgm:linClrLst>
+    <dgm:effectClrLst/>
+    <dgm:txLinClrLst/>
+    <dgm:txFillClrLst meth="repeat">
+      <a:schemeClr val="lt1"/>
+    </dgm:txFillClrLst>
+    <dgm:txEffectClrLst/>
+  </dgm:styleLbl>
+  <dgm:styleLbl name="sibTrans2D1">
+    <dgm:fillClrLst meth="repeat">
+      <a:schemeClr val="accent1">
+        <a:tint val="60000"/>
+      </a:schemeClr>
+    </dgm:fillClrLst>
+    <dgm:linClrLst meth="repeat">
+      <a:schemeClr val="accent1">
+        <a:tint val="60000"/>
+      </a:schemeClr>
+    </dgm:linClrLst>
+    <dgm:effectClrLst/>
+    <dgm:txLinClrLst/>
+    <dgm:txFillClrLst/>
+    <dgm:txEffectClrLst/>
+  </dgm:styleLbl>
+  <dgm:styleLbl name="fgSibTrans2D1">
+    <dgm:fillClrLst meth="repeat">
+      <a:schemeClr val="accent1">
+        <a:tint val="60000"/>
+      </a:schemeClr>
+    </dgm:fillClrLst>
+    <dgm:linClrLst meth="repeat">
+      <a:schemeClr val="accent1">
+        <a:tint val="60000"/>
+      </a:schemeClr>
+    </dgm:linClrLst>
+    <dgm:effectClrLst/>
+    <dgm:txLinClrLst/>
+    <dgm:txFillClrLst/>
+    <dgm:txEffectClrLst/>
+  </dgm:styleLbl>
+  <dgm:styleLbl name="bgSibTrans2D1">
+    <dgm:fillClrLst meth="repeat">
+      <a:schemeClr val="accent1">
+        <a:tint val="60000"/>
+      </a:schemeClr>
+    </dgm:fillClrLst>
+    <dgm:linClrLst meth="repeat">
+      <a:schemeClr val="accent1">
+        <a:tint val="60000"/>
+      </a:schemeClr>
+    </dgm:linClrLst>
+    <dgm:effectClrLst/>
+    <dgm:txLinClrLst/>
+    <dgm:txFillClrLst/>
+    <dgm:txEffectClrLst/>
+  </dgm:styleLbl>
+  <dgm:styleLbl name="sibTrans1D1">
+    <dgm:fillClrLst meth="repeat">
+      <a:schemeClr val="accent1"/>
+    </dgm:fillClrLst>
+    <dgm:linClrLst meth="repeat">
+      <a:schemeClr val="accent1"/>
+    </dgm:linClrLst>
+    <dgm:effectClrLst/>
+    <dgm:txLinClrLst/>
+    <dgm:txFillClrLst meth="repeat">
+      <a:schemeClr val="tx1"/>
+    </dgm:txFillClrLst>
+    <dgm:txEffectClrLst/>
+  </dgm:styleLbl>
+  <dgm:styleLbl name="callout">
+    <dgm:fillClrLst meth="repeat">
+      <a:schemeClr val="accent1"/>
+    </dgm:fillClrLst>
+    <dgm:linClrLst meth="repeat">
+      <a:schemeClr val="accent1">
+        <a:tint val="50000"/>
+      </a:schemeClr>
+    </dgm:linClrLst>
+    <dgm:effectClrLst/>
+    <dgm:txLinClrLst/>
+    <dgm:txFillClrLst meth="repeat">
+      <a:schemeClr val="tx1"/>
+    </dgm:txFillClrLst>
+    <dgm:txEffectClrLst/>
+  </dgm:styleLbl>
+  <dgm:styleLbl name="asst0">
+    <dgm:fillClrLst meth="repeat">
+      <a:schemeClr val="accent1"/>
+    </dgm:fillClrLst>
+    <dgm:linClrLst meth="repeat">
+      <a:schemeClr val="lt1"/>
+    </dgm:linClrLst>
+    <dgm:effectClrLst/>
+    <dgm:txLinClrLst/>
+    <dgm:txFillClrLst/>
+    <dgm:txEffectClrLst/>
+  </dgm:styleLbl>
+  <dgm:styleLbl name="asst1">
+    <dgm:fillClrLst meth="repeat">
+      <a:schemeClr val="accent1"/>
+    </dgm:fillClrLst>
+    <dgm:linClrLst meth="repeat">
+      <a:schemeClr val="lt1"/>
+    </dgm:linClrLst>
+    <dgm:effectClrLst/>
+    <dgm:txLinClrLst/>
+    <dgm:txFillClrLst/>
+    <dgm:txEffectClrLst/>
+  </dgm:styleLbl>
+  <dgm:styleLbl name="asst2">
+    <dgm:fillClrLst meth="repeat">
+      <a:schemeClr val="accent1"/>
+    </dgm:fillClrLst>
+    <dgm:linClrLst meth="repeat">
+      <a:schemeClr val="lt1"/>
+    </dgm:linClrLst>
+    <dgm:effectClrLst/>
+    <dgm:txLinClrLst/>
+    <dgm:txFillClrLst/>
+    <dgm:txEffectClrLst/>
+  </dgm:styleLbl>
+  <dgm:styleLbl name="asst3">
+    <dgm:fillClrLst meth="repeat">
+      <a:schemeClr val="accent1"/>
+    </dgm:fillClrLst>
+    <dgm:linClrLst meth="repeat">
+      <a:schemeClr val="lt1"/>
+    </dgm:linClrLst>
+    <dgm:effectClrLst/>
+    <dgm:txLinClrLst/>
+    <dgm:txFillClrLst/>
+    <dgm:txEffectClrLst/>
+  </dgm:styleLbl>
+  <dgm:styleLbl name="asst4">
+    <dgm:fillClrLst meth="repeat">
+      <a:schemeClr val="accent1"/>
+    </dgm:fillClrLst>
+    <dgm:linClrLst meth="repeat">
+      <a:schemeClr val="lt1"/>
+    </dgm:linClrLst>
+    <dgm:effectClrLst/>
+    <dgm:txLinClrLst/>
+    <dgm:txFillClrLst/>
+    <dgm:txEffectClrLst/>
+  </dgm:styleLbl>
+  <dgm:styleLbl name="parChTrans2D1">
+    <dgm:fillClrLst meth="repeat">
+      <a:schemeClr val="accent1">
+        <a:tint val="60000"/>
+      </a:schemeClr>
+    </dgm:fillClrLst>
+    <dgm:linClrLst meth="repeat">
+      <a:schemeClr val="accent1">
+        <a:tint val="60000"/>
+      </a:schemeClr>
+    </dgm:linClrLst>
+    <dgm:effectClrLst/>
+    <dgm:txLinClrLst/>
+    <dgm:txFillClrLst meth="repeat">
+      <a:schemeClr val="lt1"/>
+    </dgm:txFillClrLst>
+    <dgm:txEffectClrLst/>
+  </dgm:styleLbl>
+  <dgm:styleLbl name="parChTrans2D2">
+    <dgm:fillClrLst meth="repeat">
+      <a:schemeClr val="accent1"/>
+    </dgm:fillClrLst>
+    <dgm:linClrLst meth="repeat">
+      <a:schemeClr val="accent1"/>
+    </dgm:linClrLst>
+    <dgm:effectClrLst/>
+    <dgm:txLinClrLst/>
+    <dgm:txFillClrLst meth="repeat">
+      <a:schemeClr val="lt1"/>
+    </dgm:txFillClrLst>
+    <dgm:txEffectClrLst/>
+  </dgm:styleLbl>
+  <dgm:styleLbl name="parChTrans2D3">
+    <dgm:fillClrLst meth="repeat">
+      <a:schemeClr val="accent1"/>
+    </dgm:fillClrLst>
+    <dgm:linClrLst meth="repeat">
+      <a:schemeClr val="accent1"/>
+    </dgm:linClrLst>
+    <dgm:effectClrLst/>
+    <dgm:txLinClrLst/>
+    <dgm:txFillClrLst meth="repeat">
+      <a:schemeClr val="lt1"/>
+    </dgm:txFillClrLst>
+    <dgm:txEffectClrLst/>
+  </dgm:styleLbl>
+  <dgm:styleLbl name="parChTrans2D4">
+    <dgm:fillClrLst meth="repeat">
+      <a:schemeClr val="accent1"/>
+    </dgm:fillClrLst>
+    <dgm:linClrLst meth="repeat">
+      <a:schemeClr val="accent1"/>
+    </dgm:linClrLst>
+    <dgm:effectClrLst/>
+    <dgm:txLinClrLst/>
+    <dgm:txFillClrLst meth="repeat">
+      <a:schemeClr val="lt1"/>
+    </dgm:txFillClrLst>
+    <dgm:txEffectClrLst/>
+  </dgm:styleLbl>
+  <dgm:styleLbl name="parChTrans1D1">
+    <dgm:fillClrLst meth="repeat">
+      <a:schemeClr val="accent1"/>
+    </dgm:fillClrLst>
+    <dgm:linClrLst meth="repeat">
+      <a:schemeClr val="accent1">
+        <a:shade val="60000"/>
+      </a:schemeClr>
+    </dgm:linClrLst>
+    <dgm:effectClrLst/>
+    <dgm:txLinClrLst/>
+    <dgm:txFillClrLst meth="repeat">
+      <a:schemeClr val="tx1"/>
+    </dgm:txFillClrLst>
+    <dgm:txEffectClrLst/>
+  </dgm:styleLbl>
+  <dgm:styleLbl name="parChTrans1D2">
+    <dgm:fillClrLst meth="repeat">
+      <a:schemeClr val="accent1"/>
+    </dgm:fillClrLst>
+    <dgm:linClrLst meth="repeat">
+      <a:schemeClr val="accent1">
+        <a:shade val="60000"/>
+      </a:schemeClr>
+    </dgm:linClrLst>
+    <dgm:effectClrLst/>
+    <dgm:txLinClrLst/>
+    <dgm:txFillClrLst meth="repeat">
+      <a:schemeClr val="tx1"/>
+    </dgm:txFillClrLst>
+    <dgm:txEffectClrLst/>
+  </dgm:styleLbl>
+  <dgm:styleLbl name="parChTrans1D3">
+    <dgm:fillClrLst meth="repeat">
+      <a:schemeClr val="accent1"/>
+    </dgm:fillClrLst>
+    <dgm:linClrLst meth="repeat">
+      <a:schemeClr val="accent1">
+        <a:shade val="80000"/>
+      </a:schemeClr>
+    </dgm:linClrLst>
+    <dgm:effectClrLst/>
+    <dgm:txLinClrLst/>
+    <dgm:txFillClrLst meth="repeat">
+      <a:schemeClr val="tx1"/>
+    </dgm:txFillClrLst>
+    <dgm:txEffectClrLst/>
+  </dgm:styleLbl>
+  <dgm:styleLbl name="parChTrans1D4">
+    <dgm:fillClrLst meth="repeat">
+      <a:schemeClr val="accent1"/>
+    </dgm:fillClrLst>
+    <dgm:linClrLst meth="repeat">
+      <a:schemeClr val="accent1">
+        <a:shade val="80000"/>
+      </a:schemeClr>
+    </dgm:linClrLst>
+    <dgm:effectClrLst/>
+    <dgm:txLinClrLst/>
+    <dgm:txFillClrLst meth="repeat">
+      <a:schemeClr val="tx1"/>
+    </dgm:txFillClrLst>
+    <dgm:txEffectClrLst/>
+  </dgm:styleLbl>
+  <dgm:styleLbl name="fgAcc1">
+    <dgm:fillClrLst meth="repeat">
+      <a:schemeClr val="lt1">
+        <a:alpha val="90000"/>
+      </a:schemeClr>
+    </dgm:fillClrLst>
+    <dgm:linClrLst meth="repeat">
+      <a:schemeClr val="accent1"/>
+    </dgm:linClrLst>
+    <dgm:effectClrLst/>
+    <dgm:txLinClrLst/>
+    <dgm:txFillClrLst meth="repeat">
+      <a:schemeClr val="dk1"/>
+    </dgm:txFillClrLst>
+    <dgm:txEffectClrLst/>
+  </dgm:styleLbl>
+  <dgm:styleLbl name="conFgAcc1">
+    <dgm:fillClrLst meth="repeat">
+      <a:schemeClr val="lt1">
+        <a:alpha val="90000"/>
+      </a:schemeClr>
+    </dgm:fillClrLst>
+    <dgm:linClrLst meth="repeat">
+      <a:schemeClr val="accent1"/>
+    </dgm:linClrLst>
+    <dgm:effectClrLst/>
+    <dgm:txLinClrLst/>
+    <dgm:txFillClrLst meth="repeat">
+      <a:schemeClr val="dk1"/>
+    </dgm:txFillClrLst>
+    <dgm:txEffectClrLst/>
+  </dgm:styleLbl>
+  <dgm:styleLbl name="alignAcc1">
+    <dgm:fillClrLst meth="repeat">
+      <a:schemeClr val="lt1">
+        <a:alpha val="90000"/>
+      </a:schemeClr>
+    </dgm:fillClrLst>
+    <dgm:linClrLst meth="repeat">
+      <a:schemeClr val="accent1"/>
+    </dgm:linClrLst>
+    <dgm:effectClrLst/>
+    <dgm:txLinClrLst/>
+    <dgm:txFillClrLst meth="repeat">
+      <a:schemeClr val="dk1"/>
+    </dgm:txFillClrLst>
+    <dgm:txEffectClrLst/>
+  </dgm:styleLbl>
+  <dgm:styleLbl name="trAlignAcc1">
+    <dgm:fillClrLst meth="repeat">
+      <a:schemeClr val="lt1">
+        <a:alpha val="40000"/>
+      </a:schemeClr>
+    </dgm:fillClrLst>
+    <dgm:linClrLst meth="repeat">
+      <a:schemeClr val="accent1"/>
+    </dgm:linClrLst>
+    <dgm:effectClrLst/>
+    <dgm:txLinClrLst/>
+    <dgm:txFillClrLst meth="repeat">
+      <a:schemeClr val="dk1"/>
+    </dgm:txFillClrLst>
+    <dgm:txEffectClrLst/>
+  </dgm:styleLbl>
+  <dgm:styleLbl name="bgAcc1">
+    <dgm:fillClrLst meth="repeat">
+      <a:schemeClr val="lt1">
+        <a:alpha val="90000"/>
+      </a:schemeClr>
+    </dgm:fillClrLst>
+    <dgm:linClrLst meth="repeat">
+      <a:schemeClr val="accent1"/>
+    </dgm:linClrLst>
+    <dgm:effectClrLst/>
+    <dgm:txLinClrLst/>
+    <dgm:txFillClrLst meth="repeat">
+      <a:schemeClr val="dk1"/>
+    </dgm:txFillClrLst>
+    <dgm:txEffectClrLst/>
+  </dgm:styleLbl>
+  <dgm:styleLbl name="solidFgAcc1">
+    <dgm:fillClrLst meth="repeat">
+      <a:schemeClr val="lt1"/>
+    </dgm:fillClrLst>
+    <dgm:linClrLst meth="repeat">
+      <a:schemeClr val="accent1"/>
+    </dgm:linClrLst>
+    <dgm:effectClrLst/>
+    <dgm:txLinClrLst/>
+    <dgm:txFillClrLst meth="repeat">
+      <a:schemeClr val="dk1"/>
+    </dgm:txFillClrLst>
+    <dgm:txEffectClrLst/>
+  </dgm:styleLbl>
+  <dgm:styleLbl name="solidAlignAcc1">
+    <dgm:fillClrLst meth="repeat">
+      <a:schemeClr val="lt1"/>
+    </dgm:fillClrLst>
+    <dgm:linClrLst meth="repeat">
+      <a:schemeClr val="accent1"/>
+    </dgm:linClrLst>
+    <dgm:effectClrLst/>
+    <dgm:txLinClrLst/>
+    <dgm:txFillClrLst meth="repeat">
+      <a:schemeClr val="dk1"/>
+    </dgm:txFillClrLst>
+    <dgm:txEffectClrLst/>
+  </dgm:styleLbl>
+  <dgm:styleLbl name="solidBgAcc1">
+    <dgm:fillClrLst meth="repeat">
+      <a:schemeClr val="lt1"/>
+    </dgm:fillClrLst>
+    <dgm:linClrLst meth="repeat">
+      <a:schemeClr val="accent1"/>
+    </dgm:linClrLst>
+    <dgm:effectClrLst/>
+    <dgm:txLinClrLst/>
+    <dgm:txFillClrLst meth="repeat">
+      <a:schemeClr val="dk1"/>
+    </dgm:txFillClrLst>
+    <dgm:txEffectClrLst/>
+  </dgm:styleLbl>
+  <dgm:styleLbl name="fgAccFollowNode1">
+    <dgm:fillClrLst meth="repeat">
+      <a:schemeClr val="accent1">
+        <a:alpha val="90000"/>
+        <a:tint val="40000"/>
+      </a:schemeClr>
+    </dgm:fillClrLst>
+    <dgm:linClrLst meth="repeat">
+      <a:schemeClr val="accent1">
+        <a:alpha val="90000"/>
+        <a:tint val="40000"/>
+      </a:schemeClr>
+    </dgm:linClrLst>
+    <dgm:effectClrLst/>
+    <dgm:txLinClrLst/>
+    <dgm:txFillClrLst meth="repeat">
+      <a:schemeClr val="dk1"/>
+    </dgm:txFillClrLst>
+    <dgm:txEffectClrLst/>
+  </dgm:styleLbl>
+  <dgm:styleLbl name="alignAccFollowNode1">
+    <dgm:fillClrLst meth="repeat">
+      <a:schemeClr val="accent1">
+        <a:alpha val="90000"/>
+        <a:tint val="40000"/>
+      </a:schemeClr>
+    </dgm:fillClrLst>
+    <dgm:linClrLst meth="repeat">
+      <a:schemeClr val="accent1">
+        <a:alpha val="90000"/>
+        <a:tint val="40000"/>
+      </a:schemeClr>
+    </dgm:linClrLst>
+    <dgm:effectClrLst/>
+    <dgm:txLinClrLst/>
+    <dgm:txFillClrLst meth="repeat">
+      <a:schemeClr val="dk1"/>
+    </dgm:txFillClrLst>
+    <dgm:txEffectClrLst/>
+  </dgm:styleLbl>
+  <dgm:styleLbl name="bgAccFollowNode1">
+    <dgm:fillClrLst meth="repeat">
+      <a:schemeClr val="accent1">
+        <a:alpha val="90000"/>
+        <a:tint val="40000"/>
+      </a:schemeClr>
+    </dgm:fillClrLst>
+    <dgm:linClrLst meth="repeat">
+      <a:schemeClr val="accent1">
+        <a:alpha val="90000"/>
+        <a:tint val="40000"/>
+      </a:schemeClr>
+    </dgm:linClrLst>
+    <dgm:effectClrLst/>
+    <dgm:txLinClrLst/>
+    <dgm:txFillClrLst meth="repeat">
+      <a:schemeClr val="dk1"/>
+    </dgm:txFillClrLst>
+    <dgm:txEffectClrLst/>
+  </dgm:styleLbl>
+  <dgm:styleLbl name="fgAcc0">
+    <dgm:fillClrLst meth="repeat">
+      <a:schemeClr val="lt1">
+        <a:alpha val="90000"/>
+      </a:schemeClr>
+    </dgm:fillClrLst>
+    <dgm:linClrLst meth="repeat">
+      <a:schemeClr val="accent1"/>
+    </dgm:linClrLst>
+    <dgm:effectClrLst/>
+    <dgm:txLinClrLst/>
+    <dgm:txFillClrLst meth="repeat">
+      <a:schemeClr val="dk1"/>
+    </dgm:txFillClrLst>
+    <dgm:txEffectClrLst/>
+  </dgm:styleLbl>
+  <dgm:styleLbl name="fgAcc2">
+    <dgm:fillClrLst meth="repeat">
+      <a:schemeClr val="lt1">
+        <a:alpha val="90000"/>
+      </a:schemeClr>
+    </dgm:fillClrLst>
+    <dgm:linClrLst meth="repeat">
+      <a:schemeClr val="accent1"/>
+    </dgm:linClrLst>
+    <dgm:effectClrLst/>
+    <dgm:txLinClrLst/>
+    <dgm:txFillClrLst meth="repeat">
+      <a:schemeClr val="dk1"/>
+    </dgm:txFillClrLst>
+    <dgm:txEffectClrLst/>
+  </dgm:styleLbl>
+  <dgm:styleLbl name="fgAcc3">
+    <dgm:fillClrLst meth="repeat">
+      <a:schemeClr val="lt1">
+        <a:alpha val="90000"/>
+      </a:schemeClr>
+    </dgm:fillClrLst>
+    <dgm:linClrLst meth="repeat">
+      <a:schemeClr val="accent1"/>
+    </dgm:linClrLst>
+    <dgm:effectClrLst/>
+    <dgm:txLinClrLst/>
+    <dgm:txFillClrLst meth="repeat">
+      <a:schemeClr val="dk1"/>
+    </dgm:txFillClrLst>
+    <dgm:txEffectClrLst/>
+  </dgm:styleLbl>
+  <dgm:styleLbl name="fgAcc4">
+    <dgm:fillClrLst meth="repeat">
+      <a:schemeClr val="lt1">
+        <a:alpha val="90000"/>
+      </a:schemeClr>
+    </dgm:fillClrLst>
+    <dgm:linClrLst meth="repeat">
+      <a:schemeClr val="accent1"/>
+    </dgm:linClrLst>
+    <dgm:effectClrLst/>
+    <dgm:txLinClrLst/>
+    <dgm:txFillClrLst meth="repeat">
+      <a:schemeClr val="dk1"/>
+    </dgm:txFillClrLst>
+    <dgm:txEffectClrLst/>
+  </dgm:styleLbl>
+  <dgm:styleLbl name="bgShp">
+    <dgm:fillClrLst meth="repeat">
+      <a:schemeClr val="accent1">
+        <a:tint val="40000"/>
+      </a:schemeClr>
+    </dgm:fillClrLst>
+    <dgm:linClrLst meth="repeat">
+      <a:schemeClr val="accent1"/>
+    </dgm:linClrLst>
+    <dgm:effectClrLst/>
+    <dgm:txLinClrLst/>
+    <dgm:txFillClrLst meth="repeat">
+      <a:schemeClr val="dk1"/>
+    </dgm:txFillClrLst>
+    <dgm:txEffectClrLst/>
+  </dgm:styleLbl>
+  <dgm:styleLbl name="dkBgShp">
+    <dgm:fillClrLst meth="repeat">
+      <a:schemeClr val="accent1">
+        <a:shade val="80000"/>
+      </a:schemeClr>
+    </dgm:fillClrLst>
+    <dgm:linClrLst meth="repeat">
+      <a:schemeClr val="accent1"/>
+    </dgm:linClrLst>
+    <dgm:effectClrLst/>
+    <dgm:txLinClrLst/>
+    <dgm:txFillClrLst meth="repeat">
+      <a:schemeClr val="lt1"/>
+    </dgm:txFillClrLst>
+    <dgm:txEffectClrLst/>
+  </dgm:styleLbl>
+  <dgm:styleLbl name="trBgShp">
+    <dgm:fillClrLst meth="repeat">
+      <a:schemeClr val="accent1">
+        <a:tint val="50000"/>
+        <a:alpha val="40000"/>
+      </a:schemeClr>
+    </dgm:fillClrLst>
+    <dgm:linClrLst meth="repeat">
+      <a:schemeClr val="accent1"/>
+    </dgm:linClrLst>
+    <dgm:effectClrLst/>
+    <dgm:txLinClrLst/>
+    <dgm:txFillClrLst meth="repeat">
+      <a:schemeClr val="lt1"/>
+    </dgm:txFillClrLst>
+    <dgm:txEffectClrLst/>
+  </dgm:styleLbl>
+  <dgm:styleLbl name="fgShp">
+    <dgm:fillClrLst meth="repeat">
+      <a:schemeClr val="accent1">
+        <a:tint val="60000"/>
+      </a:schemeClr>
+    </dgm:fillClrLst>
+    <dgm:linClrLst meth="repeat">
+      <a:schemeClr val="lt1"/>
+    </dgm:linClrLst>
+    <dgm:effectClrLst/>
+    <dgm:txLinClrLst/>
+    <dgm:txFillClrLst meth="repeat">
+      <a:schemeClr val="dk1"/>
+    </dgm:txFillClrLst>
+    <dgm:txEffectClrLst/>
+  </dgm:styleLbl>
+  <dgm:styleLbl name="revTx">
+    <dgm:fillClrLst meth="repeat">
+      <a:schemeClr val="lt1">
+        <a:alpha val="0"/>
+      </a:schemeClr>
+    </dgm:fillClrLst>
+    <dgm:linClrLst meth="repeat">
+      <a:schemeClr val="dk1">
+        <a:alpha val="0"/>
+      </a:schemeClr>
+    </dgm:linClrLst>
+    <dgm:effectClrLst/>
+    <dgm:txLinClrLst/>
+    <dgm:txFillClrLst meth="repeat">
+      <a:schemeClr val="tx1"/>
+    </dgm:txFillClrLst>
+    <dgm:txEffectClrLst/>
+  </dgm:styleLbl>
+</dgm:colorsDef>
+</file>
+
+<file path=ppt/diagrams/data1.xml><?xml version="1.0" encoding="utf-8"?>
+<dgm:dataModel xmlns:dgm="http://schemas.openxmlformats.org/drawingml/2006/diagram" xmlns:a="http://schemas.openxmlformats.org/drawingml/2006/main">
+  <dgm:ptLst>
+    <dgm:pt modelId="{BBF0B7FB-DA3D-4DCD-92CE-5515BC2A0FEC}" type="doc">
+      <dgm:prSet loTypeId="urn:microsoft.com/office/officeart/2005/8/layout/process1" loCatId="process" qsTypeId="urn:microsoft.com/office/officeart/2005/8/quickstyle/simple1" qsCatId="simple" csTypeId="urn:microsoft.com/office/officeart/2005/8/colors/accent1_2" csCatId="accent1" phldr="1"/>
+      <dgm:spPr/>
+    </dgm:pt>
+    <dgm:pt modelId="{E5C905EA-FF2D-46BF-8669-05EE1915E020}">
+      <dgm:prSet phldrT="[Texto]"/>
+      <dgm:spPr/>
+      <dgm:t>
+        <a:bodyPr/>
+        <a:lstStyle/>
+        <a:p>
+          <a:r>
+            <a:rPr lang="es-MX" dirty="0"/>
+            <a:t>Selección del modelo .h5</a:t>
+          </a:r>
+          <a:endParaRPr lang="es-CL" dirty="0"/>
+        </a:p>
+      </dgm:t>
+    </dgm:pt>
+    <dgm:pt modelId="{4128E8CC-78AA-45B7-8BA1-82A2B49FD298}" type="parTrans" cxnId="{E19266C1-4804-4D75-AAB6-80135145A043}">
+      <dgm:prSet/>
+      <dgm:spPr/>
+      <dgm:t>
+        <a:bodyPr/>
+        <a:lstStyle/>
+        <a:p>
+          <a:endParaRPr lang="es-CL"/>
+        </a:p>
+      </dgm:t>
+    </dgm:pt>
+    <dgm:pt modelId="{0C28BC9E-73B5-4DC3-80F7-409B261A2B02}" type="sibTrans" cxnId="{E19266C1-4804-4D75-AAB6-80135145A043}">
+      <dgm:prSet/>
+      <dgm:spPr/>
+      <dgm:t>
+        <a:bodyPr/>
+        <a:lstStyle/>
+        <a:p>
+          <a:endParaRPr lang="es-CL"/>
+        </a:p>
+      </dgm:t>
+    </dgm:pt>
+    <dgm:pt modelId="{576E78F5-2C1A-489F-B331-AA06D337DBDA}">
+      <dgm:prSet phldrT="[Texto]"/>
+      <dgm:spPr/>
+      <dgm:t>
+        <a:bodyPr/>
+        <a:lstStyle/>
+        <a:p>
+          <a:r>
+            <a:rPr lang="es-MX" dirty="0"/>
+            <a:t>Definición de un </a:t>
+          </a:r>
+          <a:r>
+            <a:rPr lang="es-MX" dirty="0" err="1"/>
+            <a:t>dataset</a:t>
+          </a:r>
+          <a:r>
+            <a:rPr lang="es-MX" dirty="0"/>
+            <a:t> representativo</a:t>
+          </a:r>
+          <a:endParaRPr lang="es-CL" dirty="0"/>
+        </a:p>
+      </dgm:t>
+    </dgm:pt>
+    <dgm:pt modelId="{D8C6085D-61D3-4D5C-BA95-E1FCF6DB3669}" type="parTrans" cxnId="{C429F160-EB84-4A5E-8A36-EA120ADF90A9}">
+      <dgm:prSet/>
+      <dgm:spPr/>
+      <dgm:t>
+        <a:bodyPr/>
+        <a:lstStyle/>
+        <a:p>
+          <a:endParaRPr lang="es-CL"/>
+        </a:p>
+      </dgm:t>
+    </dgm:pt>
+    <dgm:pt modelId="{E4808B09-8AAC-4FAA-9DF2-D4C5C1BFC6AC}" type="sibTrans" cxnId="{C429F160-EB84-4A5E-8A36-EA120ADF90A9}">
+      <dgm:prSet/>
+      <dgm:spPr/>
+      <dgm:t>
+        <a:bodyPr/>
+        <a:lstStyle/>
+        <a:p>
+          <a:endParaRPr lang="es-CL"/>
+        </a:p>
+      </dgm:t>
+    </dgm:pt>
+    <dgm:pt modelId="{B6ACF22C-3E34-43DC-9AD4-08CE792B69FF}">
+      <dgm:prSet phldrT="[Texto]"/>
+      <dgm:spPr/>
+      <dgm:t>
+        <a:bodyPr/>
+        <a:lstStyle/>
+        <a:p>
+          <a:r>
+            <a:rPr lang="es-MX" dirty="0"/>
+            <a:t>Conversión de pesos, entradas y salidas</a:t>
+          </a:r>
+          <a:endParaRPr lang="es-CL" dirty="0"/>
+        </a:p>
+      </dgm:t>
+    </dgm:pt>
+    <dgm:pt modelId="{D7B0D111-37E2-4F5D-9387-63304CEB7E31}" type="parTrans" cxnId="{85FC786F-54B5-4F2C-8C7B-73B1DDE4A8DD}">
+      <dgm:prSet/>
+      <dgm:spPr/>
+      <dgm:t>
+        <a:bodyPr/>
+        <a:lstStyle/>
+        <a:p>
+          <a:endParaRPr lang="es-CL"/>
+        </a:p>
+      </dgm:t>
+    </dgm:pt>
+    <dgm:pt modelId="{EFDBE9CF-F2CF-4E16-ADD5-D68B0522DFBC}" type="sibTrans" cxnId="{85FC786F-54B5-4F2C-8C7B-73B1DDE4A8DD}">
+      <dgm:prSet/>
+      <dgm:spPr/>
+      <dgm:t>
+        <a:bodyPr/>
+        <a:lstStyle/>
+        <a:p>
+          <a:endParaRPr lang="es-CL"/>
+        </a:p>
+      </dgm:t>
+    </dgm:pt>
+    <dgm:pt modelId="{2020DAA4-4895-4DA0-99CE-C0E1396164E7}" type="pres">
+      <dgm:prSet presAssocID="{BBF0B7FB-DA3D-4DCD-92CE-5515BC2A0FEC}" presName="Name0" presStyleCnt="0">
+        <dgm:presLayoutVars>
+          <dgm:dir/>
+          <dgm:resizeHandles val="exact"/>
+        </dgm:presLayoutVars>
+      </dgm:prSet>
+      <dgm:spPr/>
+    </dgm:pt>
+    <dgm:pt modelId="{18055A54-E558-4FD9-B50F-54AFFF322322}" type="pres">
+      <dgm:prSet presAssocID="{E5C905EA-FF2D-46BF-8669-05EE1915E020}" presName="node" presStyleLbl="node1" presStyleIdx="0" presStyleCnt="3">
+        <dgm:presLayoutVars>
+          <dgm:bulletEnabled val="1"/>
+        </dgm:presLayoutVars>
+      </dgm:prSet>
+      <dgm:spPr/>
+    </dgm:pt>
+    <dgm:pt modelId="{EBE4062C-D33A-4911-BBF4-F1C1BC398585}" type="pres">
+      <dgm:prSet presAssocID="{0C28BC9E-73B5-4DC3-80F7-409B261A2B02}" presName="sibTrans" presStyleLbl="sibTrans2D1" presStyleIdx="0" presStyleCnt="2"/>
+      <dgm:spPr/>
+    </dgm:pt>
+    <dgm:pt modelId="{60FF4CD8-81DC-4905-ABD4-D43A800B49D3}" type="pres">
+      <dgm:prSet presAssocID="{0C28BC9E-73B5-4DC3-80F7-409B261A2B02}" presName="connectorText" presStyleLbl="sibTrans2D1" presStyleIdx="0" presStyleCnt="2"/>
+      <dgm:spPr/>
+    </dgm:pt>
+    <dgm:pt modelId="{DB5B3C18-27D4-4F99-BA0C-4A17568A05B0}" type="pres">
+      <dgm:prSet presAssocID="{576E78F5-2C1A-489F-B331-AA06D337DBDA}" presName="node" presStyleLbl="node1" presStyleIdx="1" presStyleCnt="3">
+        <dgm:presLayoutVars>
+          <dgm:bulletEnabled val="1"/>
+        </dgm:presLayoutVars>
+      </dgm:prSet>
+      <dgm:spPr/>
+    </dgm:pt>
+    <dgm:pt modelId="{9A339B42-B521-4EEB-8BE5-073F65B5B026}" type="pres">
+      <dgm:prSet presAssocID="{E4808B09-8AAC-4FAA-9DF2-D4C5C1BFC6AC}" presName="sibTrans" presStyleLbl="sibTrans2D1" presStyleIdx="1" presStyleCnt="2"/>
+      <dgm:spPr/>
+    </dgm:pt>
+    <dgm:pt modelId="{7DECE3A3-D355-498B-8685-0537F63CC0BB}" type="pres">
+      <dgm:prSet presAssocID="{E4808B09-8AAC-4FAA-9DF2-D4C5C1BFC6AC}" presName="connectorText" presStyleLbl="sibTrans2D1" presStyleIdx="1" presStyleCnt="2"/>
+      <dgm:spPr/>
+    </dgm:pt>
+    <dgm:pt modelId="{CA53FA59-2C7E-421B-B440-40591DCCD046}" type="pres">
+      <dgm:prSet presAssocID="{B6ACF22C-3E34-43DC-9AD4-08CE792B69FF}" presName="node" presStyleLbl="node1" presStyleIdx="2" presStyleCnt="3">
+        <dgm:presLayoutVars>
+          <dgm:bulletEnabled val="1"/>
+        </dgm:presLayoutVars>
+      </dgm:prSet>
+      <dgm:spPr/>
+    </dgm:pt>
+  </dgm:ptLst>
+  <dgm:cxnLst>
+    <dgm:cxn modelId="{C429F160-EB84-4A5E-8A36-EA120ADF90A9}" srcId="{BBF0B7FB-DA3D-4DCD-92CE-5515BC2A0FEC}" destId="{576E78F5-2C1A-489F-B331-AA06D337DBDA}" srcOrd="1" destOrd="0" parTransId="{D8C6085D-61D3-4D5C-BA95-E1FCF6DB3669}" sibTransId="{E4808B09-8AAC-4FAA-9DF2-D4C5C1BFC6AC}"/>
+    <dgm:cxn modelId="{7A2F1F64-AE8F-4C79-8EBC-6A441C67FF37}" type="presOf" srcId="{B6ACF22C-3E34-43DC-9AD4-08CE792B69FF}" destId="{CA53FA59-2C7E-421B-B440-40591DCCD046}" srcOrd="0" destOrd="0" presId="urn:microsoft.com/office/officeart/2005/8/layout/process1"/>
+    <dgm:cxn modelId="{FCE2A644-0AB9-4B68-87B3-7A3D6256E365}" type="presOf" srcId="{E5C905EA-FF2D-46BF-8669-05EE1915E020}" destId="{18055A54-E558-4FD9-B50F-54AFFF322322}" srcOrd="0" destOrd="0" presId="urn:microsoft.com/office/officeart/2005/8/layout/process1"/>
+    <dgm:cxn modelId="{ADF78C65-C934-47E5-8007-C3E6602B89AD}" type="presOf" srcId="{0C28BC9E-73B5-4DC3-80F7-409B261A2B02}" destId="{60FF4CD8-81DC-4905-ABD4-D43A800B49D3}" srcOrd="1" destOrd="0" presId="urn:microsoft.com/office/officeart/2005/8/layout/process1"/>
+    <dgm:cxn modelId="{D050D46B-4982-4E4C-982F-BF1B258ED7DE}" type="presOf" srcId="{576E78F5-2C1A-489F-B331-AA06D337DBDA}" destId="{DB5B3C18-27D4-4F99-BA0C-4A17568A05B0}" srcOrd="0" destOrd="0" presId="urn:microsoft.com/office/officeart/2005/8/layout/process1"/>
+    <dgm:cxn modelId="{14C2FF6D-2E8D-49C8-B6E7-FDEA7CBA72B4}" type="presOf" srcId="{E4808B09-8AAC-4FAA-9DF2-D4C5C1BFC6AC}" destId="{9A339B42-B521-4EEB-8BE5-073F65B5B026}" srcOrd="0" destOrd="0" presId="urn:microsoft.com/office/officeart/2005/8/layout/process1"/>
+    <dgm:cxn modelId="{85FC786F-54B5-4F2C-8C7B-73B1DDE4A8DD}" srcId="{BBF0B7FB-DA3D-4DCD-92CE-5515BC2A0FEC}" destId="{B6ACF22C-3E34-43DC-9AD4-08CE792B69FF}" srcOrd="2" destOrd="0" parTransId="{D7B0D111-37E2-4F5D-9387-63304CEB7E31}" sibTransId="{EFDBE9CF-F2CF-4E16-ADD5-D68B0522DFBC}"/>
+    <dgm:cxn modelId="{034ABEAF-0118-4CF6-84AA-06921497926F}" type="presOf" srcId="{0C28BC9E-73B5-4DC3-80F7-409B261A2B02}" destId="{EBE4062C-D33A-4911-BBF4-F1C1BC398585}" srcOrd="0" destOrd="0" presId="urn:microsoft.com/office/officeart/2005/8/layout/process1"/>
+    <dgm:cxn modelId="{61657FBB-0A61-4E5B-A17F-8F77F3796A21}" type="presOf" srcId="{E4808B09-8AAC-4FAA-9DF2-D4C5C1BFC6AC}" destId="{7DECE3A3-D355-498B-8685-0537F63CC0BB}" srcOrd="1" destOrd="0" presId="urn:microsoft.com/office/officeart/2005/8/layout/process1"/>
+    <dgm:cxn modelId="{E19266C1-4804-4D75-AAB6-80135145A043}" srcId="{BBF0B7FB-DA3D-4DCD-92CE-5515BC2A0FEC}" destId="{E5C905EA-FF2D-46BF-8669-05EE1915E020}" srcOrd="0" destOrd="0" parTransId="{4128E8CC-78AA-45B7-8BA1-82A2B49FD298}" sibTransId="{0C28BC9E-73B5-4DC3-80F7-409B261A2B02}"/>
+    <dgm:cxn modelId="{BA7F15F3-E189-4B5A-8180-B59521C7CCC1}" type="presOf" srcId="{BBF0B7FB-DA3D-4DCD-92CE-5515BC2A0FEC}" destId="{2020DAA4-4895-4DA0-99CE-C0E1396164E7}" srcOrd="0" destOrd="0" presId="urn:microsoft.com/office/officeart/2005/8/layout/process1"/>
+    <dgm:cxn modelId="{338370B7-3238-4AE8-9041-D2D3CE5F91B9}" type="presParOf" srcId="{2020DAA4-4895-4DA0-99CE-C0E1396164E7}" destId="{18055A54-E558-4FD9-B50F-54AFFF322322}" srcOrd="0" destOrd="0" presId="urn:microsoft.com/office/officeart/2005/8/layout/process1"/>
+    <dgm:cxn modelId="{EE406F12-7009-4DD6-9066-39A93489C952}" type="presParOf" srcId="{2020DAA4-4895-4DA0-99CE-C0E1396164E7}" destId="{EBE4062C-D33A-4911-BBF4-F1C1BC398585}" srcOrd="1" destOrd="0" presId="urn:microsoft.com/office/officeart/2005/8/layout/process1"/>
+    <dgm:cxn modelId="{87EA0840-EAF0-485A-8838-99B96B25F99F}" type="presParOf" srcId="{EBE4062C-D33A-4911-BBF4-F1C1BC398585}" destId="{60FF4CD8-81DC-4905-ABD4-D43A800B49D3}" srcOrd="0" destOrd="0" presId="urn:microsoft.com/office/officeart/2005/8/layout/process1"/>
+    <dgm:cxn modelId="{C8294E1D-0F90-45CA-9752-49E4656A041D}" type="presParOf" srcId="{2020DAA4-4895-4DA0-99CE-C0E1396164E7}" destId="{DB5B3C18-27D4-4F99-BA0C-4A17568A05B0}" srcOrd="2" destOrd="0" presId="urn:microsoft.com/office/officeart/2005/8/layout/process1"/>
+    <dgm:cxn modelId="{B06591FC-A74A-4A0B-9630-446D5DF222C4}" type="presParOf" srcId="{2020DAA4-4895-4DA0-99CE-C0E1396164E7}" destId="{9A339B42-B521-4EEB-8BE5-073F65B5B026}" srcOrd="3" destOrd="0" presId="urn:microsoft.com/office/officeart/2005/8/layout/process1"/>
+    <dgm:cxn modelId="{20182BF0-EB1E-4F00-BCBE-3E79717A3C78}" type="presParOf" srcId="{9A339B42-B521-4EEB-8BE5-073F65B5B026}" destId="{7DECE3A3-D355-498B-8685-0537F63CC0BB}" srcOrd="0" destOrd="0" presId="urn:microsoft.com/office/officeart/2005/8/layout/process1"/>
+    <dgm:cxn modelId="{8CD0CA1E-2CB9-4555-BC96-7DC246DA0B67}" type="presParOf" srcId="{2020DAA4-4895-4DA0-99CE-C0E1396164E7}" destId="{CA53FA59-2C7E-421B-B440-40591DCCD046}" srcOrd="4" destOrd="0" presId="urn:microsoft.com/office/officeart/2005/8/layout/process1"/>
+  </dgm:cxnLst>
+  <dgm:bg/>
+  <dgm:whole/>
+  <dgm:extLst>
+    <a:ext uri="http://schemas.microsoft.com/office/drawing/2008/diagram">
+      <dsp:dataModelExt xmlns:dsp="http://schemas.microsoft.com/office/drawing/2008/diagram" relId="rId6" minVer="http://schemas.openxmlformats.org/drawingml/2006/diagram"/>
+    </a:ext>
+  </dgm:extLst>
+</dgm:dataModel>
+</file>
+
+<file path=ppt/diagrams/drawing1.xml><?xml version="1.0" encoding="utf-8"?>
+<dsp:drawing xmlns:dgm="http://schemas.openxmlformats.org/drawingml/2006/diagram" xmlns:dsp="http://schemas.microsoft.com/office/drawing/2008/diagram" xmlns:a="http://schemas.openxmlformats.org/drawingml/2006/main">
+  <dsp:spTree>
+    <dsp:nvGrpSpPr>
+      <dsp:cNvPr id="0" name=""/>
+      <dsp:cNvGrpSpPr/>
+    </dsp:nvGrpSpPr>
+    <dsp:grpSpPr/>
+    <dsp:sp modelId="{18055A54-E558-4FD9-B50F-54AFFF322322}">
+      <dsp:nvSpPr>
+        <dsp:cNvPr id="0" name=""/>
+        <dsp:cNvSpPr/>
+      </dsp:nvSpPr>
+      <dsp:spPr>
+        <a:xfrm>
+          <a:off x="9242" y="1346949"/>
+          <a:ext cx="2762398" cy="1657439"/>
+        </a:xfrm>
+        <a:prstGeom prst="roundRect">
+          <a:avLst>
+            <a:gd name="adj" fmla="val 10000"/>
+          </a:avLst>
+        </a:prstGeom>
+        <a:solidFill>
+          <a:schemeClr val="accent1">
+            <a:hueOff val="0"/>
+            <a:satOff val="0"/>
+            <a:lumOff val="0"/>
+            <a:alphaOff val="0"/>
+          </a:schemeClr>
+        </a:solidFill>
+        <a:ln w="12700" cap="flat" cmpd="sng" algn="ctr">
+          <a:solidFill>
+            <a:schemeClr val="lt1">
+              <a:hueOff val="0"/>
+              <a:satOff val="0"/>
+              <a:lumOff val="0"/>
+              <a:alphaOff val="0"/>
+            </a:schemeClr>
+          </a:solidFill>
+          <a:prstDash val="solid"/>
+          <a:miter lim="800000"/>
+        </a:ln>
+        <a:effectLst/>
+      </dsp:spPr>
+      <dsp:style>
+        <a:lnRef idx="2">
+          <a:scrgbClr r="0" g="0" b="0"/>
+        </a:lnRef>
+        <a:fillRef idx="1">
+          <a:scrgbClr r="0" g="0" b="0"/>
+        </a:fillRef>
+        <a:effectRef idx="0">
+          <a:scrgbClr r="0" g="0" b="0"/>
+        </a:effectRef>
+        <a:fontRef idx="minor">
+          <a:schemeClr val="lt1"/>
+        </a:fontRef>
+      </dsp:style>
+      <dsp:txBody>
+        <a:bodyPr spcFirstLastPara="0" vert="horz" wrap="square" lIns="114300" tIns="114300" rIns="114300" bIns="114300" numCol="1" spcCol="1270" anchor="ctr" anchorCtr="0">
+          <a:noAutofit/>
+        </a:bodyPr>
+        <a:lstStyle/>
+        <a:p>
+          <a:pPr marL="0" lvl="0" indent="0" algn="ctr" defTabSz="1333500">
+            <a:lnSpc>
+              <a:spcPct val="90000"/>
+            </a:lnSpc>
+            <a:spcBef>
+              <a:spcPct val="0"/>
+            </a:spcBef>
+            <a:spcAft>
+              <a:spcPct val="35000"/>
+            </a:spcAft>
+            <a:buNone/>
+          </a:pPr>
+          <a:r>
+            <a:rPr lang="es-MX" sz="3000" kern="1200" dirty="0"/>
+            <a:t>Selección del modelo .h5</a:t>
+          </a:r>
+          <a:endParaRPr lang="es-CL" sz="3000" kern="1200" dirty="0"/>
+        </a:p>
+      </dsp:txBody>
+      <dsp:txXfrm>
+        <a:off x="57787" y="1395494"/>
+        <a:ext cx="2665308" cy="1560349"/>
+      </dsp:txXfrm>
+    </dsp:sp>
+    <dsp:sp modelId="{EBE4062C-D33A-4911-BBF4-F1C1BC398585}">
+      <dsp:nvSpPr>
+        <dsp:cNvPr id="0" name=""/>
+        <dsp:cNvSpPr/>
+      </dsp:nvSpPr>
+      <dsp:spPr>
+        <a:xfrm>
+          <a:off x="3047880" y="1833131"/>
+          <a:ext cx="585628" cy="685074"/>
+        </a:xfrm>
+        <a:prstGeom prst="rightArrow">
+          <a:avLst>
+            <a:gd name="adj1" fmla="val 60000"/>
+            <a:gd name="adj2" fmla="val 50000"/>
+          </a:avLst>
+        </a:prstGeom>
+        <a:solidFill>
+          <a:schemeClr val="accent1">
+            <a:tint val="60000"/>
+            <a:hueOff val="0"/>
+            <a:satOff val="0"/>
+            <a:lumOff val="0"/>
+            <a:alphaOff val="0"/>
+          </a:schemeClr>
+        </a:solidFill>
+        <a:ln>
+          <a:noFill/>
+        </a:ln>
+        <a:effectLst/>
+      </dsp:spPr>
+      <dsp:style>
+        <a:lnRef idx="0">
+          <a:scrgbClr r="0" g="0" b="0"/>
+        </a:lnRef>
+        <a:fillRef idx="1">
+          <a:scrgbClr r="0" g="0" b="0"/>
+        </a:fillRef>
+        <a:effectRef idx="0">
+          <a:scrgbClr r="0" g="0" b="0"/>
+        </a:effectRef>
+        <a:fontRef idx="minor">
+          <a:schemeClr val="lt1"/>
+        </a:fontRef>
+      </dsp:style>
+      <dsp:txBody>
+        <a:bodyPr spcFirstLastPara="0" vert="horz" wrap="square" lIns="0" tIns="0" rIns="0" bIns="0" numCol="1" spcCol="1270" anchor="ctr" anchorCtr="0">
+          <a:noAutofit/>
+        </a:bodyPr>
+        <a:lstStyle/>
+        <a:p>
+          <a:pPr marL="0" lvl="0" indent="0" algn="ctr" defTabSz="1066800">
+            <a:lnSpc>
+              <a:spcPct val="90000"/>
+            </a:lnSpc>
+            <a:spcBef>
+              <a:spcPct val="0"/>
+            </a:spcBef>
+            <a:spcAft>
+              <a:spcPct val="35000"/>
+            </a:spcAft>
+            <a:buNone/>
+          </a:pPr>
+          <a:endParaRPr lang="es-CL" sz="2400" kern="1200"/>
+        </a:p>
+      </dsp:txBody>
+      <dsp:txXfrm>
+        <a:off x="3047880" y="1970146"/>
+        <a:ext cx="409940" cy="411044"/>
+      </dsp:txXfrm>
+    </dsp:sp>
+    <dsp:sp modelId="{DB5B3C18-27D4-4F99-BA0C-4A17568A05B0}">
+      <dsp:nvSpPr>
+        <dsp:cNvPr id="0" name=""/>
+        <dsp:cNvSpPr/>
+      </dsp:nvSpPr>
+      <dsp:spPr>
+        <a:xfrm>
+          <a:off x="3876600" y="1346949"/>
+          <a:ext cx="2762398" cy="1657439"/>
+        </a:xfrm>
+        <a:prstGeom prst="roundRect">
+          <a:avLst>
+            <a:gd name="adj" fmla="val 10000"/>
+          </a:avLst>
+        </a:prstGeom>
+        <a:solidFill>
+          <a:schemeClr val="accent1">
+            <a:hueOff val="0"/>
+            <a:satOff val="0"/>
+            <a:lumOff val="0"/>
+            <a:alphaOff val="0"/>
+          </a:schemeClr>
+        </a:solidFill>
+        <a:ln w="12700" cap="flat" cmpd="sng" algn="ctr">
+          <a:solidFill>
+            <a:schemeClr val="lt1">
+              <a:hueOff val="0"/>
+              <a:satOff val="0"/>
+              <a:lumOff val="0"/>
+              <a:alphaOff val="0"/>
+            </a:schemeClr>
+          </a:solidFill>
+          <a:prstDash val="solid"/>
+          <a:miter lim="800000"/>
+        </a:ln>
+        <a:effectLst/>
+      </dsp:spPr>
+      <dsp:style>
+        <a:lnRef idx="2">
+          <a:scrgbClr r="0" g="0" b="0"/>
+        </a:lnRef>
+        <a:fillRef idx="1">
+          <a:scrgbClr r="0" g="0" b="0"/>
+        </a:fillRef>
+        <a:effectRef idx="0">
+          <a:scrgbClr r="0" g="0" b="0"/>
+        </a:effectRef>
+        <a:fontRef idx="minor">
+          <a:schemeClr val="lt1"/>
+        </a:fontRef>
+      </dsp:style>
+      <dsp:txBody>
+        <a:bodyPr spcFirstLastPara="0" vert="horz" wrap="square" lIns="114300" tIns="114300" rIns="114300" bIns="114300" numCol="1" spcCol="1270" anchor="ctr" anchorCtr="0">
+          <a:noAutofit/>
+        </a:bodyPr>
+        <a:lstStyle/>
+        <a:p>
+          <a:pPr marL="0" lvl="0" indent="0" algn="ctr" defTabSz="1333500">
+            <a:lnSpc>
+              <a:spcPct val="90000"/>
+            </a:lnSpc>
+            <a:spcBef>
+              <a:spcPct val="0"/>
+            </a:spcBef>
+            <a:spcAft>
+              <a:spcPct val="35000"/>
+            </a:spcAft>
+            <a:buNone/>
+          </a:pPr>
+          <a:r>
+            <a:rPr lang="es-MX" sz="3000" kern="1200" dirty="0"/>
+            <a:t>Definición de un </a:t>
+          </a:r>
+          <a:r>
+            <a:rPr lang="es-MX" sz="3000" kern="1200" dirty="0" err="1"/>
+            <a:t>dataset</a:t>
+          </a:r>
+          <a:r>
+            <a:rPr lang="es-MX" sz="3000" kern="1200" dirty="0"/>
+            <a:t> representativo</a:t>
+          </a:r>
+          <a:endParaRPr lang="es-CL" sz="3000" kern="1200" dirty="0"/>
+        </a:p>
+      </dsp:txBody>
+      <dsp:txXfrm>
+        <a:off x="3925145" y="1395494"/>
+        <a:ext cx="2665308" cy="1560349"/>
+      </dsp:txXfrm>
+    </dsp:sp>
+    <dsp:sp modelId="{9A339B42-B521-4EEB-8BE5-073F65B5B026}">
+      <dsp:nvSpPr>
+        <dsp:cNvPr id="0" name=""/>
+        <dsp:cNvSpPr/>
+      </dsp:nvSpPr>
+      <dsp:spPr>
+        <a:xfrm>
+          <a:off x="6915239" y="1833131"/>
+          <a:ext cx="585628" cy="685074"/>
+        </a:xfrm>
+        <a:prstGeom prst="rightArrow">
+          <a:avLst>
+            <a:gd name="adj1" fmla="val 60000"/>
+            <a:gd name="adj2" fmla="val 50000"/>
+          </a:avLst>
+        </a:prstGeom>
+        <a:solidFill>
+          <a:schemeClr val="accent1">
+            <a:tint val="60000"/>
+            <a:hueOff val="0"/>
+            <a:satOff val="0"/>
+            <a:lumOff val="0"/>
+            <a:alphaOff val="0"/>
+          </a:schemeClr>
+        </a:solidFill>
+        <a:ln>
+          <a:noFill/>
+        </a:ln>
+        <a:effectLst/>
+      </dsp:spPr>
+      <dsp:style>
+        <a:lnRef idx="0">
+          <a:scrgbClr r="0" g="0" b="0"/>
+        </a:lnRef>
+        <a:fillRef idx="1">
+          <a:scrgbClr r="0" g="0" b="0"/>
+        </a:fillRef>
+        <a:effectRef idx="0">
+          <a:scrgbClr r="0" g="0" b="0"/>
+        </a:effectRef>
+        <a:fontRef idx="minor">
+          <a:schemeClr val="lt1"/>
+        </a:fontRef>
+      </dsp:style>
+      <dsp:txBody>
+        <a:bodyPr spcFirstLastPara="0" vert="horz" wrap="square" lIns="0" tIns="0" rIns="0" bIns="0" numCol="1" spcCol="1270" anchor="ctr" anchorCtr="0">
+          <a:noAutofit/>
+        </a:bodyPr>
+        <a:lstStyle/>
+        <a:p>
+          <a:pPr marL="0" lvl="0" indent="0" algn="ctr" defTabSz="1066800">
+            <a:lnSpc>
+              <a:spcPct val="90000"/>
+            </a:lnSpc>
+            <a:spcBef>
+              <a:spcPct val="0"/>
+            </a:spcBef>
+            <a:spcAft>
+              <a:spcPct val="35000"/>
+            </a:spcAft>
+            <a:buNone/>
+          </a:pPr>
+          <a:endParaRPr lang="es-CL" sz="2400" kern="1200"/>
+        </a:p>
+      </dsp:txBody>
+      <dsp:txXfrm>
+        <a:off x="6915239" y="1970146"/>
+        <a:ext cx="409940" cy="411044"/>
+      </dsp:txXfrm>
+    </dsp:sp>
+    <dsp:sp modelId="{CA53FA59-2C7E-421B-B440-40591DCCD046}">
+      <dsp:nvSpPr>
+        <dsp:cNvPr id="0" name=""/>
+        <dsp:cNvSpPr/>
+      </dsp:nvSpPr>
+      <dsp:spPr>
+        <a:xfrm>
+          <a:off x="7743958" y="1346949"/>
+          <a:ext cx="2762398" cy="1657439"/>
+        </a:xfrm>
+        <a:prstGeom prst="roundRect">
+          <a:avLst>
+            <a:gd name="adj" fmla="val 10000"/>
+          </a:avLst>
+        </a:prstGeom>
+        <a:solidFill>
+          <a:schemeClr val="accent1">
+            <a:hueOff val="0"/>
+            <a:satOff val="0"/>
+            <a:lumOff val="0"/>
+            <a:alphaOff val="0"/>
+          </a:schemeClr>
+        </a:solidFill>
+        <a:ln w="12700" cap="flat" cmpd="sng" algn="ctr">
+          <a:solidFill>
+            <a:schemeClr val="lt1">
+              <a:hueOff val="0"/>
+              <a:satOff val="0"/>
+              <a:lumOff val="0"/>
+              <a:alphaOff val="0"/>
+            </a:schemeClr>
+          </a:solidFill>
+          <a:prstDash val="solid"/>
+          <a:miter lim="800000"/>
+        </a:ln>
+        <a:effectLst/>
+      </dsp:spPr>
+      <dsp:style>
+        <a:lnRef idx="2">
+          <a:scrgbClr r="0" g="0" b="0"/>
+        </a:lnRef>
+        <a:fillRef idx="1">
+          <a:scrgbClr r="0" g="0" b="0"/>
+        </a:fillRef>
+        <a:effectRef idx="0">
+          <a:scrgbClr r="0" g="0" b="0"/>
+        </a:effectRef>
+        <a:fontRef idx="minor">
+          <a:schemeClr val="lt1"/>
+        </a:fontRef>
+      </dsp:style>
+      <dsp:txBody>
+        <a:bodyPr spcFirstLastPara="0" vert="horz" wrap="square" lIns="114300" tIns="114300" rIns="114300" bIns="114300" numCol="1" spcCol="1270" anchor="ctr" anchorCtr="0">
+          <a:noAutofit/>
+        </a:bodyPr>
+        <a:lstStyle/>
+        <a:p>
+          <a:pPr marL="0" lvl="0" indent="0" algn="ctr" defTabSz="1333500">
+            <a:lnSpc>
+              <a:spcPct val="90000"/>
+            </a:lnSpc>
+            <a:spcBef>
+              <a:spcPct val="0"/>
+            </a:spcBef>
+            <a:spcAft>
+              <a:spcPct val="35000"/>
+            </a:spcAft>
+            <a:buNone/>
+          </a:pPr>
+          <a:r>
+            <a:rPr lang="es-MX" sz="3000" kern="1200" dirty="0"/>
+            <a:t>Conversión de pesos, entradas y salidas</a:t>
+          </a:r>
+          <a:endParaRPr lang="es-CL" sz="3000" kern="1200" dirty="0"/>
+        </a:p>
+      </dsp:txBody>
+      <dsp:txXfrm>
+        <a:off x="7792503" y="1395494"/>
+        <a:ext cx="2665308" cy="1560349"/>
+      </dsp:txXfrm>
+    </dsp:sp>
+  </dsp:spTree>
+</dsp:drawing>
+</file>
+
+<file path=ppt/diagrams/layout1.xml><?xml version="1.0" encoding="utf-8"?>
+<dgm:layoutDef xmlns:dgm="http://schemas.openxmlformats.org/drawingml/2006/diagram" xmlns:a="http://schemas.openxmlformats.org/drawingml/2006/main" uniqueId="urn:microsoft.com/office/officeart/2005/8/layout/process1">
+  <dgm:title val=""/>
+  <dgm:desc val=""/>
+  <dgm:catLst>
+    <dgm:cat type="process" pri="1000"/>
+    <dgm:cat type="convert" pri="15000"/>
+  </dgm:catLst>
+  <dgm:sampData useDef="1">
+    <dgm:dataModel>
+      <dgm:ptLst/>
+      <dgm:bg/>
+      <dgm:whole/>
+    </dgm:dataModel>
+  </dgm:sampData>
+  <dgm:styleData>
+    <dgm:dataModel>
+      <dgm:ptLst>
+        <dgm:pt modelId="0" type="doc"/>
+        <dgm:pt modelId="1"/>
+        <dgm:pt modelId="2"/>
+      </dgm:ptLst>
+      <dgm:cxnLst>
+        <dgm:cxn modelId="3" srcId="0" destId="1" srcOrd="0" destOrd="0"/>
+        <dgm:cxn modelId="4" srcId="0" destId="2" srcOrd="1" destOrd="0"/>
+      </dgm:cxnLst>
+      <dgm:bg/>
+      <dgm:whole/>
+    </dgm:dataModel>
+  </dgm:styleData>
+  <dgm:clrData>
+    <dgm:dataModel>
+      <dgm:ptLst>
+        <dgm:pt modelId="0" type="doc"/>
+        <dgm:pt modelId="1"/>
+        <dgm:pt modelId="2"/>
+        <dgm:pt modelId="3"/>
+        <dgm:pt modelId="4"/>
+      </dgm:ptLst>
+      <dgm:cxnLst>
+        <dgm:cxn modelId="5" srcId="0" destId="1" srcOrd="0" destOrd="0"/>
+        <dgm:cxn modelId="6" srcId="0" destId="2" srcOrd="1" destOrd="0"/>
+        <dgm:cxn modelId="7" srcId="0" destId="3" srcOrd="2" destOrd="0"/>
+        <dgm:cxn modelId="8" srcId="0" destId="4" srcOrd="3" destOrd="0"/>
+      </dgm:cxnLst>
+      <dgm:bg/>
+      <dgm:whole/>
+    </dgm:dataModel>
+  </dgm:clrData>
+  <dgm:layoutNode name="Name0">
+    <dgm:varLst>
+      <dgm:dir/>
+      <dgm:resizeHandles val="exact"/>
+    </dgm:varLst>
+    <dgm:choose name="Name1">
+      <dgm:if name="Name2" func="var" arg="dir" op="equ" val="norm">
+        <dgm:alg type="lin"/>
+      </dgm:if>
+      <dgm:else name="Name3">
+        <dgm:alg type="lin">
+          <dgm:param type="linDir" val="fromR"/>
+        </dgm:alg>
+      </dgm:else>
+    </dgm:choose>
+    <dgm:shape xmlns:r="http://schemas.openxmlformats.org/officeDocument/2006/relationships" r:blip="">
+      <dgm:adjLst/>
+    </dgm:shape>
+    <dgm:presOf/>
+    <dgm:constrLst>
+      <dgm:constr type="w" for="ch" ptType="node" refType="w"/>
+      <dgm:constr type="h" for="ch" ptType="node" op="equ"/>
+      <dgm:constr type="primFontSz" for="ch" ptType="node" op="equ" val="65"/>
+      <dgm:constr type="w" for="ch" ptType="sibTrans" refType="w" refFor="ch" refPtType="node" op="equ" fact="0.4"/>
+      <dgm:constr type="h" for="ch" ptType="sibTrans" op="equ"/>
+      <dgm:constr type="primFontSz" for="des" forName="connectorText" op="equ" val="55"/>
+      <dgm:constr type="primFontSz" for="des" forName="connectorText" refType="primFontSz" refFor="ch" refPtType="node" op="lte" fact="0.8"/>
+    </dgm:constrLst>
+    <dgm:ruleLst/>
+    <dgm:forEach name="nodesForEach" axis="ch" ptType="node">
+      <dgm:layoutNode name="node">
+        <dgm:varLst>
+          <dgm:bulletEnabled val="1"/>
+        </dgm:varLst>
+        <dgm:alg type="tx"/>
+        <dgm:shape xmlns:r="http://schemas.openxmlformats.org/officeDocument/2006/relationships" type="roundRect" r:blip="">
+          <dgm:adjLst>
+            <dgm:adj idx="1" val="0.1"/>
+          </dgm:adjLst>
+        </dgm:shape>
+        <dgm:presOf axis="desOrSelf" ptType="node"/>
+        <dgm:constrLst>
+          <dgm:constr type="h" refType="w" fact="0.6"/>
+          <dgm:constr type="tMarg" refType="primFontSz" fact="0.3"/>
+          <dgm:constr type="bMarg" refType="primFontSz" fact="0.3"/>
+          <dgm:constr type="lMarg" refType="primFontSz" fact="0.3"/>
+          <dgm:constr type="rMarg" refType="primFontSz" fact="0.3"/>
+        </dgm:constrLst>
+        <dgm:ruleLst>
+          <dgm:rule type="primFontSz" val="18" fact="NaN" max="NaN"/>
+          <dgm:rule type="h" val="NaN" fact="1.5" max="NaN"/>
+          <dgm:rule type="primFontSz" val="5" fact="NaN" max="NaN"/>
+          <dgm:rule type="h" val="INF" fact="NaN" max="NaN"/>
+        </dgm:ruleLst>
+      </dgm:layoutNode>
+      <dgm:forEach name="sibTransForEach" axis="followSib" ptType="sibTrans" cnt="1">
+        <dgm:layoutNode name="sibTrans">
+          <dgm:alg type="conn">
+            <dgm:param type="begPts" val="auto"/>
+            <dgm:param type="endPts" val="auto"/>
+          </dgm:alg>
+          <dgm:shape xmlns:r="http://schemas.openxmlformats.org/officeDocument/2006/relationships" type="conn" r:blip="">
+            <dgm:adjLst/>
+          </dgm:shape>
+          <dgm:presOf axis="self"/>
+          <dgm:constrLst>
+            <dgm:constr type="h" refType="w" fact="0.62"/>
+            <dgm:constr type="connDist"/>
+            <dgm:constr type="begPad" refType="connDist" fact="0.25"/>
+            <dgm:constr type="endPad" refType="connDist" fact="0.22"/>
+          </dgm:constrLst>
+          <dgm:ruleLst/>
+          <dgm:layoutNode name="connectorText">
+            <dgm:alg type="tx">
+              <dgm:param type="autoTxRot" val="grav"/>
+            </dgm:alg>
+            <dgm:shape xmlns:r="http://schemas.openxmlformats.org/officeDocument/2006/relationships" type="conn" r:blip="" hideGeom="1">
+              <dgm:adjLst/>
+            </dgm:shape>
+            <dgm:presOf axis="self"/>
+            <dgm:constrLst>
+              <dgm:constr type="lMarg"/>
+              <dgm:constr type="rMarg"/>
+              <dgm:constr type="tMarg"/>
+              <dgm:constr type="bMarg"/>
+            </dgm:constrLst>
+            <dgm:ruleLst>
+              <dgm:rule type="primFontSz" val="5" fact="NaN" max="NaN"/>
+            </dgm:ruleLst>
+          </dgm:layoutNode>
+        </dgm:layoutNode>
+      </dgm:forEach>
+    </dgm:forEach>
+  </dgm:layoutNode>
+</dgm:layoutDef>
+</file>
+
+<file path=ppt/diagrams/quickStyle1.xml><?xml version="1.0" encoding="utf-8"?>
+<dgm:styleDef xmlns:dgm="http://schemas.openxmlformats.org/drawingml/2006/diagram" xmlns:a="http://schemas.openxmlformats.org/drawingml/2006/main" uniqueId="urn:microsoft.com/office/officeart/2005/8/quickstyle/simple1">
+  <dgm:title val=""/>
+  <dgm:desc val=""/>
+  <dgm:catLst>
+    <dgm:cat type="simple" pri="10100"/>
+  </dgm:catLst>
+  <dgm:scene3d>
+    <a:camera prst="orthographicFront"/>
+    <a:lightRig rig="threePt" dir="t"/>
+  </dgm:scene3d>
+  <dgm:styleLbl name="node0">
+    <dgm:scene3d>
+      <a:camera prst="orthographicFront"/>
+      <a:lightRig rig="threePt" dir="t"/>
+    </dgm:scene3d>
+    <dgm:sp3d/>
+    <dgm:txPr/>
+    <dgm:style>
+      <a:lnRef idx="2">
+        <a:scrgbClr r="0" g="0" b="0"/>
+      </a:lnRef>
+      <a:fillRef idx="1">
+        <a:scrgbClr r="0" g="0" b="0"/>
+      </a:fillRef>
+      <a:effectRef idx="0">
+        <a:scrgbClr r="0" g="0" b="0"/>
+      </a:effectRef>
+      <a:fontRef idx="minor">
+        <a:schemeClr val="lt1"/>
+      </a:fontRef>
+    </dgm:style>
+  </dgm:styleLbl>
+  <dgm:styleLbl name="lnNode1">
+    <dgm:scene3d>
+      <a:camera prst="orthographicFront"/>
+      <a:lightRig rig="threePt" dir="t"/>
+    </dgm:scene3d>
+    <dgm:sp3d/>
+    <dgm:txPr/>
+    <dgm:style>
+      <a:lnRef idx="2">
+        <a:scrgbClr r="0" g="0" b="0"/>
+      </a:lnRef>
+      <a:fillRef idx="1">
+        <a:scrgbClr r="0" g="0" b="0"/>
+      </a:fillRef>
+      <a:effectRef idx="0">
+        <a:scrgbClr r="0" g="0" b="0"/>
+      </a:effectRef>
+      <a:fontRef idx="minor">
+        <a:schemeClr val="lt1"/>
+      </a:fontRef>
+    </dgm:style>
+  </dgm:styleLbl>
+  <dgm:styleLbl name="vennNode1">
+    <dgm:scene3d>
+      <a:camera prst="orthographicFront"/>
+      <a:lightRig rig="threePt" dir="t"/>
+    </dgm:scene3d>
+    <dgm:sp3d/>
+    <dgm:txPr/>
+    <dgm:style>
+      <a:lnRef idx="2">
+        <a:scrgbClr r="0" g="0" b="0"/>
+      </a:lnRef>
+      <a:fillRef idx="1">
+        <a:scrgbClr r="0" g="0" b="0"/>
+      </a:fillRef>
+      <a:effectRef idx="0">
+        <a:scrgbClr r="0" g="0" b="0"/>
+      </a:effectRef>
+      <a:fontRef idx="minor">
+        <a:schemeClr val="tx1"/>
+      </a:fontRef>
+    </dgm:style>
+  </dgm:styleLbl>
+  <dgm:styleLbl name="alignNode1">
+    <dgm:scene3d>
+      <a:camera prst="orthographicFront"/>
+      <a:lightRig rig="threePt" dir="t"/>
+    </dgm:scene3d>
+    <dgm:sp3d/>
+    <dgm:txPr/>
+    <dgm:style>
+      <a:lnRef idx="2">
+        <a:scrgbClr r="0" g="0" b="0"/>
+      </a:lnRef>
+      <a:fillRef idx="1">
+        <a:scrgbClr r="0" g="0" b="0"/>
+      </a:fillRef>
+      <a:effectRef idx="0">
+        <a:scrgbClr r="0" g="0" b="0"/>
+      </a:effectRef>
+      <a:fontRef idx="minor">
+        <a:schemeClr val="lt1"/>
+      </a:fontRef>
+    </dgm:style>
+  </dgm:styleLbl>
+  <dgm:styleLbl name="node1">
+    <dgm:scene3d>
+      <a:camera prst="orthographicFront"/>
+      <a:lightRig rig="threePt" dir="t"/>
+    </dgm:scene3d>
+    <dgm:sp3d/>
+    <dgm:txPr/>
+    <dgm:style>
+      <a:lnRef idx="2">
+        <a:scrgbClr r="0" g="0" b="0"/>
+      </a:lnRef>
+      <a:fillRef idx="1">
+        <a:scrgbClr r="0" g="0" b="0"/>
+      </a:fillRef>
+      <a:effectRef idx="0">
+        <a:scrgbClr r="0" g="0" b="0"/>
+      </a:effectRef>
+      <a:fontRef idx="minor">
+        <a:schemeClr val="lt1"/>
+      </a:fontRef>
+    </dgm:style>
+  </dgm:styleLbl>
+  <dgm:styleLbl name="node2">
+    <dgm:scene3d>
+      <a:camera prst="orthographicFront"/>
+      <a:lightRig rig="threePt" dir="t"/>
+    </dgm:scene3d>
+    <dgm:sp3d/>
+    <dgm:txPr/>
+    <dgm:style>
+      <a:lnRef idx="2">
+        <a:scrgbClr r="0" g="0" b="0"/>
+      </a:lnRef>
+      <a:fillRef idx="1">
+        <a:scrgbClr r="0" g="0" b="0"/>
+      </a:fillRef>
+      <a:effectRef idx="0">
+        <a:scrgbClr r="0" g="0" b="0"/>
+      </a:effectRef>
+      <a:fontRef idx="minor">
+        <a:schemeClr val="lt1"/>
+      </a:fontRef>
+    </dgm:style>
+  </dgm:styleLbl>
+  <dgm:styleLbl name="node3">
+    <dgm:scene3d>
+      <a:camera prst="orthographicFront"/>
+      <a:lightRig rig="threePt" dir="t"/>
+    </dgm:scene3d>
+    <dgm:sp3d/>
+    <dgm:txPr/>
+    <dgm:style>
+      <a:lnRef idx="2">
+        <a:scrgbClr r="0" g="0" b="0"/>
+      </a:lnRef>
+      <a:fillRef idx="1">
+        <a:scrgbClr r="0" g="0" b="0"/>
+      </a:fillRef>
+      <a:effectRef idx="0">
+        <a:scrgbClr r="0" g="0" b="0"/>
+      </a:effectRef>
+      <a:fontRef idx="minor">
+        <a:schemeClr val="lt1"/>
+      </a:fontRef>
+    </dgm:style>
+  </dgm:styleLbl>
+  <dgm:styleLbl name="node4">
+    <dgm:scene3d>
+      <a:camera prst="orthographicFront"/>
+      <a:lightRig rig="threePt" dir="t"/>
+    </dgm:scene3d>
+    <dgm:sp3d/>
+    <dgm:txPr/>
+    <dgm:style>
+      <a:lnRef idx="2">
+        <a:scrgbClr r="0" g="0" b="0"/>
+      </a:lnRef>
+      <a:fillRef idx="1">
+        <a:scrgbClr r="0" g="0" b="0"/>
+      </a:fillRef>
+      <a:effectRef idx="0">
+        <a:scrgbClr r="0" g="0" b="0"/>
+      </a:effectRef>
+      <a:fontRef idx="minor">
+        <a:schemeClr val="lt1"/>
+      </a:fontRef>
+    </dgm:style>
+  </dgm:styleLbl>
+  <dgm:styleLbl name="fgImgPlace1">
+    <dgm:scene3d>
+      <a:camera prst="orthographicFront"/>
+      <a:lightRig rig="threePt" dir="t"/>
+    </dgm:scene3d>
+    <dgm:sp3d/>
+    <dgm:txPr/>
+    <dgm:style>
+      <a:lnRef idx="2">
+        <a:scrgbClr r="0" g="0" b="0"/>
+      </a:lnRef>
+      <a:fillRef idx="1">
+        <a:scrgbClr r="0" g="0" b="0"/>
+      </a:fillRef>
+      <a:effectRef idx="0">
+        <a:scrgbClr r="0" g="0" b="0"/>
+      </a:effectRef>
+      <a:fontRef idx="minor"/>
+    </dgm:style>
+  </dgm:styleLbl>
+  <dgm:styleLbl name="alignImgPlace1">
+    <dgm:scene3d>
+      <a:camera prst="orthographicFront"/>
+      <a:lightRig rig="threePt" dir="t"/>
+    </dgm:scene3d>
+    <dgm:sp3d/>
+    <dgm:txPr/>
+    <dgm:style>
+      <a:lnRef idx="2">
+        <a:scrgbClr r="0" g="0" b="0"/>
+      </a:lnRef>
+      <a:fillRef idx="1">
+        <a:scrgbClr r="0" g="0" b="0"/>
+      </a:fillRef>
+      <a:effectRef idx="0">
+        <a:scrgbClr r="0" g="0" b="0"/>
+      </a:effectRef>
+      <a:fontRef idx="minor"/>
+    </dgm:style>
+  </dgm:styleLbl>
+  <dgm:styleLbl name="bgImgPlace1">
+    <dgm:scene3d>
+      <a:camera prst="orthographicFront"/>
+      <a:lightRig rig="threePt" dir="t"/>
+    </dgm:scene3d>
+    <dgm:sp3d/>
+    <dgm:txPr/>
+    <dgm:style>
+      <a:lnRef idx="2">
+        <a:scrgbClr r="0" g="0" b="0"/>
+      </a:lnRef>
+      <a:fillRef idx="1">
+        <a:scrgbClr r="0" g="0" b="0"/>
+      </a:fillRef>
+      <a:effectRef idx="0">
+        <a:scrgbClr r="0" g="0" b="0"/>
+      </a:effectRef>
+      <a:fontRef idx="minor"/>
+    </dgm:style>
+  </dgm:styleLbl>
+  <dgm:styleLbl name="sibTrans2D1">
+    <dgm:scene3d>
+      <a:camera prst="orthographicFront"/>
+      <a:lightRig rig="threePt" dir="t"/>
+    </dgm:scene3d>
+    <dgm:sp3d/>
+    <dgm:txPr/>
+    <dgm:style>
+      <a:lnRef idx="0">
+        <a:scrgbClr r="0" g="0" b="0"/>
+      </a:lnRef>
+      <a:fillRef idx="1">
+        <a:scrgbClr r="0" g="0" b="0"/>
+      </a:fillRef>
+      <a:effectRef idx="0">
+        <a:scrgbClr r="0" g="0" b="0"/>
+      </a:effectRef>
+      <a:fontRef idx="minor">
+        <a:schemeClr val="lt1"/>
+      </a:fontRef>
+    </dgm:style>
+  </dgm:styleLbl>
+  <dgm:styleLbl name="fgSibTrans2D1">
+    <dgm:scene3d>
+      <a:camera prst="orthographicFront"/>
+      <a:lightRig rig="threePt" dir="t"/>
+    </dgm:scene3d>
+    <dgm:sp3d/>
+    <dgm:txPr/>
+    <dgm:style>
+      <a:lnRef idx="0">
+        <a:scrgbClr r="0" g="0" b="0"/>
+      </a:lnRef>
+      <a:fillRef idx="1">
+        <a:scrgbClr r="0" g="0" b="0"/>
+      </a:fillRef>
+      <a:effectRef idx="0">
+        <a:scrgbClr r="0" g="0" b="0"/>
+      </a:effectRef>
+      <a:fontRef idx="minor">
+        <a:schemeClr val="lt1"/>
+      </a:fontRef>
+    </dgm:style>
+  </dgm:styleLbl>
+  <dgm:styleLbl name="bgSibTrans2D1">
+    <dgm:scene3d>
+      <a:camera prst="orthographicFront"/>
+      <a:lightRig rig="threePt" dir="t"/>
+    </dgm:scene3d>
+    <dgm:sp3d/>
+    <dgm:txPr/>
+    <dgm:style>
+      <a:lnRef idx="0">
+        <a:scrgbClr r="0" g="0" b="0"/>
+      </a:lnRef>
+      <a:fillRef idx="1">
+        <a:scrgbClr r="0" g="0" b="0"/>
+      </a:fillRef>
+      <a:effectRef idx="0">
+        <a:scrgbClr r="0" g="0" b="0"/>
+      </a:effectRef>
+      <a:fontRef idx="minor">
+        <a:schemeClr val="lt1"/>
+      </a:fontRef>
+    </dgm:style>
+  </dgm:styleLbl>
+  <dgm:styleLbl name="sibTrans1D1">
+    <dgm:scene3d>
+      <a:camera prst="orthographicFront"/>
+      <a:lightRig rig="threePt" dir="t"/>
+    </dgm:scene3d>
+    <dgm:sp3d/>
+    <dgm:txPr/>
+    <dgm:style>
+      <a:lnRef idx="1">
+        <a:scrgbClr r="0" g="0" b="0"/>
+      </a:lnRef>
+      <a:fillRef idx="0">
+        <a:scrgbClr r="0" g="0" b="0"/>
+      </a:fillRef>
+      <a:effectRef idx="0">
+        <a:scrgbClr r="0" g="0" b="0"/>
+      </a:effectRef>
+      <a:fontRef idx="minor"/>
+    </dgm:style>
+  </dgm:styleLbl>
+  <dgm:styleLbl name="callout">
+    <dgm:scene3d>
+      <a:camera prst="orthographicFront"/>
+      <a:lightRig rig="threePt" dir="t"/>
+    </dgm:scene3d>
+    <dgm:sp3d/>
+    <dgm:txPr/>
+    <dgm:style>
+      <a:lnRef idx="2">
+        <a:scrgbClr r="0" g="0" b="0"/>
+      </a:lnRef>
+      <a:fillRef idx="1">
+        <a:scrgbClr r="0" g="0" b="0"/>
+      </a:fillRef>
+      <a:effectRef idx="0">
+        <a:scrgbClr r="0" g="0" b="0"/>
+      </a:effectRef>
+      <a:fontRef idx="minor"/>
+    </dgm:style>
+  </dgm:styleLbl>
+  <dgm:styleLbl name="asst0">
+    <dgm:scene3d>
+      <a:camera prst="orthographicFront"/>
+      <a:lightRig rig="threePt" dir="t"/>
+    </dgm:scene3d>
+    <dgm:sp3d/>
+    <dgm:txPr/>
+    <dgm:style>
+      <a:lnRef idx="2">
+        <a:scrgbClr r="0" g="0" b="0"/>
+      </a:lnRef>
+      <a:fillRef idx="1">
+        <a:scrgbClr r="0" g="0" b="0"/>
+      </a:fillRef>
+      <a:effectRef idx="0">
+        <a:scrgbClr r="0" g="0" b="0"/>
+      </a:effectRef>
+      <a:fontRef idx="minor">
+        <a:schemeClr val="lt1"/>
+      </a:fontRef>
+    </dgm:style>
+  </dgm:styleLbl>
+  <dgm:styleLbl name="asst1">
+    <dgm:scene3d>
+      <a:camera prst="orthographicFront"/>
+      <a:lightRig rig="threePt" dir="t"/>
+    </dgm:scene3d>
+    <dgm:sp3d/>
+    <dgm:txPr/>
+    <dgm:style>
+      <a:lnRef idx="2">
+        <a:scrgbClr r="0" g="0" b="0"/>
+      </a:lnRef>
+      <a:fillRef idx="1">
+        <a:scrgbClr r="0" g="0" b="0"/>
+      </a:fillRef>
+      <a:effectRef idx="0">
+        <a:scrgbClr r="0" g="0" b="0"/>
+      </a:effectRef>
+      <a:fontRef idx="minor">
+        <a:schemeClr val="lt1"/>
+      </a:fontRef>
+    </dgm:style>
+  </dgm:styleLbl>
+  <dgm:styleLbl name="asst2">
+    <dgm:scene3d>
+      <a:camera prst="orthographicFront"/>
+      <a:lightRig rig="threePt" dir="t"/>
+    </dgm:scene3d>
+    <dgm:sp3d/>
+    <dgm:txPr/>
+    <dgm:style>
+      <a:lnRef idx="2">
+        <a:scrgbClr r="0" g="0" b="0"/>
+      </a:lnRef>
+      <a:fillRef idx="1">
+        <a:scrgbClr r="0" g="0" b="0"/>
+      </a:fillRef>
+      <a:effectRef idx="0">
+        <a:scrgbClr r="0" g="0" b="0"/>
+      </a:effectRef>
+      <a:fontRef idx="minor">
+        <a:schemeClr val="lt1"/>
+      </a:fontRef>
+    </dgm:style>
+  </dgm:styleLbl>
+  <dgm:styleLbl name="asst3">
+    <dgm:scene3d>
+      <a:camera prst="orthographicFront"/>
+      <a:lightRig rig="threePt" dir="t"/>
+    </dgm:scene3d>
+    <dgm:sp3d/>
+    <dgm:txPr/>
+    <dgm:style>
+      <a:lnRef idx="2">
+        <a:scrgbClr r="0" g="0" b="0"/>
+      </a:lnRef>
+      <a:fillRef idx="1">
+        <a:scrgbClr r="0" g="0" b="0"/>
+      </a:fillRef>
+      <a:effectRef idx="0">
+        <a:scrgbClr r="0" g="0" b="0"/>
+      </a:effectRef>
+      <a:fontRef idx="minor">
+        <a:schemeClr val="lt1"/>
+      </a:fontRef>
+    </dgm:style>
+  </dgm:styleLbl>
+  <dgm:styleLbl name="asst4">
+    <dgm:scene3d>
+      <a:camera prst="orthographicFront"/>
+      <a:lightRig rig="threePt" dir="t"/>
+    </dgm:scene3d>
+    <dgm:sp3d/>
+    <dgm:txPr/>
+    <dgm:style>
+      <a:lnRef idx="2">
+        <a:scrgbClr r="0" g="0" b="0"/>
+      </a:lnRef>
+      <a:fillRef idx="1">
+        <a:scrgbClr r="0" g="0" b="0"/>
+      </a:fillRef>
+      <a:effectRef idx="0">
+        <a:scrgbClr r="0" g="0" b="0"/>
+      </a:effectRef>
+      <a:fontRef idx="minor">
+        <a:schemeClr val="lt1"/>
+      </a:fontRef>
+    </dgm:style>
+  </dgm:styleLbl>
+  <dgm:styleLbl name="parChTrans2D1">
+    <dgm:scene3d>
+      <a:camera prst="orthographicFront"/>
+      <a:lightRig rig="threePt" dir="t"/>
+    </dgm:scene3d>
+    <dgm:sp3d/>
+    <dgm:txPr/>
+    <dgm:style>
+      <a:lnRef idx="2">
+        <a:scrgbClr r="0" g="0" b="0"/>
+      </a:lnRef>
+      <a:fillRef idx="1">
+        <a:scrgbClr r="0" g="0" b="0"/>
+      </a:fillRef>
+      <a:effectRef idx="0">
+        <a:scrgbClr r="0" g="0" b="0"/>
+      </a:effectRef>
+      <a:fontRef idx="minor">
+        <a:schemeClr val="lt1"/>
+      </a:fontRef>
+    </dgm:style>
+  </dgm:styleLbl>
+  <dgm:styleLbl name="parChTrans2D2">
+    <dgm:scene3d>
+      <a:camera prst="orthographicFront"/>
+      <a:lightRig rig="threePt" dir="t"/>
+    </dgm:scene3d>
+    <dgm:sp3d/>
+    <dgm:txPr/>
+    <dgm:style>
+      <a:lnRef idx="2">
+        <a:scrgbClr r="0" g="0" b="0"/>
+      </a:lnRef>
+      <a:fillRef idx="1">
+        <a:scrgbClr r="0" g="0" b="0"/>
+      </a:fillRef>
+      <a:effectRef idx="0">
+        <a:scrgbClr r="0" g="0" b="0"/>
+      </a:effectRef>
+      <a:fontRef idx="minor">
+        <a:schemeClr val="lt1"/>
+      </a:fontRef>
+    </dgm:style>
+  </dgm:styleLbl>
+  <dgm:styleLbl name="parChTrans2D3">
+    <dgm:scene3d>
+      <a:camera prst="orthographicFront"/>
+      <a:lightRig rig="threePt" dir="t"/>
+    </dgm:scene3d>
+    <dgm:sp3d/>
+    <dgm:txPr/>
+    <dgm:style>
+      <a:lnRef idx="2">
+        <a:scrgbClr r="0" g="0" b="0"/>
+      </a:lnRef>
+      <a:fillRef idx="1">
+        <a:scrgbClr r="0" g="0" b="0"/>
+      </a:fillRef>
+      <a:effectRef idx="0">
+        <a:scrgbClr r="0" g="0" b="0"/>
+      </a:effectRef>
+      <a:fontRef idx="minor">
+        <a:schemeClr val="lt1"/>
+      </a:fontRef>
+    </dgm:style>
+  </dgm:styleLbl>
+  <dgm:styleLbl name="parChTrans2D4">
+    <dgm:scene3d>
+      <a:camera prst="orthographicFront"/>
+      <a:lightRig rig="threePt" dir="t"/>
+    </dgm:scene3d>
+    <dgm:sp3d/>
+    <dgm:txPr/>
+    <dgm:style>
+      <a:lnRef idx="2">
+        <a:scrgbClr r="0" g="0" b="0"/>
+      </a:lnRef>
+      <a:fillRef idx="1">
+        <a:scrgbClr r="0" g="0" b="0"/>
+      </a:fillRef>
+      <a:effectRef idx="0">
+        <a:scrgbClr r="0" g="0" b="0"/>
+      </a:effectRef>
+      <a:fontRef idx="minor">
+        <a:schemeClr val="lt1"/>
+      </a:fontRef>
+    </dgm:style>
+  </dgm:styleLbl>
+  <dgm:styleLbl name="parChTrans1D1">
+    <dgm:scene3d>
+      <a:camera prst="orthographicFront"/>
+      <a:lightRig rig="threePt" dir="t"/>
+    </dgm:scene3d>
+    <dgm:sp3d/>
+    <dgm:txPr/>
+    <dgm:style>
+      <a:lnRef idx="2">
+        <a:scrgbClr r="0" g="0" b="0"/>
+      </a:lnRef>
+      <a:fillRef idx="0">
+        <a:scrgbClr r="0" g="0" b="0"/>
+      </a:fillRef>
+      <a:effectRef idx="0">
+        <a:scrgbClr r="0" g="0" b="0"/>
+      </a:effectRef>
+      <a:fontRef idx="minor"/>
+    </dgm:style>
+  </dgm:styleLbl>
+  <dgm:styleLbl name="parChTrans1D2">
+    <dgm:scene3d>
+      <a:camera prst="orthographicFront"/>
+      <a:lightRig rig="threePt" dir="t"/>
+    </dgm:scene3d>
+    <dgm:sp3d/>
+    <dgm:txPr/>
+    <dgm:style>
+      <a:lnRef idx="2">
+        <a:scrgbClr r="0" g="0" b="0"/>
+      </a:lnRef>
+      <a:fillRef idx="0">
+        <a:scrgbClr r="0" g="0" b="0"/>
+      </a:fillRef>
+      <a:effectRef idx="0">
+        <a:scrgbClr r="0" g="0" b="0"/>
+      </a:effectRef>
+      <a:fontRef idx="minor"/>
+    </dgm:style>
+  </dgm:styleLbl>
+  <dgm:styleLbl name="parChTrans1D3">
+    <dgm:scene3d>
+      <a:camera prst="orthographicFront"/>
+      <a:lightRig rig="threePt" dir="t"/>
+    </dgm:scene3d>
+    <dgm:sp3d/>
+    <dgm:txPr/>
+    <dgm:style>
+      <a:lnRef idx="2">
+        <a:scrgbClr r="0" g="0" b="0"/>
+      </a:lnRef>
+      <a:fillRef idx="0">
+        <a:scrgbClr r="0" g="0" b="0"/>
+      </a:fillRef>
+      <a:effectRef idx="0">
+        <a:scrgbClr r="0" g="0" b="0"/>
+      </a:effectRef>
+      <a:fontRef idx="minor"/>
+    </dgm:style>
+  </dgm:styleLbl>
+  <dgm:styleLbl name="parChTrans1D4">
+    <dgm:scene3d>
+      <a:camera prst="orthographicFront"/>
+      <a:lightRig rig="threePt" dir="t"/>
+    </dgm:scene3d>
+    <dgm:sp3d/>
+    <dgm:txPr/>
+    <dgm:style>
+      <a:lnRef idx="2">
+        <a:scrgbClr r="0" g="0" b="0"/>
+      </a:lnRef>
+      <a:fillRef idx="0">
+        <a:scrgbClr r="0" g="0" b="0"/>
+      </a:fillRef>
+      <a:effectRef idx="0">
+        <a:scrgbClr r="0" g="0" b="0"/>
+      </a:effectRef>
+      <a:fontRef idx="minor"/>
+    </dgm:style>
+  </dgm:styleLbl>
+  <dgm:styleLbl name="fgAcc1">
+    <dgm:scene3d>
+      <a:camera prst="orthographicFront"/>
+      <a:lightRig rig="threePt" dir="t"/>
+    </dgm:scene3d>
+    <dgm:sp3d/>
+    <dgm:txPr/>
+    <dgm:style>
+      <a:lnRef idx="2">
+        <a:scrgbClr r="0" g="0" b="0"/>
+      </a:lnRef>
+      <a:fillRef idx="1">
+        <a:scrgbClr r="0" g="0" b="0"/>
+      </a:fillRef>
+      <a:effectRef idx="0">
+        <a:scrgbClr r="0" g="0" b="0"/>
+      </a:effectRef>
+      <a:fontRef idx="minor"/>
+    </dgm:style>
+  </dgm:styleLbl>
+  <dgm:styleLbl name="conFgAcc1">
+    <dgm:scene3d>
+      <a:camera prst="orthographicFront"/>
+      <a:lightRig rig="threePt" dir="t"/>
+    </dgm:scene3d>
+    <dgm:sp3d/>
+    <dgm:txPr/>
+    <dgm:style>
+      <a:lnRef idx="2">
+        <a:scrgbClr r="0" g="0" b="0"/>
+      </a:lnRef>
+      <a:fillRef idx="1">
+        <a:scrgbClr r="0" g="0" b="0"/>
+      </a:fillRef>
+      <a:effectRef idx="0">
+        <a:scrgbClr r="0" g="0" b="0"/>
+      </a:effectRef>
+      <a:fontRef idx="minor"/>
+    </dgm:style>
+  </dgm:styleLbl>
+  <dgm:styleLbl name="alignAcc1">
+    <dgm:scene3d>
+      <a:camera prst="orthographicFront"/>
+      <a:lightRig rig="threePt" dir="t"/>
+    </dgm:scene3d>
+    <dgm:sp3d/>
+    <dgm:txPr/>
+    <dgm:style>
+      <a:lnRef idx="2">
+        <a:scrgbClr r="0" g="0" b="0"/>
+      </a:lnRef>
+      <a:fillRef idx="1">
+        <a:scrgbClr r="0" g="0" b="0"/>
+      </a:fillRef>
+      <a:effectRef idx="0">
+        <a:scrgbClr r="0" g="0" b="0"/>
+      </a:effectRef>
+      <a:fontRef idx="minor"/>
+    </dgm:style>
+  </dgm:styleLbl>
+  <dgm:styleLbl name="trAlignAcc1">
+    <dgm:scene3d>
+      <a:camera prst="orthographicFront"/>
+      <a:lightRig rig="threePt" dir="t"/>
+    </dgm:scene3d>
+    <dgm:sp3d/>
+    <dgm:txPr/>
+    <dgm:style>
+      <a:lnRef idx="1">
+        <a:scrgbClr r="0" g="0" b="0"/>
+      </a:lnRef>
+      <a:fillRef idx="1">
+        <a:scrgbClr r="0" g="0" b="0"/>
+      </a:fillRef>
+      <a:effectRef idx="0">
+        <a:scrgbClr r="0" g="0" b="0"/>
+      </a:effectRef>
+      <a:fontRef idx="minor"/>
+    </dgm:style>
+  </dgm:styleLbl>
+  <dgm:styleLbl name="bgAcc1">
+    <dgm:scene3d>
+      <a:camera prst="orthographicFront"/>
+      <a:lightRig rig="threePt" dir="t"/>
+    </dgm:scene3d>
+    <dgm:sp3d/>
+    <dgm:txPr/>
+    <dgm:style>
+      <a:lnRef idx="2">
+        <a:scrgbClr r="0" g="0" b="0"/>
+      </a:lnRef>
+      <a:fillRef idx="1">
+        <a:scrgbClr r="0" g="0" b="0"/>
+      </a:fillRef>
+      <a:effectRef idx="0">
+        <a:scrgbClr r="0" g="0" b="0"/>
+      </a:effectRef>
+      <a:fontRef idx="minor"/>
+    </dgm:style>
+  </dgm:styleLbl>
+  <dgm:styleLbl name="solidFgAcc1">
+    <dgm:scene3d>
+      <a:camera prst="orthographicFront"/>
+      <a:lightRig rig="threePt" dir="t"/>
+    </dgm:scene3d>
+    <dgm:sp3d/>
+    <dgm:txPr/>
+    <dgm:style>
+      <a:lnRef idx="2">
+        <a:scrgbClr r="0" g="0" b="0"/>
+      </a:lnRef>
+      <a:fillRef idx="1">
+        <a:scrgbClr r="0" g="0" b="0"/>
+      </a:fillRef>
+      <a:effectRef idx="0">
+        <a:scrgbClr r="0" g="0" b="0"/>
+      </a:effectRef>
+      <a:fontRef idx="minor"/>
+    </dgm:style>
+  </dgm:styleLbl>
+  <dgm:styleLbl name="solidAlignAcc1">
+    <dgm:scene3d>
+      <a:camera prst="orthographicFront"/>
+      <a:lightRig rig="threePt" dir="t"/>
+    </dgm:scene3d>
+    <dgm:sp3d/>
+    <dgm:txPr/>
+    <dgm:style>
+      <a:lnRef idx="2">
+        <a:scrgbClr r="0" g="0" b="0"/>
+      </a:lnRef>
+      <a:fillRef idx="1">
+        <a:scrgbClr r="0" g="0" b="0"/>
+      </a:fillRef>
+      <a:effectRef idx="0">
+        <a:scrgbClr r="0" g="0" b="0"/>
+      </a:effectRef>
+      <a:fontRef idx="minor"/>
+    </dgm:style>
+  </dgm:styleLbl>
+  <dgm:styleLbl name="solidBgAcc1">
+    <dgm:scene3d>
+      <a:camera prst="orthographicFront"/>
+      <a:lightRig rig="threePt" dir="t"/>
+    </dgm:scene3d>
+    <dgm:sp3d/>
+    <dgm:txPr/>
+    <dgm:style>
+      <a:lnRef idx="2">
+        <a:scrgbClr r="0" g="0" b="0"/>
+      </a:lnRef>
+      <a:fillRef idx="1">
+        <a:scrgbClr r="0" g="0" b="0"/>
+      </a:fillRef>
+      <a:effectRef idx="0">
+        <a:scrgbClr r="0" g="0" b="0"/>
+      </a:effectRef>
+      <a:fontRef idx="minor"/>
+    </dgm:style>
+  </dgm:styleLbl>
+  <dgm:styleLbl name="fgAccFollowNode1">
+    <dgm:scene3d>
+      <a:camera prst="orthographicFront"/>
+      <a:lightRig rig="threePt" dir="t"/>
+    </dgm:scene3d>
+    <dgm:sp3d/>
+    <dgm:txPr/>
+    <dgm:style>
+      <a:lnRef idx="2">
+        <a:scrgbClr r="0" g="0" b="0"/>
+      </a:lnRef>
+      <a:fillRef idx="1">
+        <a:scrgbClr r="0" g="0" b="0"/>
+      </a:fillRef>
+      <a:effectRef idx="0">
+        <a:scrgbClr r="0" g="0" b="0"/>
+      </a:effectRef>
+      <a:fontRef idx="minor"/>
+    </dgm:style>
+  </dgm:styleLbl>
+  <dgm:styleLbl name="alignAccFollowNode1">
+    <dgm:scene3d>
+      <a:camera prst="orthographicFront"/>
+      <a:lightRig rig="threePt" dir="t"/>
+    </dgm:scene3d>
+    <dgm:sp3d/>
+    <dgm:txPr/>
+    <dgm:style>
+      <a:lnRef idx="2">
+        <a:scrgbClr r="0" g="0" b="0"/>
+      </a:lnRef>
+      <a:fillRef idx="1">
+        <a:scrgbClr r="0" g="0" b="0"/>
+      </a:fillRef>
+      <a:effectRef idx="0">
+        <a:scrgbClr r="0" g="0" b="0"/>
+      </a:effectRef>
+      <a:fontRef idx="minor"/>
+    </dgm:style>
+  </dgm:styleLbl>
+  <dgm:styleLbl name="bgAccFollowNode1">
+    <dgm:scene3d>
+      <a:camera prst="orthographicFront"/>
+      <a:lightRig rig="threePt" dir="t"/>
+    </dgm:scene3d>
+    <dgm:sp3d/>
+    <dgm:txPr/>
+    <dgm:style>
+      <a:lnRef idx="2">
+        <a:scrgbClr r="0" g="0" b="0"/>
+      </a:lnRef>
+      <a:fillRef idx="1">
+        <a:scrgbClr r="0" g="0" b="0"/>
+      </a:fillRef>
+      <a:effectRef idx="0">
+        <a:scrgbClr r="0" g="0" b="0"/>
+      </a:effectRef>
+      <a:fontRef idx="minor"/>
+    </dgm:style>
+  </dgm:styleLbl>
+  <dgm:styleLbl name="fgAcc0">
+    <dgm:scene3d>
+      <a:camera prst="orthographicFront"/>
+      <a:lightRig rig="threePt" dir="t"/>
+    </dgm:scene3d>
+    <dgm:sp3d/>
+    <dgm:txPr/>
+    <dgm:style>
+      <a:lnRef idx="2">
+        <a:scrgbClr r="0" g="0" b="0"/>
+      </a:lnRef>
+      <a:fillRef idx="1">
+        <a:scrgbClr r="0" g="0" b="0"/>
+      </a:fillRef>
+      <a:effectRef idx="0">
+        <a:scrgbClr r="0" g="0" b="0"/>
+      </a:effectRef>
+      <a:fontRef idx="minor"/>
+    </dgm:style>
+  </dgm:styleLbl>
+  <dgm:styleLbl name="fgAcc2">
+    <dgm:scene3d>
+      <a:camera prst="orthographicFront"/>
+      <a:lightRig rig="threePt" dir="t"/>
+    </dgm:scene3d>
+    <dgm:sp3d/>
+    <dgm:txPr/>
+    <dgm:style>
+      <a:lnRef idx="2">
+        <a:scrgbClr r="0" g="0" b="0"/>
+      </a:lnRef>
+      <a:fillRef idx="1">
+        <a:scrgbClr r="0" g="0" b="0"/>
+      </a:fillRef>
+      <a:effectRef idx="0">
+        <a:scrgbClr r="0" g="0" b="0"/>
+      </a:effectRef>
+      <a:fontRef idx="minor"/>
+    </dgm:style>
+  </dgm:styleLbl>
+  <dgm:styleLbl name="fgAcc3">
+    <dgm:scene3d>
+      <a:camera prst="orthographicFront"/>
+      <a:lightRig rig="threePt" dir="t"/>
+    </dgm:scene3d>
+    <dgm:sp3d/>
+    <dgm:txPr/>
+    <dgm:style>
+      <a:lnRef idx="2">
+        <a:scrgbClr r="0" g="0" b="0"/>
+      </a:lnRef>
+      <a:fillRef idx="1">
+        <a:scrgbClr r="0" g="0" b="0"/>
+      </a:fillRef>
+      <a:effectRef idx="0">
+        <a:scrgbClr r="0" g="0" b="0"/>
+      </a:effectRef>
+      <a:fontRef idx="minor"/>
+    </dgm:style>
+  </dgm:styleLbl>
+  <dgm:styleLbl name="fgAcc4">
+    <dgm:scene3d>
+      <a:camera prst="orthographicFront"/>
+      <a:lightRig rig="threePt" dir="t"/>
+    </dgm:scene3d>
+    <dgm:sp3d/>
+    <dgm:txPr/>
+    <dgm:style>
+      <a:lnRef idx="2">
+        <a:scrgbClr r="0" g="0" b="0"/>
+      </a:lnRef>
+      <a:fillRef idx="1">
+        <a:scrgbClr r="0" g="0" b="0"/>
+      </a:fillRef>
+      <a:effectRef idx="0">
+        <a:scrgbClr r="0" g="0" b="0"/>
+      </a:effectRef>
+      <a:fontRef idx="minor"/>
+    </dgm:style>
+  </dgm:styleLbl>
+  <dgm:styleLbl name="bgShp">
+    <dgm:scene3d>
+      <a:camera prst="orthographicFront"/>
+      <a:lightRig rig="threePt" dir="t"/>
+    </dgm:scene3d>
+    <dgm:sp3d/>
+    <dgm:txPr/>
+    <dgm:style>
+      <a:lnRef idx="0">
+        <a:scrgbClr r="0" g="0" b="0"/>
+      </a:lnRef>
+      <a:fillRef idx="1">
+        <a:scrgbClr r="0" g="0" b="0"/>
+      </a:fillRef>
+      <a:effectRef idx="0">
+        <a:scrgbClr r="0" g="0" b="0"/>
+      </a:effectRef>
+      <a:fontRef idx="minor"/>
+    </dgm:style>
+  </dgm:styleLbl>
+  <dgm:styleLbl name="dkBgShp">
+    <dgm:scene3d>
+      <a:camera prst="orthographicFront"/>
+      <a:lightRig rig="threePt" dir="t"/>
+    </dgm:scene3d>
+    <dgm:sp3d/>
+    <dgm:txPr/>
+    <dgm:style>
+      <a:lnRef idx="0">
+        <a:scrgbClr r="0" g="0" b="0"/>
+      </a:lnRef>
+      <a:fillRef idx="1">
+        <a:scrgbClr r="0" g="0" b="0"/>
+      </a:fillRef>
+      <a:effectRef idx="0">
+        <a:scrgbClr r="0" g="0" b="0"/>
+      </a:effectRef>
+      <a:fontRef idx="minor"/>
+    </dgm:style>
+  </dgm:styleLbl>
+  <dgm:styleLbl name="trBgShp">
+    <dgm:scene3d>
+      <a:camera prst="orthographicFront"/>
+      <a:lightRig rig="threePt" dir="t"/>
+    </dgm:scene3d>
+    <dgm:sp3d/>
+    <dgm:txPr/>
+    <dgm:style>
+      <a:lnRef idx="0">
+        <a:scrgbClr r="0" g="0" b="0"/>
+      </a:lnRef>
+      <a:fillRef idx="1">
+        <a:scrgbClr r="0" g="0" b="0"/>
+      </a:fillRef>
+      <a:effectRef idx="0">
+        <a:scrgbClr r="0" g="0" b="0"/>
+      </a:effectRef>
+      <a:fontRef idx="minor"/>
+    </dgm:style>
+  </dgm:styleLbl>
+  <dgm:styleLbl name="fgShp">
+    <dgm:scene3d>
+      <a:camera prst="orthographicFront"/>
+      <a:lightRig rig="threePt" dir="t"/>
+    </dgm:scene3d>
+    <dgm:sp3d/>
+    <dgm:txPr/>
+    <dgm:style>
+      <a:lnRef idx="2">
+        <a:scrgbClr r="0" g="0" b="0"/>
+      </a:lnRef>
+      <a:fillRef idx="1">
+        <a:scrgbClr r="0" g="0" b="0"/>
+      </a:fillRef>
+      <a:effectRef idx="0">
+        <a:scrgbClr r="0" g="0" b="0"/>
+      </a:effectRef>
+      <a:fontRef idx="minor"/>
+    </dgm:style>
+  </dgm:styleLbl>
+  <dgm:styleLbl name="revTx">
+    <dgm:scene3d>
+      <a:camera prst="orthographicFront"/>
+      <a:lightRig rig="threePt" dir="t"/>
+    </dgm:scene3d>
+    <dgm:sp3d/>
+    <dgm:txPr/>
+    <dgm:style>
+      <a:lnRef idx="0">
+        <a:scrgbClr r="0" g="0" b="0"/>
+      </a:lnRef>
+      <a:fillRef idx="0">
+        <a:scrgbClr r="0" g="0" b="0"/>
+      </a:fillRef>
+      <a:effectRef idx="0">
+        <a:scrgbClr r="0" g="0" b="0"/>
+      </a:effectRef>
+      <a:fontRef idx="minor"/>
+    </dgm:style>
+  </dgm:styleLbl>
+</dgm:styleDef>
 </file>
 
 <file path=ppt/notesMasters/notesMaster1.xml><?xml version="1.0" encoding="utf-8"?>
@@ -3791,127 +6316,6 @@
 </p:sld>
 </file>
 
-<file path=ppt/slides/slide10.xml><?xml version="1.0" encoding="utf-8"?>
-<p:sld xmlns:a="http://schemas.openxmlformats.org/drawingml/2006/main" xmlns:r="http://schemas.openxmlformats.org/officeDocument/2006/relationships" xmlns:p="http://schemas.openxmlformats.org/presentationml/2006/main">
-  <p:cSld>
-    <p:spTree>
-      <p:nvGrpSpPr>
-        <p:cNvPr id="1" name=""/>
-        <p:cNvGrpSpPr/>
-        <p:nvPr/>
-      </p:nvGrpSpPr>
-      <p:grpSpPr>
-        <a:xfrm>
-          <a:off x="0" y="0"/>
-          <a:ext cx="0" cy="0"/>
-          <a:chOff x="0" y="0"/>
-          <a:chExt cx="0" cy="0"/>
-        </a:xfrm>
-      </p:grpSpPr>
-      <p:sp>
-        <p:nvSpPr>
-          <p:cNvPr id="2" name="Título 1">
-            <a:extLst>
-              <a:ext uri="{FF2B5EF4-FFF2-40B4-BE49-F238E27FC236}">
-                <a16:creationId xmlns:a16="http://schemas.microsoft.com/office/drawing/2014/main" id="{1424B8F3-2D93-351F-C736-924D2BC1E5FE}"/>
-              </a:ext>
-            </a:extLst>
-          </p:cNvPr>
-          <p:cNvSpPr>
-            <a:spLocks noGrp="1"/>
-          </p:cNvSpPr>
-          <p:nvPr>
-            <p:ph type="title"/>
-          </p:nvPr>
-        </p:nvSpPr>
-        <p:spPr/>
-        <p:txBody>
-          <a:bodyPr/>
-          <a:lstStyle/>
-          <a:p>
-            <a:r>
-              <a:rPr lang="es-MX" dirty="0" err="1"/>
-              <a:t>Model</a:t>
-            </a:r>
-            <a:r>
-              <a:rPr lang="es-MX" dirty="0"/>
-              <a:t> </a:t>
-            </a:r>
-            <a:r>
-              <a:rPr lang="es-MX"/>
-              <a:t>Distilation</a:t>
-            </a:r>
-            <a:endParaRPr lang="es-CL"/>
-          </a:p>
-        </p:txBody>
-      </p:sp>
-      <p:sp>
-        <p:nvSpPr>
-          <p:cNvPr id="3" name="Marcador de contenido 2">
-            <a:extLst>
-              <a:ext uri="{FF2B5EF4-FFF2-40B4-BE49-F238E27FC236}">
-                <a16:creationId xmlns:a16="http://schemas.microsoft.com/office/drawing/2014/main" id="{597A8A69-B010-7B3A-6C75-69121DDD394E}"/>
-              </a:ext>
-            </a:extLst>
-          </p:cNvPr>
-          <p:cNvSpPr>
-            <a:spLocks noGrp="1"/>
-          </p:cNvSpPr>
-          <p:nvPr>
-            <p:ph idx="1"/>
-          </p:nvPr>
-        </p:nvSpPr>
-        <p:spPr/>
-        <p:txBody>
-          <a:bodyPr/>
-          <a:lstStyle/>
-          <a:p>
-            <a:endParaRPr lang="es-CL"/>
-          </a:p>
-        </p:txBody>
-      </p:sp>
-      <p:sp>
-        <p:nvSpPr>
-          <p:cNvPr id="4" name="Marcador de número de diapositiva 3">
-            <a:extLst>
-              <a:ext uri="{FF2B5EF4-FFF2-40B4-BE49-F238E27FC236}">
-                <a16:creationId xmlns:a16="http://schemas.microsoft.com/office/drawing/2014/main" id="{C305CDDF-03BC-979B-6154-58D6D4FCCB73}"/>
-              </a:ext>
-            </a:extLst>
-          </p:cNvPr>
-          <p:cNvSpPr>
-            <a:spLocks noGrp="1"/>
-          </p:cNvSpPr>
-          <p:nvPr>
-            <p:ph type="sldNum" sz="quarter" idx="12"/>
-          </p:nvPr>
-        </p:nvSpPr>
-        <p:spPr/>
-        <p:txBody>
-          <a:bodyPr/>
-          <a:lstStyle/>
-          <a:p>
-            <a:fld id="{29B47543-ED2D-461E-8250-4200DFF84A65}" type="slidenum">
-              <a:rPr lang="es-CL" smtClean="0"/>
-              <a:t>10</a:t>
-            </a:fld>
-            <a:endParaRPr lang="es-CL"/>
-          </a:p>
-        </p:txBody>
-      </p:sp>
-    </p:spTree>
-    <p:extLst>
-      <p:ext uri="{BB962C8B-B14F-4D97-AF65-F5344CB8AC3E}">
-        <p14:creationId xmlns:p14="http://schemas.microsoft.com/office/powerpoint/2010/main" val="1075242543"/>
-      </p:ext>
-    </p:extLst>
-  </p:cSld>
-  <p:clrMapOvr>
-    <a:masterClrMapping/>
-  </p:clrMapOvr>
-</p:sld>
-</file>
-
 <file path=ppt/slides/slide2.xml><?xml version="1.0" encoding="utf-8"?>
 <p:sld xmlns:a="http://schemas.openxmlformats.org/drawingml/2006/main" xmlns:r="http://schemas.openxmlformats.org/officeDocument/2006/relationships" xmlns:p="http://schemas.openxmlformats.org/presentationml/2006/main">
   <p:cSld>
@@ -3950,35 +6354,49 @@
           <a:bodyPr/>
           <a:lstStyle/>
           <a:p>
-            <a:endParaRPr lang="es-CL"/>
-          </a:p>
-        </p:txBody>
-      </p:sp>
-      <p:sp>
-        <p:nvSpPr>
-          <p:cNvPr id="3" name="Marcador de contenido 2">
+            <a:r>
+              <a:rPr lang="es-MX" dirty="0"/>
+              <a:t>Cuantización </a:t>
+            </a:r>
+            <a:r>
+              <a:rPr lang="es-MX" dirty="0" err="1"/>
+              <a:t>post-entrenamiento</a:t>
+            </a:r>
+            <a:endParaRPr lang="es-CL" dirty="0"/>
+          </a:p>
+        </p:txBody>
+      </p:sp>
+      <p:graphicFrame>
+        <p:nvGraphicFramePr>
+          <p:cNvPr id="9" name="Marcador de contenido 8">
             <a:extLst>
               <a:ext uri="{FF2B5EF4-FFF2-40B4-BE49-F238E27FC236}">
-                <a16:creationId xmlns:a16="http://schemas.microsoft.com/office/drawing/2014/main" id="{5617C6E3-69D6-0040-FCAF-7245FA45D2A2}"/>
+                <a16:creationId xmlns:a16="http://schemas.microsoft.com/office/drawing/2014/main" id="{39727CB2-874E-847D-7599-8711368EBAE0}"/>
               </a:ext>
             </a:extLst>
           </p:cNvPr>
-          <p:cNvSpPr>
-            <a:spLocks noGrp="1"/>
-          </p:cNvSpPr>
+          <p:cNvGraphicFramePr>
+            <a:graphicFrameLocks noGrp="1"/>
+          </p:cNvGraphicFramePr>
           <p:nvPr>
             <p:ph idx="1"/>
-          </p:nvPr>
-        </p:nvSpPr>
-        <p:spPr/>
-        <p:txBody>
-          <a:bodyPr/>
-          <a:lstStyle/>
-          <a:p>
-            <a:endParaRPr lang="es-CL"/>
-          </a:p>
-        </p:txBody>
-      </p:sp>
+            <p:extLst>
+              <p:ext uri="{D42A27DB-BD31-4B8C-83A1-F6EECF244321}">
+                <p14:modId xmlns:p14="http://schemas.microsoft.com/office/powerpoint/2010/main" val="2807993671"/>
+              </p:ext>
+            </p:extLst>
+          </p:nvPr>
+        </p:nvGraphicFramePr>
+        <p:xfrm>
+          <a:off x="838200" y="1825625"/>
+          <a:ext cx="10515600" cy="4351338"/>
+        </p:xfrm>
+        <a:graphic>
+          <a:graphicData uri="http://schemas.openxmlformats.org/drawingml/2006/diagram">
+            <dgm:relIds xmlns:dgm="http://schemas.openxmlformats.org/drawingml/2006/diagram" xmlns:r="http://schemas.openxmlformats.org/officeDocument/2006/relationships" r:dm="rId2" r:lo="rId3" r:qs="rId4" r:cs="rId5"/>
+          </a:graphicData>
+        </a:graphic>
+      </p:graphicFrame>
       <p:sp>
         <p:nvSpPr>
           <p:cNvPr id="4" name="Marcador de número de diapositiva 3">
@@ -4022,464 +6440,6 @@
 </file>
 
 <file path=ppt/slides/slide3.xml><?xml version="1.0" encoding="utf-8"?>
-<p:sld xmlns:a="http://schemas.openxmlformats.org/drawingml/2006/main" xmlns:r="http://schemas.openxmlformats.org/officeDocument/2006/relationships" xmlns:p="http://schemas.openxmlformats.org/presentationml/2006/main">
-  <p:cSld>
-    <p:spTree>
-      <p:nvGrpSpPr>
-        <p:cNvPr id="1" name=""/>
-        <p:cNvGrpSpPr/>
-        <p:nvPr/>
-      </p:nvGrpSpPr>
-      <p:grpSpPr>
-        <a:xfrm>
-          <a:off x="0" y="0"/>
-          <a:ext cx="0" cy="0"/>
-          <a:chOff x="0" y="0"/>
-          <a:chExt cx="0" cy="0"/>
-        </a:xfrm>
-      </p:grpSpPr>
-      <p:sp>
-        <p:nvSpPr>
-          <p:cNvPr id="2" name="Título 1">
-            <a:extLst>
-              <a:ext uri="{FF2B5EF4-FFF2-40B4-BE49-F238E27FC236}">
-                <a16:creationId xmlns:a16="http://schemas.microsoft.com/office/drawing/2014/main" id="{AE582A28-FF75-55E5-BCB9-2B312C8B0781}"/>
-              </a:ext>
-            </a:extLst>
-          </p:cNvPr>
-          <p:cNvSpPr>
-            <a:spLocks noGrp="1"/>
-          </p:cNvSpPr>
-          <p:nvPr>
-            <p:ph type="title"/>
-          </p:nvPr>
-        </p:nvSpPr>
-        <p:spPr/>
-        <p:txBody>
-          <a:bodyPr/>
-          <a:lstStyle/>
-          <a:p>
-            <a:r>
-              <a:rPr lang="es-MX" dirty="0"/>
-              <a:t>Resultado al entrenar sin ruido</a:t>
-            </a:r>
-            <a:endParaRPr lang="es-CL" dirty="0"/>
-          </a:p>
-        </p:txBody>
-      </p:sp>
-      <p:sp>
-        <p:nvSpPr>
-          <p:cNvPr id="5" name="Marcador de texto 4">
-            <a:extLst>
-              <a:ext uri="{FF2B5EF4-FFF2-40B4-BE49-F238E27FC236}">
-                <a16:creationId xmlns:a16="http://schemas.microsoft.com/office/drawing/2014/main" id="{8A9B7DB6-EEB9-CF9B-1E9B-640A9172757F}"/>
-              </a:ext>
-            </a:extLst>
-          </p:cNvPr>
-          <p:cNvSpPr>
-            <a:spLocks noGrp="1"/>
-          </p:cNvSpPr>
-          <p:nvPr>
-            <p:ph type="body" idx="1"/>
-          </p:nvPr>
-        </p:nvSpPr>
-        <p:spPr/>
-        <p:txBody>
-          <a:bodyPr/>
-          <a:lstStyle/>
-          <a:p>
-            <a:endParaRPr lang="es-CL"/>
-          </a:p>
-        </p:txBody>
-      </p:sp>
-      <p:sp>
-        <p:nvSpPr>
-          <p:cNvPr id="4" name="Marcador de número de diapositiva 3">
-            <a:extLst>
-              <a:ext uri="{FF2B5EF4-FFF2-40B4-BE49-F238E27FC236}">
-                <a16:creationId xmlns:a16="http://schemas.microsoft.com/office/drawing/2014/main" id="{DA1F4BDB-054C-7D2F-C540-5561F9F60FD4}"/>
-              </a:ext>
-            </a:extLst>
-          </p:cNvPr>
-          <p:cNvSpPr>
-            <a:spLocks noGrp="1"/>
-          </p:cNvSpPr>
-          <p:nvPr>
-            <p:ph type="sldNum" sz="quarter" idx="12"/>
-          </p:nvPr>
-        </p:nvSpPr>
-        <p:spPr/>
-        <p:txBody>
-          <a:bodyPr/>
-          <a:lstStyle/>
-          <a:p>
-            <a:fld id="{29B47543-ED2D-461E-8250-4200DFF84A65}" type="slidenum">
-              <a:rPr lang="es-CL" smtClean="0"/>
-              <a:t>3</a:t>
-            </a:fld>
-            <a:endParaRPr lang="es-CL"/>
-          </a:p>
-        </p:txBody>
-      </p:sp>
-    </p:spTree>
-    <p:extLst>
-      <p:ext uri="{BB962C8B-B14F-4D97-AF65-F5344CB8AC3E}">
-        <p14:creationId xmlns:p14="http://schemas.microsoft.com/office/powerpoint/2010/main" val="4251920358"/>
-      </p:ext>
-    </p:extLst>
-  </p:cSld>
-  <p:clrMapOvr>
-    <a:masterClrMapping/>
-  </p:clrMapOvr>
-</p:sld>
-</file>
-
-<file path=ppt/slides/slide4.xml><?xml version="1.0" encoding="utf-8"?>
-<p:sld xmlns:a="http://schemas.openxmlformats.org/drawingml/2006/main" xmlns:r="http://schemas.openxmlformats.org/officeDocument/2006/relationships" xmlns:p="http://schemas.openxmlformats.org/presentationml/2006/main">
-  <p:cSld>
-    <p:spTree>
-      <p:nvGrpSpPr>
-        <p:cNvPr id="1" name=""/>
-        <p:cNvGrpSpPr/>
-        <p:nvPr/>
-      </p:nvGrpSpPr>
-      <p:grpSpPr>
-        <a:xfrm>
-          <a:off x="0" y="0"/>
-          <a:ext cx="0" cy="0"/>
-          <a:chOff x="0" y="0"/>
-          <a:chExt cx="0" cy="0"/>
-        </a:xfrm>
-      </p:grpSpPr>
-      <p:sp>
-        <p:nvSpPr>
-          <p:cNvPr id="2" name="Título 1">
-            <a:extLst>
-              <a:ext uri="{FF2B5EF4-FFF2-40B4-BE49-F238E27FC236}">
-                <a16:creationId xmlns:a16="http://schemas.microsoft.com/office/drawing/2014/main" id="{903BA9FC-A902-4BA5-A244-275746FA148F}"/>
-              </a:ext>
-            </a:extLst>
-          </p:cNvPr>
-          <p:cNvSpPr>
-            <a:spLocks noGrp="1"/>
-          </p:cNvSpPr>
-          <p:nvPr>
-            <p:ph type="title"/>
-          </p:nvPr>
-        </p:nvSpPr>
-        <p:spPr/>
-        <p:txBody>
-          <a:bodyPr/>
-          <a:lstStyle/>
-          <a:p>
-            <a:r>
-              <a:rPr lang="es-MX" dirty="0"/>
-              <a:t>float32 en PC</a:t>
-            </a:r>
-            <a:endParaRPr lang="es-CL" dirty="0"/>
-          </a:p>
-        </p:txBody>
-      </p:sp>
-      <p:sp>
-        <p:nvSpPr>
-          <p:cNvPr id="3" name="Marcador de contenido 2">
-            <a:extLst>
-              <a:ext uri="{FF2B5EF4-FFF2-40B4-BE49-F238E27FC236}">
-                <a16:creationId xmlns:a16="http://schemas.microsoft.com/office/drawing/2014/main" id="{6EBB79B5-42DE-B21D-2137-7C894526F7D2}"/>
-              </a:ext>
-            </a:extLst>
-          </p:cNvPr>
-          <p:cNvSpPr>
-            <a:spLocks noGrp="1"/>
-          </p:cNvSpPr>
-          <p:nvPr>
-            <p:ph idx="1"/>
-          </p:nvPr>
-        </p:nvSpPr>
-        <p:spPr/>
-        <p:txBody>
-          <a:bodyPr/>
-          <a:lstStyle/>
-          <a:p>
-            <a:endParaRPr lang="es-CL"/>
-          </a:p>
-        </p:txBody>
-      </p:sp>
-      <p:sp>
-        <p:nvSpPr>
-          <p:cNvPr id="4" name="Marcador de número de diapositiva 3">
-            <a:extLst>
-              <a:ext uri="{FF2B5EF4-FFF2-40B4-BE49-F238E27FC236}">
-                <a16:creationId xmlns:a16="http://schemas.microsoft.com/office/drawing/2014/main" id="{EFA27B7E-28EA-3742-F80E-E5204FB3F52C}"/>
-              </a:ext>
-            </a:extLst>
-          </p:cNvPr>
-          <p:cNvSpPr>
-            <a:spLocks noGrp="1"/>
-          </p:cNvSpPr>
-          <p:nvPr>
-            <p:ph type="sldNum" sz="quarter" idx="12"/>
-          </p:nvPr>
-        </p:nvSpPr>
-        <p:spPr/>
-        <p:txBody>
-          <a:bodyPr/>
-          <a:lstStyle/>
-          <a:p>
-            <a:fld id="{29B47543-ED2D-461E-8250-4200DFF84A65}" type="slidenum">
-              <a:rPr lang="es-CL" smtClean="0"/>
-              <a:t>4</a:t>
-            </a:fld>
-            <a:endParaRPr lang="es-CL"/>
-          </a:p>
-        </p:txBody>
-      </p:sp>
-    </p:spTree>
-    <p:extLst>
-      <p:ext uri="{BB962C8B-B14F-4D97-AF65-F5344CB8AC3E}">
-        <p14:creationId xmlns:p14="http://schemas.microsoft.com/office/powerpoint/2010/main" val="2648280899"/>
-      </p:ext>
-    </p:extLst>
-  </p:cSld>
-  <p:clrMapOvr>
-    <a:masterClrMapping/>
-  </p:clrMapOvr>
-</p:sld>
-</file>
-
-<file path=ppt/slides/slide5.xml><?xml version="1.0" encoding="utf-8"?>
-<p:sld xmlns:a="http://schemas.openxmlformats.org/drawingml/2006/main" xmlns:r="http://schemas.openxmlformats.org/officeDocument/2006/relationships" xmlns:p="http://schemas.openxmlformats.org/presentationml/2006/main">
-  <p:cSld>
-    <p:spTree>
-      <p:nvGrpSpPr>
-        <p:cNvPr id="1" name="">
-          <a:extLst>
-            <a:ext uri="{FF2B5EF4-FFF2-40B4-BE49-F238E27FC236}">
-              <a16:creationId xmlns:a16="http://schemas.microsoft.com/office/drawing/2014/main" id="{99ED9CB2-54AF-4878-43BB-A41327B7296E}"/>
-            </a:ext>
-          </a:extLst>
-        </p:cNvPr>
-        <p:cNvGrpSpPr/>
-        <p:nvPr/>
-      </p:nvGrpSpPr>
-      <p:grpSpPr>
-        <a:xfrm>
-          <a:off x="0" y="0"/>
-          <a:ext cx="0" cy="0"/>
-          <a:chOff x="0" y="0"/>
-          <a:chExt cx="0" cy="0"/>
-        </a:xfrm>
-      </p:grpSpPr>
-      <p:sp>
-        <p:nvSpPr>
-          <p:cNvPr id="2" name="Título 1">
-            <a:extLst>
-              <a:ext uri="{FF2B5EF4-FFF2-40B4-BE49-F238E27FC236}">
-                <a16:creationId xmlns:a16="http://schemas.microsoft.com/office/drawing/2014/main" id="{A6691D38-CC9A-8910-52DA-22DCB6495424}"/>
-              </a:ext>
-            </a:extLst>
-          </p:cNvPr>
-          <p:cNvSpPr>
-            <a:spLocks noGrp="1"/>
-          </p:cNvSpPr>
-          <p:nvPr>
-            <p:ph type="title"/>
-          </p:nvPr>
-        </p:nvSpPr>
-        <p:spPr/>
-        <p:txBody>
-          <a:bodyPr/>
-          <a:lstStyle/>
-          <a:p>
-            <a:r>
-              <a:rPr lang="es-MX" dirty="0"/>
-              <a:t>float32 en STM32</a:t>
-            </a:r>
-            <a:endParaRPr lang="es-CL" dirty="0"/>
-          </a:p>
-        </p:txBody>
-      </p:sp>
-      <p:sp>
-        <p:nvSpPr>
-          <p:cNvPr id="3" name="Marcador de contenido 2">
-            <a:extLst>
-              <a:ext uri="{FF2B5EF4-FFF2-40B4-BE49-F238E27FC236}">
-                <a16:creationId xmlns:a16="http://schemas.microsoft.com/office/drawing/2014/main" id="{A5FA41D2-F20F-9827-4051-E444939E73BA}"/>
-              </a:ext>
-            </a:extLst>
-          </p:cNvPr>
-          <p:cNvSpPr>
-            <a:spLocks noGrp="1"/>
-          </p:cNvSpPr>
-          <p:nvPr>
-            <p:ph idx="1"/>
-          </p:nvPr>
-        </p:nvSpPr>
-        <p:spPr/>
-        <p:txBody>
-          <a:bodyPr/>
-          <a:lstStyle/>
-          <a:p>
-            <a:endParaRPr lang="es-CL"/>
-          </a:p>
-        </p:txBody>
-      </p:sp>
-      <p:sp>
-        <p:nvSpPr>
-          <p:cNvPr id="4" name="Marcador de número de diapositiva 3">
-            <a:extLst>
-              <a:ext uri="{FF2B5EF4-FFF2-40B4-BE49-F238E27FC236}">
-                <a16:creationId xmlns:a16="http://schemas.microsoft.com/office/drawing/2014/main" id="{2D1A8516-BB21-0D1F-5D91-2FEF3016D961}"/>
-              </a:ext>
-            </a:extLst>
-          </p:cNvPr>
-          <p:cNvSpPr>
-            <a:spLocks noGrp="1"/>
-          </p:cNvSpPr>
-          <p:nvPr>
-            <p:ph type="sldNum" sz="quarter" idx="12"/>
-          </p:nvPr>
-        </p:nvSpPr>
-        <p:spPr/>
-        <p:txBody>
-          <a:bodyPr/>
-          <a:lstStyle/>
-          <a:p>
-            <a:fld id="{29B47543-ED2D-461E-8250-4200DFF84A65}" type="slidenum">
-              <a:rPr lang="es-CL" smtClean="0"/>
-              <a:t>5</a:t>
-            </a:fld>
-            <a:endParaRPr lang="es-CL"/>
-          </a:p>
-        </p:txBody>
-      </p:sp>
-    </p:spTree>
-    <p:extLst>
-      <p:ext uri="{BB962C8B-B14F-4D97-AF65-F5344CB8AC3E}">
-        <p14:creationId xmlns:p14="http://schemas.microsoft.com/office/powerpoint/2010/main" val="4096196009"/>
-      </p:ext>
-    </p:extLst>
-  </p:cSld>
-  <p:clrMapOvr>
-    <a:masterClrMapping/>
-  </p:clrMapOvr>
-</p:sld>
-</file>
-
-<file path=ppt/slides/slide6.xml><?xml version="1.0" encoding="utf-8"?>
-<p:sld xmlns:a="http://schemas.openxmlformats.org/drawingml/2006/main" xmlns:r="http://schemas.openxmlformats.org/officeDocument/2006/relationships" xmlns:p="http://schemas.openxmlformats.org/presentationml/2006/main">
-  <p:cSld>
-    <p:spTree>
-      <p:nvGrpSpPr>
-        <p:cNvPr id="1" name=""/>
-        <p:cNvGrpSpPr/>
-        <p:nvPr/>
-      </p:nvGrpSpPr>
-      <p:grpSpPr>
-        <a:xfrm>
-          <a:off x="0" y="0"/>
-          <a:ext cx="0" cy="0"/>
-          <a:chOff x="0" y="0"/>
-          <a:chExt cx="0" cy="0"/>
-        </a:xfrm>
-      </p:grpSpPr>
-      <p:sp>
-        <p:nvSpPr>
-          <p:cNvPr id="2" name="Título 1">
-            <a:extLst>
-              <a:ext uri="{FF2B5EF4-FFF2-40B4-BE49-F238E27FC236}">
-                <a16:creationId xmlns:a16="http://schemas.microsoft.com/office/drawing/2014/main" id="{1206ACDF-0925-C4A7-B0C1-C871BC037D33}"/>
-              </a:ext>
-            </a:extLst>
-          </p:cNvPr>
-          <p:cNvSpPr>
-            <a:spLocks noGrp="1"/>
-          </p:cNvSpPr>
-          <p:nvPr>
-            <p:ph type="title"/>
-          </p:nvPr>
-        </p:nvSpPr>
-        <p:spPr/>
-        <p:txBody>
-          <a:bodyPr/>
-          <a:lstStyle/>
-          <a:p>
-            <a:r>
-              <a:rPr lang="es-MX" dirty="0"/>
-              <a:t>int8 en PC</a:t>
-            </a:r>
-            <a:endParaRPr lang="es-CL" dirty="0"/>
-          </a:p>
-        </p:txBody>
-      </p:sp>
-      <p:sp>
-        <p:nvSpPr>
-          <p:cNvPr id="3" name="Marcador de contenido 2">
-            <a:extLst>
-              <a:ext uri="{FF2B5EF4-FFF2-40B4-BE49-F238E27FC236}">
-                <a16:creationId xmlns:a16="http://schemas.microsoft.com/office/drawing/2014/main" id="{F69B6EC8-BF84-EF68-BBBE-15D8CFB8D2A6}"/>
-              </a:ext>
-            </a:extLst>
-          </p:cNvPr>
-          <p:cNvSpPr>
-            <a:spLocks noGrp="1"/>
-          </p:cNvSpPr>
-          <p:nvPr>
-            <p:ph idx="1"/>
-          </p:nvPr>
-        </p:nvSpPr>
-        <p:spPr/>
-        <p:txBody>
-          <a:bodyPr/>
-          <a:lstStyle/>
-          <a:p>
-            <a:endParaRPr lang="es-CL"/>
-          </a:p>
-        </p:txBody>
-      </p:sp>
-      <p:sp>
-        <p:nvSpPr>
-          <p:cNvPr id="4" name="Marcador de número de diapositiva 3">
-            <a:extLst>
-              <a:ext uri="{FF2B5EF4-FFF2-40B4-BE49-F238E27FC236}">
-                <a16:creationId xmlns:a16="http://schemas.microsoft.com/office/drawing/2014/main" id="{33900F41-E230-475B-72B0-B16817D2D7B3}"/>
-              </a:ext>
-            </a:extLst>
-          </p:cNvPr>
-          <p:cNvSpPr>
-            <a:spLocks noGrp="1"/>
-          </p:cNvSpPr>
-          <p:nvPr>
-            <p:ph type="sldNum" sz="quarter" idx="12"/>
-          </p:nvPr>
-        </p:nvSpPr>
-        <p:spPr/>
-        <p:txBody>
-          <a:bodyPr/>
-          <a:lstStyle/>
-          <a:p>
-            <a:fld id="{29B47543-ED2D-461E-8250-4200DFF84A65}" type="slidenum">
-              <a:rPr lang="es-CL" smtClean="0"/>
-              <a:t>6</a:t>
-            </a:fld>
-            <a:endParaRPr lang="es-CL"/>
-          </a:p>
-        </p:txBody>
-      </p:sp>
-    </p:spTree>
-    <p:extLst>
-      <p:ext uri="{BB962C8B-B14F-4D97-AF65-F5344CB8AC3E}">
-        <p14:creationId xmlns:p14="http://schemas.microsoft.com/office/powerpoint/2010/main" val="3374836012"/>
-      </p:ext>
-    </p:extLst>
-  </p:cSld>
-  <p:clrMapOvr>
-    <a:masterClrMapping/>
-  </p:clrMapOvr>
-</p:sld>
-</file>
-
-<file path=ppt/slides/slide7.xml><?xml version="1.0" encoding="utf-8"?>
 <p:sld xmlns:a="http://schemas.openxmlformats.org/drawingml/2006/main" xmlns:r="http://schemas.openxmlformats.org/officeDocument/2006/relationships" xmlns:p="http://schemas.openxmlformats.org/presentationml/2006/main">
   <p:cSld>
     <p:spTree>
@@ -4554,7 +6514,7 @@
           <a:p>
             <a:fld id="{29B47543-ED2D-461E-8250-4200DFF84A65}" type="slidenum">
               <a:rPr lang="es-CL" smtClean="0"/>
-              <a:t>7</a:t>
+              <a:t>3</a:t>
             </a:fld>
             <a:endParaRPr lang="es-CL"/>
           </a:p>
@@ -4605,7 +6565,7 @@
 </p:sld>
 </file>
 
-<file path=ppt/slides/slide8.xml><?xml version="1.0" encoding="utf-8"?>
+<file path=ppt/slides/slide4.xml><?xml version="1.0" encoding="utf-8"?>
 <p:sld xmlns:a="http://schemas.openxmlformats.org/drawingml/2006/main" xmlns:r="http://schemas.openxmlformats.org/officeDocument/2006/relationships" xmlns:p="http://schemas.openxmlformats.org/presentationml/2006/main">
   <p:cSld>
     <p:spTree>
@@ -4627,7 +6587,7 @@
           <p:cNvPr id="2" name="Título 1">
             <a:extLst>
               <a:ext uri="{FF2B5EF4-FFF2-40B4-BE49-F238E27FC236}">
-                <a16:creationId xmlns:a16="http://schemas.microsoft.com/office/drawing/2014/main" id="{71B8BDC7-5C46-83B1-B368-D72399A4E928}"/>
+                <a16:creationId xmlns:a16="http://schemas.microsoft.com/office/drawing/2014/main" id="{009E83A4-82D2-B75B-49A9-3B50504B977F}"/>
               </a:ext>
             </a:extLst>
           </p:cNvPr>
@@ -4645,18 +6605,21 @@
           <a:p>
             <a:r>
               <a:rPr lang="es-MX" dirty="0"/>
-              <a:t>Comparación entre todas</a:t>
-            </a:r>
+              <a:t>Int8 vs Float32</a:t>
+            </a:r>
+            <a:br>
+              <a:rPr lang="es-MX" dirty="0"/>
+            </a:br>
             <a:endParaRPr lang="es-CL" dirty="0"/>
           </a:p>
         </p:txBody>
       </p:sp>
       <p:sp>
         <p:nvSpPr>
-          <p:cNvPr id="3" name="Marcador de contenido 2">
+          <p:cNvPr id="4" name="Marcador de número de diapositiva 3">
             <a:extLst>
               <a:ext uri="{FF2B5EF4-FFF2-40B4-BE49-F238E27FC236}">
-                <a16:creationId xmlns:a16="http://schemas.microsoft.com/office/drawing/2014/main" id="{4876636F-CD8A-47BC-E006-4C7280B760AA}"/>
+                <a16:creationId xmlns:a16="http://schemas.microsoft.com/office/drawing/2014/main" id="{D474CA58-D465-2352-0482-03D7391E9707}"/>
               </a:ext>
             </a:extLst>
           </p:cNvPr>
@@ -4664,7 +6627,7 @@
             <a:spLocks noGrp="1"/>
           </p:cNvSpPr>
           <p:nvPr>
-            <p:ph idx="1"/>
+            <p:ph type="sldNum" sz="quarter" idx="12"/>
           </p:nvPr>
         </p:nvSpPr>
         <p:spPr/>
@@ -4672,43 +6635,79 @@
           <a:bodyPr/>
           <a:lstStyle/>
           <a:p>
+            <a:fld id="{29B47543-ED2D-461E-8250-4200DFF84A65}" type="slidenum">
+              <a:rPr lang="es-CL" smtClean="0"/>
+              <a:t>4</a:t>
+            </a:fld>
             <a:endParaRPr lang="es-CL"/>
           </a:p>
         </p:txBody>
       </p:sp>
-      <p:sp>
-        <p:nvSpPr>
-          <p:cNvPr id="4" name="Marcador de número de diapositiva 3">
+      <p:pic>
+        <p:nvPicPr>
+          <p:cNvPr id="3" name="Marcador de contenido 5">
             <a:extLst>
               <a:ext uri="{FF2B5EF4-FFF2-40B4-BE49-F238E27FC236}">
-                <a16:creationId xmlns:a16="http://schemas.microsoft.com/office/drawing/2014/main" id="{D2A16E88-BE1C-3033-6AD2-FF686D1F74AE}"/>
+                <a16:creationId xmlns:a16="http://schemas.microsoft.com/office/drawing/2014/main" id="{C0FFA249-0D73-F84D-228B-10026BF04672}"/>
               </a:ext>
             </a:extLst>
           </p:cNvPr>
-          <p:cNvSpPr>
-            <a:spLocks noGrp="1"/>
-          </p:cNvSpPr>
-          <p:nvPr>
-            <p:ph type="sldNum" sz="quarter" idx="12"/>
-          </p:nvPr>
-        </p:nvSpPr>
-        <p:spPr/>
-        <p:txBody>
-          <a:bodyPr/>
-          <a:lstStyle/>
-          <a:p>
-            <a:fld id="{29B47543-ED2D-461E-8250-4200DFF84A65}" type="slidenum">
-              <a:rPr lang="es-CL" smtClean="0"/>
-              <a:t>8</a:t>
-            </a:fld>
-            <a:endParaRPr lang="es-CL"/>
-          </a:p>
-        </p:txBody>
-      </p:sp>
+          <p:cNvPicPr>
+            <a:picLocks noChangeAspect="1"/>
+          </p:cNvPicPr>
+          <p:nvPr/>
+        </p:nvPicPr>
+        <p:blipFill>
+          <a:blip r:embed="rId2"/>
+          <a:srcRect r="41840"/>
+          <a:stretch>
+            <a:fillRect/>
+          </a:stretch>
+        </p:blipFill>
+        <p:spPr>
+          <a:xfrm>
+            <a:off x="656058" y="1819780"/>
+            <a:ext cx="5174428" cy="4165480"/>
+          </a:xfrm>
+          <a:prstGeom prst="rect">
+            <a:avLst/>
+          </a:prstGeom>
+        </p:spPr>
+      </p:pic>
+      <p:pic>
+        <p:nvPicPr>
+          <p:cNvPr id="8" name="Marcador de contenido 5">
+            <a:extLst>
+              <a:ext uri="{FF2B5EF4-FFF2-40B4-BE49-F238E27FC236}">
+                <a16:creationId xmlns:a16="http://schemas.microsoft.com/office/drawing/2014/main" id="{86A49DF0-8233-7499-15BE-BBD881472593}"/>
+              </a:ext>
+            </a:extLst>
+          </p:cNvPr>
+          <p:cNvPicPr>
+            <a:picLocks noGrp="1" noChangeAspect="1"/>
+          </p:cNvPicPr>
+          <p:nvPr>
+            <p:ph idx="1"/>
+          </p:nvPr>
+        </p:nvPicPr>
+        <p:blipFill>
+          <a:blip r:embed="rId3"/>
+          <a:srcRect r="43007"/>
+          <a:stretch>
+            <a:fillRect/>
+          </a:stretch>
+        </p:blipFill>
+        <p:spPr>
+          <a:xfrm>
+            <a:off x="6361515" y="1819347"/>
+            <a:ext cx="5070589" cy="4165913"/>
+          </a:xfrm>
+        </p:spPr>
+      </p:pic>
     </p:spTree>
     <p:extLst>
       <p:ext uri="{BB962C8B-B14F-4D97-AF65-F5344CB8AC3E}">
-        <p14:creationId xmlns:p14="http://schemas.microsoft.com/office/powerpoint/2010/main" val="1838463700"/>
+        <p14:creationId xmlns:p14="http://schemas.microsoft.com/office/powerpoint/2010/main" val="336731501"/>
       </p:ext>
     </p:extLst>
   </p:cSld>
@@ -4718,7 +6717,324 @@
 </p:sld>
 </file>
 
-<file path=ppt/slides/slide9.xml><?xml version="1.0" encoding="utf-8"?>
+<file path=ppt/slides/slide5.xml><?xml version="1.0" encoding="utf-8"?>
+<p:sld xmlns:a="http://schemas.openxmlformats.org/drawingml/2006/main" xmlns:r="http://schemas.openxmlformats.org/officeDocument/2006/relationships" xmlns:p="http://schemas.openxmlformats.org/presentationml/2006/main">
+  <p:cSld>
+    <p:spTree>
+      <p:nvGrpSpPr>
+        <p:cNvPr id="1" name="">
+          <a:extLst>
+            <a:ext uri="{FF2B5EF4-FFF2-40B4-BE49-F238E27FC236}">
+              <a16:creationId xmlns:a16="http://schemas.microsoft.com/office/drawing/2014/main" id="{0E9B7512-6A40-C6D1-71A6-B3B92DA020C8}"/>
+            </a:ext>
+          </a:extLst>
+        </p:cNvPr>
+        <p:cNvGrpSpPr/>
+        <p:nvPr/>
+      </p:nvGrpSpPr>
+      <p:grpSpPr>
+        <a:xfrm>
+          <a:off x="0" y="0"/>
+          <a:ext cx="0" cy="0"/>
+          <a:chOff x="0" y="0"/>
+          <a:chExt cx="0" cy="0"/>
+        </a:xfrm>
+      </p:grpSpPr>
+      <p:sp>
+        <p:nvSpPr>
+          <p:cNvPr id="2" name="Título 1">
+            <a:extLst>
+              <a:ext uri="{FF2B5EF4-FFF2-40B4-BE49-F238E27FC236}">
+                <a16:creationId xmlns:a16="http://schemas.microsoft.com/office/drawing/2014/main" id="{ED09BDEC-6D02-3EEB-2E43-7AB95F058C3F}"/>
+              </a:ext>
+            </a:extLst>
+          </p:cNvPr>
+          <p:cNvSpPr>
+            <a:spLocks noGrp="1"/>
+          </p:cNvSpPr>
+          <p:nvPr>
+            <p:ph type="title"/>
+          </p:nvPr>
+        </p:nvSpPr>
+        <p:spPr/>
+        <p:txBody>
+          <a:bodyPr/>
+          <a:lstStyle/>
+          <a:p>
+            <a:r>
+              <a:rPr lang="es-MX" dirty="0"/>
+              <a:t>Información del modelo cuantizado</a:t>
+            </a:r>
+            <a:endParaRPr lang="es-CL" dirty="0"/>
+          </a:p>
+        </p:txBody>
+      </p:sp>
+      <mc:AlternateContent xmlns:mc="http://schemas.openxmlformats.org/markup-compatibility/2006" xmlns:a14="http://schemas.microsoft.com/office/drawing/2010/main">
+        <mc:Choice Requires="a14">
+          <p:sp>
+            <p:nvSpPr>
+              <p:cNvPr id="5" name="Marcador de contenido 4">
+                <a:extLst>
+                  <a:ext uri="{FF2B5EF4-FFF2-40B4-BE49-F238E27FC236}">
+                    <a16:creationId xmlns:a16="http://schemas.microsoft.com/office/drawing/2014/main" id="{AB2045A2-048B-21E6-C6AA-07080F19B593}"/>
+                  </a:ext>
+                </a:extLst>
+              </p:cNvPr>
+              <p:cNvSpPr>
+                <a:spLocks noGrp="1"/>
+              </p:cNvSpPr>
+              <p:nvPr>
+                <p:ph idx="1"/>
+              </p:nvPr>
+            </p:nvSpPr>
+            <p:spPr/>
+            <p:txBody>
+              <a:bodyPr/>
+              <a:lstStyle/>
+              <a:p>
+                <a:pPr marL="0" indent="0">
+                  <a:buNone/>
+                </a:pPr>
+                <a:endParaRPr lang="es-MX" b="0" i="1" dirty="0">
+                  <a:latin typeface="Cambria Math" panose="02040503050406030204" pitchFamily="18" charset="0"/>
+                </a:endParaRPr>
+              </a:p>
+              <a:p>
+                <a:pPr marL="0" indent="0">
+                  <a:buNone/>
+                </a:pPr>
+                <a14:m>
+                  <m:oMathPara xmlns:m="http://schemas.openxmlformats.org/officeDocument/2006/math">
+                    <m:oMathParaPr>
+                      <m:jc m:val="centerGroup"/>
+                    </m:oMathParaPr>
+                    <m:oMath xmlns:m="http://schemas.openxmlformats.org/officeDocument/2006/math">
+                      <m:r>
+                        <a:rPr lang="es-MX" b="0" i="1" smtClean="0">
+                          <a:latin typeface="Cambria Math" panose="02040503050406030204" pitchFamily="18" charset="0"/>
+                        </a:rPr>
+                        <m:t>𝐶𝑢𝑎𝑛𝑡𝑖𝑧𝑎𝑑𝑜</m:t>
+                      </m:r>
+                      <m:r>
+                        <a:rPr lang="es-MX" b="0" i="1" smtClean="0">
+                          <a:latin typeface="Cambria Math" panose="02040503050406030204" pitchFamily="18" charset="0"/>
+                        </a:rPr>
+                        <m:t>=</m:t>
+                      </m:r>
+                      <m:r>
+                        <a:rPr lang="es-MX" b="0" i="1" smtClean="0">
+                          <a:latin typeface="Cambria Math" panose="02040503050406030204" pitchFamily="18" charset="0"/>
+                        </a:rPr>
+                        <m:t>𝑟𝑜𝑢𝑛𝑑</m:t>
+                      </m:r>
+                      <m:d>
+                        <m:dPr>
+                          <m:ctrlPr>
+                            <a:rPr lang="es-MX" b="0" i="1" smtClean="0">
+                              <a:latin typeface="Cambria Math" panose="02040503050406030204" pitchFamily="18" charset="0"/>
+                            </a:rPr>
+                          </m:ctrlPr>
+                        </m:dPr>
+                        <m:e>
+                          <m:r>
+                            <a:rPr lang="es-MX" b="0" i="1" smtClean="0">
+                              <a:latin typeface="Cambria Math" panose="02040503050406030204" pitchFamily="18" charset="0"/>
+                            </a:rPr>
+                            <m:t>𝑅𝑒𝑎𝑙</m:t>
+                          </m:r>
+                          <m:r>
+                            <a:rPr lang="es-MX" b="0" i="1" smtClean="0">
+                              <a:latin typeface="Cambria Math" panose="02040503050406030204" pitchFamily="18" charset="0"/>
+                            </a:rPr>
+                            <m:t>/</m:t>
+                          </m:r>
+                          <m:r>
+                            <a:rPr lang="es-MX" b="0" i="1" smtClean="0">
+                              <a:latin typeface="Cambria Math" panose="02040503050406030204" pitchFamily="18" charset="0"/>
+                            </a:rPr>
+                            <m:t>𝐸𝑠𝑐𝑎𝑙𝑎</m:t>
+                          </m:r>
+                        </m:e>
+                      </m:d>
+                      <m:r>
+                        <a:rPr lang="es-MX" b="0" i="1" smtClean="0">
+                          <a:latin typeface="Cambria Math" panose="02040503050406030204" pitchFamily="18" charset="0"/>
+                        </a:rPr>
+                        <m:t>+</m:t>
+                      </m:r>
+                      <m:r>
+                        <a:rPr lang="es-MX" b="0" i="1" smtClean="0">
+                          <a:latin typeface="Cambria Math" panose="02040503050406030204" pitchFamily="18" charset="0"/>
+                        </a:rPr>
+                        <m:t>𝐶𝑒𝑟𝑜</m:t>
+                      </m:r>
+                    </m:oMath>
+                  </m:oMathPara>
+                </a14:m>
+                <a:endParaRPr lang="es-MX" b="0" dirty="0"/>
+              </a:p>
+              <a:p>
+                <a:pPr marL="0" indent="0">
+                  <a:buNone/>
+                </a:pPr>
+                <a:endParaRPr lang="es-MX" b="0" i="1" dirty="0">
+                  <a:latin typeface="Cambria Math" panose="02040503050406030204" pitchFamily="18" charset="0"/>
+                </a:endParaRPr>
+              </a:p>
+              <a:p>
+                <a:pPr marL="0" indent="0">
+                  <a:buNone/>
+                </a:pPr>
+                <a14:m>
+                  <m:oMathPara xmlns:m="http://schemas.openxmlformats.org/officeDocument/2006/math">
+                    <m:oMathParaPr>
+                      <m:jc m:val="centerGroup"/>
+                    </m:oMathParaPr>
+                    <m:oMath xmlns:m="http://schemas.openxmlformats.org/officeDocument/2006/math">
+                      <m:r>
+                        <a:rPr lang="es-MX" b="0" i="1" smtClean="0">
+                          <a:latin typeface="Cambria Math" panose="02040503050406030204" pitchFamily="18" charset="0"/>
+                        </a:rPr>
+                        <m:t>𝑅𝑒𝑎𝑙</m:t>
+                      </m:r>
+                      <m:r>
+                        <a:rPr lang="es-MX" b="0" i="1" smtClean="0">
+                          <a:latin typeface="Cambria Math" panose="02040503050406030204" pitchFamily="18" charset="0"/>
+                        </a:rPr>
+                        <m:t>=</m:t>
+                      </m:r>
+                      <m:d>
+                        <m:dPr>
+                          <m:ctrlPr>
+                            <a:rPr lang="es-MX" b="0" i="1" smtClean="0">
+                              <a:latin typeface="Cambria Math" panose="02040503050406030204" pitchFamily="18" charset="0"/>
+                            </a:rPr>
+                          </m:ctrlPr>
+                        </m:dPr>
+                        <m:e>
+                          <m:r>
+                            <a:rPr lang="es-MX" b="0" i="1" smtClean="0">
+                              <a:latin typeface="Cambria Math" panose="02040503050406030204" pitchFamily="18" charset="0"/>
+                            </a:rPr>
+                            <m:t>𝐶𝑢𝑎𝑛𝑡𝑖𝑧𝑎𝑑𝑜</m:t>
+                          </m:r>
+                          <m:r>
+                            <a:rPr lang="es-MX" b="0" i="1" smtClean="0">
+                              <a:latin typeface="Cambria Math" panose="02040503050406030204" pitchFamily="18" charset="0"/>
+                            </a:rPr>
+                            <m:t> −</m:t>
+                          </m:r>
+                          <m:r>
+                            <a:rPr lang="es-MX" b="0" i="1" smtClean="0">
+                              <a:latin typeface="Cambria Math" panose="02040503050406030204" pitchFamily="18" charset="0"/>
+                            </a:rPr>
+                            <m:t>𝐶𝑒𝑟𝑜</m:t>
+                          </m:r>
+                        </m:e>
+                      </m:d>
+                      <m:r>
+                        <a:rPr lang="es-MX" b="0" i="1" smtClean="0">
+                          <a:latin typeface="Cambria Math" panose="02040503050406030204" pitchFamily="18" charset="0"/>
+                        </a:rPr>
+                        <m:t>×</m:t>
+                      </m:r>
+                      <m:r>
+                        <a:rPr lang="es-MX" b="0" i="1" smtClean="0">
+                          <a:latin typeface="Cambria Math" panose="02040503050406030204" pitchFamily="18" charset="0"/>
+                        </a:rPr>
+                        <m:t>𝐸𝑠𝑐𝑎𝑙𝑎</m:t>
+                      </m:r>
+                    </m:oMath>
+                  </m:oMathPara>
+                </a14:m>
+                <a:endParaRPr lang="es-CL" dirty="0"/>
+              </a:p>
+            </p:txBody>
+          </p:sp>
+        </mc:Choice>
+        <mc:Fallback xmlns="">
+          <p:sp>
+            <p:nvSpPr>
+              <p:cNvPr id="5" name="Marcador de contenido 4">
+                <a:extLst>
+                  <a:ext uri="{FF2B5EF4-FFF2-40B4-BE49-F238E27FC236}">
+                    <a16:creationId xmlns:a16="http://schemas.microsoft.com/office/drawing/2014/main" id="{AB2045A2-048B-21E6-C6AA-07080F19B593}"/>
+                  </a:ext>
+                </a:extLst>
+              </p:cNvPr>
+              <p:cNvSpPr>
+                <a:spLocks noGrp="1" noRot="1" noChangeAspect="1" noMove="1" noResize="1" noEditPoints="1" noAdjustHandles="1" noChangeArrowheads="1" noChangeShapeType="1" noTextEdit="1"/>
+              </p:cNvSpPr>
+              <p:nvPr>
+                <p:ph idx="1"/>
+              </p:nvPr>
+            </p:nvSpPr>
+            <p:spPr>
+              <a:blipFill>
+                <a:blip r:embed="rId2"/>
+                <a:stretch>
+                  <a:fillRect/>
+                </a:stretch>
+              </a:blipFill>
+            </p:spPr>
+            <p:txBody>
+              <a:bodyPr/>
+              <a:lstStyle/>
+              <a:p>
+                <a:r>
+                  <a:rPr lang="es-CL">
+                    <a:noFill/>
+                  </a:rPr>
+                  <a:t> </a:t>
+                </a:r>
+              </a:p>
+            </p:txBody>
+          </p:sp>
+        </mc:Fallback>
+      </mc:AlternateContent>
+      <p:sp>
+        <p:nvSpPr>
+          <p:cNvPr id="4" name="Marcador de número de diapositiva 3">
+            <a:extLst>
+              <a:ext uri="{FF2B5EF4-FFF2-40B4-BE49-F238E27FC236}">
+                <a16:creationId xmlns:a16="http://schemas.microsoft.com/office/drawing/2014/main" id="{D89A3095-E397-C32C-5BFD-7C4D16E12032}"/>
+              </a:ext>
+            </a:extLst>
+          </p:cNvPr>
+          <p:cNvSpPr>
+            <a:spLocks noGrp="1"/>
+          </p:cNvSpPr>
+          <p:nvPr>
+            <p:ph type="sldNum" sz="quarter" idx="12"/>
+          </p:nvPr>
+        </p:nvSpPr>
+        <p:spPr/>
+        <p:txBody>
+          <a:bodyPr/>
+          <a:lstStyle/>
+          <a:p>
+            <a:fld id="{29B47543-ED2D-461E-8250-4200DFF84A65}" type="slidenum">
+              <a:rPr lang="es-CL" smtClean="0"/>
+              <a:t>5</a:t>
+            </a:fld>
+            <a:endParaRPr lang="es-CL"/>
+          </a:p>
+        </p:txBody>
+      </p:sp>
+    </p:spTree>
+    <p:extLst>
+      <p:ext uri="{BB962C8B-B14F-4D97-AF65-F5344CB8AC3E}">
+        <p14:creationId xmlns:p14="http://schemas.microsoft.com/office/powerpoint/2010/main" val="3524431556"/>
+      </p:ext>
+    </p:extLst>
+  </p:cSld>
+  <p:clrMapOvr>
+    <a:masterClrMapping/>
+  </p:clrMapOvr>
+</p:sld>
+</file>
+
+<file path=ppt/slides/slide6.xml><?xml version="1.0" encoding="utf-8"?>
 <p:sld xmlns:a="http://schemas.openxmlformats.org/drawingml/2006/main" xmlns:r="http://schemas.openxmlformats.org/officeDocument/2006/relationships" xmlns:p="http://schemas.openxmlformats.org/presentationml/2006/main">
   <p:cSld>
     <p:spTree>
@@ -4740,7 +7056,7 @@
           <p:cNvPr id="2" name="Título 1">
             <a:extLst>
               <a:ext uri="{FF2B5EF4-FFF2-40B4-BE49-F238E27FC236}">
-                <a16:creationId xmlns:a16="http://schemas.microsoft.com/office/drawing/2014/main" id="{AEF388C1-6D59-7BBC-7620-8834B5E3124E}"/>
+                <a16:creationId xmlns:a16="http://schemas.microsoft.com/office/drawing/2014/main" id="{903BA9FC-A902-4BA5-A244-275746FA148F}"/>
               </a:ext>
             </a:extLst>
           </p:cNvPr>
@@ -4758,11 +7074,7 @@
           <a:p>
             <a:r>
               <a:rPr lang="es-MX" dirty="0"/>
-              <a:t>Cuantización de </a:t>
-            </a:r>
-            <a:r>
-              <a:rPr lang="es-MX" dirty="0" err="1"/>
-              <a:t>FingerFlexionNN</a:t>
+              <a:t>Información del modelo cuantizado</a:t>
             </a:r>
             <a:endParaRPr lang="es-CL" dirty="0"/>
           </a:p>
@@ -4773,7 +7085,7 @@
           <p:cNvPr id="3" name="Marcador de contenido 2">
             <a:extLst>
               <a:ext uri="{FF2B5EF4-FFF2-40B4-BE49-F238E27FC236}">
-                <a16:creationId xmlns:a16="http://schemas.microsoft.com/office/drawing/2014/main" id="{0697CD8A-7F6C-0022-9A92-25AF281729C8}"/>
+                <a16:creationId xmlns:a16="http://schemas.microsoft.com/office/drawing/2014/main" id="{6EBB79B5-42DE-B21D-2137-7C894526F7D2}"/>
               </a:ext>
             </a:extLst>
           </p:cNvPr>
@@ -4786,10 +7098,57 @@
         </p:nvSpPr>
         <p:spPr/>
         <p:txBody>
-          <a:bodyPr/>
+          <a:bodyPr>
+            <a:normAutofit/>
+          </a:bodyPr>
           <a:lstStyle/>
           <a:p>
-            <a:endParaRPr lang="es-CL"/>
+            <a:r>
+              <a:rPr lang="es-MX" sz="3600" dirty="0"/>
+              <a:t>Entrada:</a:t>
+            </a:r>
+          </a:p>
+          <a:p>
+            <a:pPr lvl="1"/>
+            <a:r>
+              <a:rPr lang="es-MX" sz="3200" dirty="0"/>
+              <a:t>Forma del tensor: [1, 1]</a:t>
+            </a:r>
+          </a:p>
+          <a:p>
+            <a:pPr lvl="1"/>
+            <a:r>
+              <a:rPr lang="es-MX" sz="3200" dirty="0"/>
+              <a:t>Tipo: numpy.int8</a:t>
+            </a:r>
+          </a:p>
+          <a:p>
+            <a:pPr lvl="1"/>
+            <a:r>
+              <a:rPr lang="es-MX" sz="3200" dirty="0"/>
+              <a:t>Cuantización:</a:t>
+            </a:r>
+          </a:p>
+          <a:p>
+            <a:pPr lvl="2"/>
+            <a:r>
+              <a:rPr lang="es-MX" sz="2800" dirty="0"/>
+              <a:t>Escala: 0.02442015</a:t>
+            </a:r>
+          </a:p>
+          <a:p>
+            <a:pPr lvl="2"/>
+            <a:r>
+              <a:rPr lang="es-MX" sz="2800" dirty="0"/>
+              <a:t>Cero: -128</a:t>
+            </a:r>
+            <a:endParaRPr lang="es-CL" sz="2800" dirty="0"/>
+          </a:p>
+          <a:p>
+            <a:pPr marL="914400" lvl="2" indent="0">
+              <a:buNone/>
+            </a:pPr>
+            <a:endParaRPr lang="es-CL" sz="2800" dirty="0"/>
           </a:p>
         </p:txBody>
       </p:sp>
@@ -4798,7 +7157,7 @@
           <p:cNvPr id="4" name="Marcador de número de diapositiva 3">
             <a:extLst>
               <a:ext uri="{FF2B5EF4-FFF2-40B4-BE49-F238E27FC236}">
-                <a16:creationId xmlns:a16="http://schemas.microsoft.com/office/drawing/2014/main" id="{89D44F31-C64B-2226-10C0-0AEACB9AC27A}"/>
+                <a16:creationId xmlns:a16="http://schemas.microsoft.com/office/drawing/2014/main" id="{EFA27B7E-28EA-3742-F80E-E5204FB3F52C}"/>
               </a:ext>
             </a:extLst>
           </p:cNvPr>
@@ -4816,7 +7175,7 @@
           <a:p>
             <a:fld id="{29B47543-ED2D-461E-8250-4200DFF84A65}" type="slidenum">
               <a:rPr lang="es-CL" smtClean="0"/>
-              <a:t>9</a:t>
+              <a:t>6</a:t>
             </a:fld>
             <a:endParaRPr lang="es-CL"/>
           </a:p>
@@ -4825,7 +7184,173 @@
     </p:spTree>
     <p:extLst>
       <p:ext uri="{BB962C8B-B14F-4D97-AF65-F5344CB8AC3E}">
-        <p14:creationId xmlns:p14="http://schemas.microsoft.com/office/powerpoint/2010/main" val="1447662959"/>
+        <p14:creationId xmlns:p14="http://schemas.microsoft.com/office/powerpoint/2010/main" val="2648280899"/>
+      </p:ext>
+    </p:extLst>
+  </p:cSld>
+  <p:clrMapOvr>
+    <a:masterClrMapping/>
+  </p:clrMapOvr>
+</p:sld>
+</file>
+
+<file path=ppt/slides/slide7.xml><?xml version="1.0" encoding="utf-8"?>
+<p:sld xmlns:a="http://schemas.openxmlformats.org/drawingml/2006/main" xmlns:r="http://schemas.openxmlformats.org/officeDocument/2006/relationships" xmlns:p="http://schemas.openxmlformats.org/presentationml/2006/main">
+  <p:cSld>
+    <p:spTree>
+      <p:nvGrpSpPr>
+        <p:cNvPr id="1" name="">
+          <a:extLst>
+            <a:ext uri="{FF2B5EF4-FFF2-40B4-BE49-F238E27FC236}">
+              <a16:creationId xmlns:a16="http://schemas.microsoft.com/office/drawing/2014/main" id="{6D23D573-9D0A-3DCB-B383-CC9B3CF21CEB}"/>
+            </a:ext>
+          </a:extLst>
+        </p:cNvPr>
+        <p:cNvGrpSpPr/>
+        <p:nvPr/>
+      </p:nvGrpSpPr>
+      <p:grpSpPr>
+        <a:xfrm>
+          <a:off x="0" y="0"/>
+          <a:ext cx="0" cy="0"/>
+          <a:chOff x="0" y="0"/>
+          <a:chExt cx="0" cy="0"/>
+        </a:xfrm>
+      </p:grpSpPr>
+      <p:sp>
+        <p:nvSpPr>
+          <p:cNvPr id="2" name="Título 1">
+            <a:extLst>
+              <a:ext uri="{FF2B5EF4-FFF2-40B4-BE49-F238E27FC236}">
+                <a16:creationId xmlns:a16="http://schemas.microsoft.com/office/drawing/2014/main" id="{15D7100B-C44C-6E29-A727-C8C11E430BE7}"/>
+              </a:ext>
+            </a:extLst>
+          </p:cNvPr>
+          <p:cNvSpPr>
+            <a:spLocks noGrp="1"/>
+          </p:cNvSpPr>
+          <p:nvPr>
+            <p:ph type="title"/>
+          </p:nvPr>
+        </p:nvSpPr>
+        <p:spPr/>
+        <p:txBody>
+          <a:bodyPr/>
+          <a:lstStyle/>
+          <a:p>
+            <a:r>
+              <a:rPr lang="es-MX" dirty="0"/>
+              <a:t>Información del modelo cuantizado</a:t>
+            </a:r>
+            <a:endParaRPr lang="es-CL" dirty="0"/>
+          </a:p>
+        </p:txBody>
+      </p:sp>
+      <p:sp>
+        <p:nvSpPr>
+          <p:cNvPr id="3" name="Marcador de contenido 2">
+            <a:extLst>
+              <a:ext uri="{FF2B5EF4-FFF2-40B4-BE49-F238E27FC236}">
+                <a16:creationId xmlns:a16="http://schemas.microsoft.com/office/drawing/2014/main" id="{8B93E09A-2FE4-72FD-5985-CF1897584C23}"/>
+              </a:ext>
+            </a:extLst>
+          </p:cNvPr>
+          <p:cNvSpPr>
+            <a:spLocks noGrp="1"/>
+          </p:cNvSpPr>
+          <p:nvPr>
+            <p:ph idx="1"/>
+          </p:nvPr>
+        </p:nvSpPr>
+        <p:spPr/>
+        <p:txBody>
+          <a:bodyPr>
+            <a:normAutofit/>
+          </a:bodyPr>
+          <a:lstStyle/>
+          <a:p>
+            <a:r>
+              <a:rPr lang="es-MX" sz="3600" dirty="0"/>
+              <a:t>Salida:</a:t>
+            </a:r>
+          </a:p>
+          <a:p>
+            <a:pPr lvl="1"/>
+            <a:r>
+              <a:rPr lang="es-MX" sz="3200" dirty="0"/>
+              <a:t>Forma del tensor: [1, 1]</a:t>
+            </a:r>
+          </a:p>
+          <a:p>
+            <a:pPr lvl="1"/>
+            <a:r>
+              <a:rPr lang="es-MX" sz="3200" dirty="0"/>
+              <a:t>Tipo: numpy.int8</a:t>
+            </a:r>
+          </a:p>
+          <a:p>
+            <a:pPr lvl="1"/>
+            <a:r>
+              <a:rPr lang="es-MX" sz="3200" dirty="0"/>
+              <a:t>Cuantización:</a:t>
+            </a:r>
+          </a:p>
+          <a:p>
+            <a:pPr lvl="2"/>
+            <a:r>
+              <a:rPr lang="es-MX" sz="2800" dirty="0"/>
+              <a:t>Escala: 0.0082211</a:t>
+            </a:r>
+          </a:p>
+          <a:p>
+            <a:pPr lvl="2"/>
+            <a:r>
+              <a:rPr lang="es-MX" sz="2800" dirty="0"/>
+              <a:t>Cero: 5</a:t>
+            </a:r>
+            <a:endParaRPr lang="es-CL" sz="2800" dirty="0"/>
+          </a:p>
+          <a:p>
+            <a:pPr marL="914400" lvl="2" indent="0">
+              <a:buNone/>
+            </a:pPr>
+            <a:endParaRPr lang="es-CL" sz="2800" dirty="0"/>
+          </a:p>
+        </p:txBody>
+      </p:sp>
+      <p:sp>
+        <p:nvSpPr>
+          <p:cNvPr id="4" name="Marcador de número de diapositiva 3">
+            <a:extLst>
+              <a:ext uri="{FF2B5EF4-FFF2-40B4-BE49-F238E27FC236}">
+                <a16:creationId xmlns:a16="http://schemas.microsoft.com/office/drawing/2014/main" id="{A4047A20-5494-AB2C-364A-A5342221ADCA}"/>
+              </a:ext>
+            </a:extLst>
+          </p:cNvPr>
+          <p:cNvSpPr>
+            <a:spLocks noGrp="1"/>
+          </p:cNvSpPr>
+          <p:nvPr>
+            <p:ph type="sldNum" sz="quarter" idx="12"/>
+          </p:nvPr>
+        </p:nvSpPr>
+        <p:spPr/>
+        <p:txBody>
+          <a:bodyPr/>
+          <a:lstStyle/>
+          <a:p>
+            <a:fld id="{29B47543-ED2D-461E-8250-4200DFF84A65}" type="slidenum">
+              <a:rPr lang="es-CL" smtClean="0"/>
+              <a:t>7</a:t>
+            </a:fld>
+            <a:endParaRPr lang="es-CL"/>
+          </a:p>
+        </p:txBody>
+      </p:sp>
+    </p:spTree>
+    <p:extLst>
+      <p:ext uri="{BB962C8B-B14F-4D97-AF65-F5344CB8AC3E}">
+        <p14:creationId xmlns:p14="http://schemas.microsoft.com/office/powerpoint/2010/main" val="1361633971"/>
       </p:ext>
     </p:extLst>
   </p:cSld>
@@ -5446,15 +7971,6 @@
 </file>
 
 <file path=customXml/item1.xml><?xml version="1.0" encoding="utf-8"?>
-<?mso-contentType ?>
-<FormTemplates xmlns="http://schemas.microsoft.com/sharepoint/v3/contenttype/forms">
-  <Display>DocumentLibraryForm</Display>
-  <Edit>DocumentLibraryForm</Edit>
-  <New>DocumentLibraryForm</New>
-</FormTemplates>
-</file>
-
-<file path=customXml/item2.xml><?xml version="1.0" encoding="utf-8"?>
 <p:properties xmlns:p="http://schemas.microsoft.com/office/2006/metadata/properties" xmlns:xsi="http://www.w3.org/2001/XMLSchema-instance" xmlns:pc="http://schemas.microsoft.com/office/infopath/2007/PartnerControls">
   <documentManagement>
     <_activity xmlns="1ca73e69-5c0b-48ea-a835-779e1875cab4" xsi:nil="true"/>
@@ -5462,7 +7978,7 @@
 </p:properties>
 </file>
 
-<file path=customXml/item3.xml><?xml version="1.0" encoding="utf-8"?>
+<file path=customXml/item2.xml><?xml version="1.0" encoding="utf-8"?>
 <ct:contentTypeSchema xmlns:ct="http://schemas.microsoft.com/office/2006/metadata/contentType" xmlns:ma="http://schemas.microsoft.com/office/2006/metadata/properties/metaAttributes" ct:_="" ma:_="" ma:contentTypeName="Documento" ma:contentTypeID="0x0101000350BC36331587468FC1264AE40710EA" ma:contentTypeVersion="14" ma:contentTypeDescription="Crear nuevo documento." ma:contentTypeScope="" ma:versionID="87be5154aa1b102034f80a264d154dfa">
   <xsd:schema xmlns:xsd="http://www.w3.org/2001/XMLSchema" xmlns:xs="http://www.w3.org/2001/XMLSchema" xmlns:p="http://schemas.microsoft.com/office/2006/metadata/properties" xmlns:ns3="1ca73e69-5c0b-48ea-a835-779e1875cab4" xmlns:ns4="73f6c764-4f9c-4529-97a4-e6108ddfe422" targetNamespace="http://schemas.microsoft.com/office/2006/metadata/properties" ma:root="true" ma:fieldsID="37624e3746ebb616b7d5e7f6a525cb5b" ns3:_="" ns4:_="">
     <xsd:import namespace="1ca73e69-5c0b-48ea-a835-779e1875cab4"/>
@@ -5689,15 +8205,16 @@
 </ct:contentTypeSchema>
 </file>
 
-<file path=customXml/itemProps1.xml><?xml version="1.0" encoding="utf-8"?>
-<ds:datastoreItem xmlns:ds="http://schemas.openxmlformats.org/officeDocument/2006/customXml" ds:itemID="{7C14A90D-02DD-47F0-BF02-A623F5D74365}">
-  <ds:schemaRefs>
-    <ds:schemaRef ds:uri="http://schemas.microsoft.com/sharepoint/v3/contenttype/forms"/>
-  </ds:schemaRefs>
-</ds:datastoreItem>
+<file path=customXml/item3.xml><?xml version="1.0" encoding="utf-8"?>
+<?mso-contentType ?>
+<FormTemplates xmlns="http://schemas.microsoft.com/sharepoint/v3/contenttype/forms">
+  <Display>DocumentLibraryForm</Display>
+  <Edit>DocumentLibraryForm</Edit>
+  <New>DocumentLibraryForm</New>
+</FormTemplates>
 </file>
 
-<file path=customXml/itemProps2.xml><?xml version="1.0" encoding="utf-8"?>
+<file path=customXml/itemProps1.xml><?xml version="1.0" encoding="utf-8"?>
 <ds:datastoreItem xmlns:ds="http://schemas.openxmlformats.org/officeDocument/2006/customXml" ds:itemID="{64D3A0E1-0556-456A-B99D-21EE789AEAD0}">
   <ds:schemaRefs>
     <ds:schemaRef ds:uri="1ca73e69-5c0b-48ea-a835-779e1875cab4"/>
@@ -5714,7 +8231,7 @@
 </ds:datastoreItem>
 </file>
 
-<file path=customXml/itemProps3.xml><?xml version="1.0" encoding="utf-8"?>
+<file path=customXml/itemProps2.xml><?xml version="1.0" encoding="utf-8"?>
 <ds:datastoreItem xmlns:ds="http://schemas.openxmlformats.org/officeDocument/2006/customXml" ds:itemID="{3DF8B472-1F73-4C42-A139-622080E0BEA1}">
   <ds:schemaRefs>
     <ds:schemaRef ds:uri="1ca73e69-5c0b-48ea-a835-779e1875cab4"/>
@@ -5731,4 +8248,12 @@
     <ds:schemaRef ds:uri="http://www.w3.org/2001/XMLSchema"/>
   </ds:schemaRefs>
 </ds:datastoreItem>
+</file>
+
+<file path=customXml/itemProps3.xml><?xml version="1.0" encoding="utf-8"?>
+<ds:datastoreItem xmlns:ds="http://schemas.openxmlformats.org/officeDocument/2006/customXml" ds:itemID="{7C14A90D-02DD-47F0-BF02-A623F5D74365}">
+  <ds:schemaRefs>
+    <ds:schemaRef ds:uri="http://schemas.microsoft.com/sharepoint/v3/contenttype/forms"/>
+  </ds:schemaRefs>
+</ds:datastoreItem>
 </file>
</xml_diff>

<commit_message>
Workspace funcional con sinemodel cuantizado
</commit_message>
<xml_diff>
--- a/Edge Computing para Control Biónico con Señales Cerebrales.pptx
+++ b/Edge Computing para Control Biónico con Señales Cerebrales.pptx
@@ -5,7 +5,7 @@
     <p:sldMasterId id="2147483648" r:id="rId4"/>
   </p:sldMasterIdLst>
   <p:notesMasterIdLst>
-    <p:notesMasterId r:id="rId12"/>
+    <p:notesMasterId r:id="rId13"/>
   </p:notesMasterIdLst>
   <p:sldIdLst>
     <p:sldId id="256" r:id="rId5"/>
@@ -15,6 +15,7 @@
     <p:sldId id="285" r:id="rId9"/>
     <p:sldId id="276" r:id="rId10"/>
     <p:sldId id="284" r:id="rId11"/>
+    <p:sldId id="287" r:id="rId12"/>
   </p:sldIdLst>
   <p:sldSz cx="12192000" cy="6858000"/>
   <p:notesSz cx="6858000" cy="9144000"/>
@@ -2739,7 +2740,7 @@
           <a:p>
             <a:fld id="{9D46E1BC-9D70-4B9E-9845-30E6A0E439DE}" type="datetimeFigureOut">
               <a:rPr lang="es-CL" smtClean="0"/>
-              <a:t>03-06-2025</a:t>
+              <a:t>12-06-2025</a:t>
             </a:fld>
             <a:endParaRPr lang="es-CL"/>
           </a:p>
@@ -3156,7 +3157,7 @@
           <a:p>
             <a:fld id="{3057AFD2-2E50-47EA-8313-7EE0BF4DB844}" type="datetime1">
               <a:rPr lang="es-CL" smtClean="0"/>
-              <a:t>03-06-2025</a:t>
+              <a:t>12-06-2025</a:t>
             </a:fld>
             <a:endParaRPr lang="es-CL"/>
           </a:p>
@@ -3356,7 +3357,7 @@
           <a:p>
             <a:fld id="{9ABB4C2D-AC9D-4A03-9EA0-41CC1E8B638D}" type="datetime1">
               <a:rPr lang="es-CL" smtClean="0"/>
-              <a:t>03-06-2025</a:t>
+              <a:t>12-06-2025</a:t>
             </a:fld>
             <a:endParaRPr lang="es-CL"/>
           </a:p>
@@ -3566,7 +3567,7 @@
           <a:p>
             <a:fld id="{4491CB44-4C5E-4FE6-A739-2EEEC509E2E3}" type="datetime1">
               <a:rPr lang="es-CL" smtClean="0"/>
-              <a:t>03-06-2025</a:t>
+              <a:t>12-06-2025</a:t>
             </a:fld>
             <a:endParaRPr lang="es-CL"/>
           </a:p>
@@ -3766,7 +3767,7 @@
           <a:p>
             <a:fld id="{C635104C-855C-4B6C-890D-4AB2CA091A63}" type="datetime1">
               <a:rPr lang="es-CL" smtClean="0"/>
-              <a:t>03-06-2025</a:t>
+              <a:t>12-06-2025</a:t>
             </a:fld>
             <a:endParaRPr lang="es-CL"/>
           </a:p>
@@ -4042,7 +4043,7 @@
           <a:p>
             <a:fld id="{2CA4F56F-FFB5-4D4F-8157-A3F6E1208686}" type="datetime1">
               <a:rPr lang="es-CL" smtClean="0"/>
-              <a:t>03-06-2025</a:t>
+              <a:t>12-06-2025</a:t>
             </a:fld>
             <a:endParaRPr lang="es-CL"/>
           </a:p>
@@ -4310,7 +4311,7 @@
           <a:p>
             <a:fld id="{0FBFB81C-3238-4E55-BBDB-ABD3B47D33C3}" type="datetime1">
               <a:rPr lang="es-CL" smtClean="0"/>
-              <a:t>03-06-2025</a:t>
+              <a:t>12-06-2025</a:t>
             </a:fld>
             <a:endParaRPr lang="es-CL"/>
           </a:p>
@@ -4725,7 +4726,7 @@
           <a:p>
             <a:fld id="{9142CA42-5823-44DC-A2D8-66A69FC1D8A5}" type="datetime1">
               <a:rPr lang="es-CL" smtClean="0"/>
-              <a:t>03-06-2025</a:t>
+              <a:t>12-06-2025</a:t>
             </a:fld>
             <a:endParaRPr lang="es-CL"/>
           </a:p>
@@ -4867,7 +4868,7 @@
           <a:p>
             <a:fld id="{08679031-1A41-476F-B818-FB293F04499D}" type="datetime1">
               <a:rPr lang="es-CL" smtClean="0"/>
-              <a:t>03-06-2025</a:t>
+              <a:t>12-06-2025</a:t>
             </a:fld>
             <a:endParaRPr lang="es-CL"/>
           </a:p>
@@ -4980,7 +4981,7 @@
           <a:p>
             <a:fld id="{D8AE8DE8-1FED-46DA-9654-E74B4A7C5DEA}" type="datetime1">
               <a:rPr lang="es-CL" smtClean="0"/>
-              <a:t>03-06-2025</a:t>
+              <a:t>12-06-2025</a:t>
             </a:fld>
             <a:endParaRPr lang="es-CL"/>
           </a:p>
@@ -5293,7 +5294,7 @@
           <a:p>
             <a:fld id="{DC537023-F69E-4452-B72E-2DEE3AFB9C53}" type="datetime1">
               <a:rPr lang="es-CL" smtClean="0"/>
-              <a:t>03-06-2025</a:t>
+              <a:t>12-06-2025</a:t>
             </a:fld>
             <a:endParaRPr lang="es-CL"/>
           </a:p>
@@ -5582,7 +5583,7 @@
           <a:p>
             <a:fld id="{81819FF8-2823-4B85-80F1-6DE0C3C2B12E}" type="datetime1">
               <a:rPr lang="es-CL" smtClean="0"/>
-              <a:t>03-06-2025</a:t>
+              <a:t>12-06-2025</a:t>
             </a:fld>
             <a:endParaRPr lang="es-CL"/>
           </a:p>
@@ -5825,7 +5826,7 @@
           <a:p>
             <a:fld id="{A8AC9CAF-9571-4308-BC43-45FC52060C70}" type="datetime1">
               <a:rPr lang="es-CL" smtClean="0"/>
-              <a:t>03-06-2025</a:t>
+              <a:t>12-06-2025</a:t>
             </a:fld>
             <a:endParaRPr lang="es-CL"/>
           </a:p>
@@ -7351,6 +7352,123 @@
     <p:extLst>
       <p:ext uri="{BB962C8B-B14F-4D97-AF65-F5344CB8AC3E}">
         <p14:creationId xmlns:p14="http://schemas.microsoft.com/office/powerpoint/2010/main" val="1361633971"/>
+      </p:ext>
+    </p:extLst>
+  </p:cSld>
+  <p:clrMapOvr>
+    <a:masterClrMapping/>
+  </p:clrMapOvr>
+</p:sld>
+</file>
+
+<file path=ppt/slides/slide8.xml><?xml version="1.0" encoding="utf-8"?>
+<p:sld xmlns:a="http://schemas.openxmlformats.org/drawingml/2006/main" xmlns:r="http://schemas.openxmlformats.org/officeDocument/2006/relationships" xmlns:p="http://schemas.openxmlformats.org/presentationml/2006/main">
+  <p:cSld>
+    <p:spTree>
+      <p:nvGrpSpPr>
+        <p:cNvPr id="1" name=""/>
+        <p:cNvGrpSpPr/>
+        <p:nvPr/>
+      </p:nvGrpSpPr>
+      <p:grpSpPr>
+        <a:xfrm>
+          <a:off x="0" y="0"/>
+          <a:ext cx="0" cy="0"/>
+          <a:chOff x="0" y="0"/>
+          <a:chExt cx="0" cy="0"/>
+        </a:xfrm>
+      </p:grpSpPr>
+      <p:sp>
+        <p:nvSpPr>
+          <p:cNvPr id="2" name="Título 1">
+            <a:extLst>
+              <a:ext uri="{FF2B5EF4-FFF2-40B4-BE49-F238E27FC236}">
+                <a16:creationId xmlns:a16="http://schemas.microsoft.com/office/drawing/2014/main" id="{C5818552-88C4-4BDF-F175-77744CD5D7B0}"/>
+              </a:ext>
+            </a:extLst>
+          </p:cNvPr>
+          <p:cNvSpPr>
+            <a:spLocks noGrp="1"/>
+          </p:cNvSpPr>
+          <p:nvPr>
+            <p:ph type="title"/>
+          </p:nvPr>
+        </p:nvSpPr>
+        <p:spPr/>
+        <p:txBody>
+          <a:bodyPr/>
+          <a:lstStyle/>
+          <a:p>
+            <a:r>
+              <a:rPr lang="es-MX" dirty="0"/>
+              <a:t>Int8 solo pesos</a:t>
+            </a:r>
+            <a:endParaRPr lang="es-CL" dirty="0"/>
+          </a:p>
+        </p:txBody>
+      </p:sp>
+      <p:pic>
+        <p:nvPicPr>
+          <p:cNvPr id="6" name="Marcador de contenido 5">
+            <a:extLst>
+              <a:ext uri="{FF2B5EF4-FFF2-40B4-BE49-F238E27FC236}">
+                <a16:creationId xmlns:a16="http://schemas.microsoft.com/office/drawing/2014/main" id="{EB973051-5417-891E-A5A6-68ED9F9C739A}"/>
+              </a:ext>
+            </a:extLst>
+          </p:cNvPr>
+          <p:cNvPicPr>
+            <a:picLocks noGrp="1" noChangeAspect="1"/>
+          </p:cNvPicPr>
+          <p:nvPr>
+            <p:ph idx="1"/>
+          </p:nvPr>
+        </p:nvPicPr>
+        <p:blipFill>
+          <a:blip r:embed="rId2"/>
+          <a:stretch>
+            <a:fillRect/>
+          </a:stretch>
+        </p:blipFill>
+        <p:spPr>
+          <a:xfrm>
+            <a:off x="1479337" y="1825625"/>
+            <a:ext cx="9233326" cy="4351338"/>
+          </a:xfrm>
+        </p:spPr>
+      </p:pic>
+      <p:sp>
+        <p:nvSpPr>
+          <p:cNvPr id="4" name="Marcador de número de diapositiva 3">
+            <a:extLst>
+              <a:ext uri="{FF2B5EF4-FFF2-40B4-BE49-F238E27FC236}">
+                <a16:creationId xmlns:a16="http://schemas.microsoft.com/office/drawing/2014/main" id="{BF663559-4E75-25E7-8A1D-BEC209F766BB}"/>
+              </a:ext>
+            </a:extLst>
+          </p:cNvPr>
+          <p:cNvSpPr>
+            <a:spLocks noGrp="1"/>
+          </p:cNvSpPr>
+          <p:nvPr>
+            <p:ph type="sldNum" sz="quarter" idx="12"/>
+          </p:nvPr>
+        </p:nvSpPr>
+        <p:spPr/>
+        <p:txBody>
+          <a:bodyPr/>
+          <a:lstStyle/>
+          <a:p>
+            <a:fld id="{29B47543-ED2D-461E-8250-4200DFF84A65}" type="slidenum">
+              <a:rPr lang="es-CL" smtClean="0"/>
+              <a:t>8</a:t>
+            </a:fld>
+            <a:endParaRPr lang="es-CL"/>
+          </a:p>
+        </p:txBody>
+      </p:sp>
+    </p:spTree>
+    <p:extLst>
+      <p:ext uri="{BB962C8B-B14F-4D97-AF65-F5344CB8AC3E}">
+        <p14:creationId xmlns:p14="http://schemas.microsoft.com/office/powerpoint/2010/main" val="1978492718"/>
       </p:ext>
     </p:extLst>
   </p:cSld>
@@ -7979,6 +8097,15 @@
 </file>
 
 <file path=customXml/item2.xml><?xml version="1.0" encoding="utf-8"?>
+<?mso-contentType ?>
+<FormTemplates xmlns="http://schemas.microsoft.com/sharepoint/v3/contenttype/forms">
+  <Display>DocumentLibraryForm</Display>
+  <Edit>DocumentLibraryForm</Edit>
+  <New>DocumentLibraryForm</New>
+</FormTemplates>
+</file>
+
+<file path=customXml/item3.xml><?xml version="1.0" encoding="utf-8"?>
 <ct:contentTypeSchema xmlns:ct="http://schemas.microsoft.com/office/2006/metadata/contentType" xmlns:ma="http://schemas.microsoft.com/office/2006/metadata/properties/metaAttributes" ct:_="" ma:_="" ma:contentTypeName="Documento" ma:contentTypeID="0x0101000350BC36331587468FC1264AE40710EA" ma:contentTypeVersion="14" ma:contentTypeDescription="Crear nuevo documento." ma:contentTypeScope="" ma:versionID="87be5154aa1b102034f80a264d154dfa">
   <xsd:schema xmlns:xsd="http://www.w3.org/2001/XMLSchema" xmlns:xs="http://www.w3.org/2001/XMLSchema" xmlns:p="http://schemas.microsoft.com/office/2006/metadata/properties" xmlns:ns3="1ca73e69-5c0b-48ea-a835-779e1875cab4" xmlns:ns4="73f6c764-4f9c-4529-97a4-e6108ddfe422" targetNamespace="http://schemas.microsoft.com/office/2006/metadata/properties" ma:root="true" ma:fieldsID="37624e3746ebb616b7d5e7f6a525cb5b" ns3:_="" ns4:_="">
     <xsd:import namespace="1ca73e69-5c0b-48ea-a835-779e1875cab4"/>
@@ -8205,15 +8332,6 @@
 </ct:contentTypeSchema>
 </file>
 
-<file path=customXml/item3.xml><?xml version="1.0" encoding="utf-8"?>
-<?mso-contentType ?>
-<FormTemplates xmlns="http://schemas.microsoft.com/sharepoint/v3/contenttype/forms">
-  <Display>DocumentLibraryForm</Display>
-  <Edit>DocumentLibraryForm</Edit>
-  <New>DocumentLibraryForm</New>
-</FormTemplates>
-</file>
-
 <file path=customXml/itemProps1.xml><?xml version="1.0" encoding="utf-8"?>
 <ds:datastoreItem xmlns:ds="http://schemas.openxmlformats.org/officeDocument/2006/customXml" ds:itemID="{64D3A0E1-0556-456A-B99D-21EE789AEAD0}">
   <ds:schemaRefs>
@@ -8232,6 +8350,14 @@
 </file>
 
 <file path=customXml/itemProps2.xml><?xml version="1.0" encoding="utf-8"?>
+<ds:datastoreItem xmlns:ds="http://schemas.openxmlformats.org/officeDocument/2006/customXml" ds:itemID="{7C14A90D-02DD-47F0-BF02-A623F5D74365}">
+  <ds:schemaRefs>
+    <ds:schemaRef ds:uri="http://schemas.microsoft.com/sharepoint/v3/contenttype/forms"/>
+  </ds:schemaRefs>
+</ds:datastoreItem>
+</file>
+
+<file path=customXml/itemProps3.xml><?xml version="1.0" encoding="utf-8"?>
 <ds:datastoreItem xmlns:ds="http://schemas.openxmlformats.org/officeDocument/2006/customXml" ds:itemID="{3DF8B472-1F73-4C42-A139-622080E0BEA1}">
   <ds:schemaRefs>
     <ds:schemaRef ds:uri="1ca73e69-5c0b-48ea-a835-779e1875cab4"/>
@@ -8248,12 +8374,4 @@
     <ds:schemaRef ds:uri="http://www.w3.org/2001/XMLSchema"/>
   </ds:schemaRefs>
 </ds:datastoreItem>
-</file>
-
-<file path=customXml/itemProps3.xml><?xml version="1.0" encoding="utf-8"?>
-<ds:datastoreItem xmlns:ds="http://schemas.openxmlformats.org/officeDocument/2006/customXml" ds:itemID="{7C14A90D-02DD-47F0-BF02-A623F5D74365}">
-  <ds:schemaRefs>
-    <ds:schemaRef ds:uri="http://schemas.microsoft.com/sharepoint/v3/contenttype/forms"/>
-  </ds:schemaRefs>
-</ds:datastoreItem>
 </file>
</xml_diff>

<commit_message>
Figura sine model int8 y float32
</commit_message>
<xml_diff>
--- a/Edge Computing para Control Biónico con Señales Cerebrales.pptx
+++ b/Edge Computing para Control Biónico con Señales Cerebrales.pptx
@@ -5,7 +5,7 @@
     <p:sldMasterId id="2147483648" r:id="rId4"/>
   </p:sldMasterIdLst>
   <p:notesMasterIdLst>
-    <p:notesMasterId r:id="rId13"/>
+    <p:notesMasterId r:id="rId14"/>
   </p:notesMasterIdLst>
   <p:sldIdLst>
     <p:sldId id="256" r:id="rId5"/>
@@ -16,6 +16,7 @@
     <p:sldId id="276" r:id="rId10"/>
     <p:sldId id="284" r:id="rId11"/>
     <p:sldId id="287" r:id="rId12"/>
+    <p:sldId id="288" r:id="rId13"/>
   </p:sldIdLst>
   <p:sldSz cx="12192000" cy="6858000"/>
   <p:notesSz cx="6858000" cy="9144000"/>
@@ -7478,6 +7479,201 @@
 </p:sld>
 </file>
 
+<file path=ppt/slides/slide9.xml><?xml version="1.0" encoding="utf-8"?>
+<p:sld xmlns:a="http://schemas.openxmlformats.org/drawingml/2006/main" xmlns:r="http://schemas.openxmlformats.org/officeDocument/2006/relationships" xmlns:p="http://schemas.openxmlformats.org/presentationml/2006/main">
+  <p:cSld>
+    <p:spTree>
+      <p:nvGrpSpPr>
+        <p:cNvPr id="1" name=""/>
+        <p:cNvGrpSpPr/>
+        <p:nvPr/>
+      </p:nvGrpSpPr>
+      <p:grpSpPr>
+        <a:xfrm>
+          <a:off x="0" y="0"/>
+          <a:ext cx="0" cy="0"/>
+          <a:chOff x="0" y="0"/>
+          <a:chExt cx="0" cy="0"/>
+        </a:xfrm>
+      </p:grpSpPr>
+      <p:sp>
+        <p:nvSpPr>
+          <p:cNvPr id="8" name="Título 7">
+            <a:extLst>
+              <a:ext uri="{FF2B5EF4-FFF2-40B4-BE49-F238E27FC236}">
+                <a16:creationId xmlns:a16="http://schemas.microsoft.com/office/drawing/2014/main" id="{09F9692C-10F5-6363-517D-49680FF954C7}"/>
+              </a:ext>
+            </a:extLst>
+          </p:cNvPr>
+          <p:cNvSpPr>
+            <a:spLocks noGrp="1"/>
+          </p:cNvSpPr>
+          <p:nvPr>
+            <p:ph type="title"/>
+          </p:nvPr>
+        </p:nvSpPr>
+        <p:spPr/>
+        <p:txBody>
+          <a:bodyPr/>
+          <a:lstStyle/>
+          <a:p>
+            <a:endParaRPr lang="es-CL"/>
+          </a:p>
+        </p:txBody>
+      </p:sp>
+      <p:sp>
+        <p:nvSpPr>
+          <p:cNvPr id="9" name="Marcador de texto 8">
+            <a:extLst>
+              <a:ext uri="{FF2B5EF4-FFF2-40B4-BE49-F238E27FC236}">
+                <a16:creationId xmlns:a16="http://schemas.microsoft.com/office/drawing/2014/main" id="{DBE482BE-F6C7-B15E-9416-C9BC458A7295}"/>
+              </a:ext>
+            </a:extLst>
+          </p:cNvPr>
+          <p:cNvSpPr>
+            <a:spLocks noGrp="1"/>
+          </p:cNvSpPr>
+          <p:nvPr>
+            <p:ph type="body" idx="1"/>
+          </p:nvPr>
+        </p:nvSpPr>
+        <p:spPr/>
+        <p:txBody>
+          <a:bodyPr/>
+          <a:lstStyle/>
+          <a:p>
+            <a:endParaRPr lang="es-CL"/>
+          </a:p>
+        </p:txBody>
+      </p:sp>
+      <p:pic>
+        <p:nvPicPr>
+          <p:cNvPr id="7" name="Marcador de contenido 6">
+            <a:extLst>
+              <a:ext uri="{FF2B5EF4-FFF2-40B4-BE49-F238E27FC236}">
+                <a16:creationId xmlns:a16="http://schemas.microsoft.com/office/drawing/2014/main" id="{4AB6E04B-FCC3-7959-9925-372C06F30F97}"/>
+              </a:ext>
+            </a:extLst>
+          </p:cNvPr>
+          <p:cNvPicPr>
+            <a:picLocks noGrp="1" noChangeAspect="1"/>
+          </p:cNvPicPr>
+          <p:nvPr>
+            <p:ph sz="half" idx="2"/>
+          </p:nvPr>
+        </p:nvPicPr>
+        <p:blipFill>
+          <a:blip r:embed="rId2"/>
+          <a:stretch>
+            <a:fillRect/>
+          </a:stretch>
+        </p:blipFill>
+        <p:spPr>
+          <a:xfrm>
+            <a:off x="1376288" y="2505075"/>
+            <a:ext cx="4084786" cy="3684588"/>
+          </a:xfrm>
+          <a:prstGeom prst="rect">
+            <a:avLst/>
+          </a:prstGeom>
+        </p:spPr>
+      </p:pic>
+      <p:sp>
+        <p:nvSpPr>
+          <p:cNvPr id="10" name="Marcador de texto 9">
+            <a:extLst>
+              <a:ext uri="{FF2B5EF4-FFF2-40B4-BE49-F238E27FC236}">
+                <a16:creationId xmlns:a16="http://schemas.microsoft.com/office/drawing/2014/main" id="{CFFBF1F4-E6C8-B3B1-B922-AF21B2EEB6B9}"/>
+              </a:ext>
+            </a:extLst>
+          </p:cNvPr>
+          <p:cNvSpPr>
+            <a:spLocks noGrp="1"/>
+          </p:cNvSpPr>
+          <p:nvPr>
+            <p:ph type="body" sz="quarter" idx="3"/>
+          </p:nvPr>
+        </p:nvSpPr>
+        <p:spPr/>
+        <p:txBody>
+          <a:bodyPr/>
+          <a:lstStyle/>
+          <a:p>
+            <a:endParaRPr lang="es-CL"/>
+          </a:p>
+        </p:txBody>
+      </p:sp>
+      <p:pic>
+        <p:nvPicPr>
+          <p:cNvPr id="13" name="Marcador de contenido 12">
+            <a:extLst>
+              <a:ext uri="{FF2B5EF4-FFF2-40B4-BE49-F238E27FC236}">
+                <a16:creationId xmlns:a16="http://schemas.microsoft.com/office/drawing/2014/main" id="{175439AB-1020-AC25-97D7-65A11146E431}"/>
+              </a:ext>
+            </a:extLst>
+          </p:cNvPr>
+          <p:cNvPicPr>
+            <a:picLocks noGrp="1" noChangeAspect="1"/>
+          </p:cNvPicPr>
+          <p:nvPr>
+            <p:ph sz="quarter" idx="4"/>
+          </p:nvPr>
+        </p:nvPicPr>
+        <p:blipFill>
+          <a:blip r:embed="rId3"/>
+          <a:stretch>
+            <a:fillRect/>
+          </a:stretch>
+        </p:blipFill>
+        <p:spPr>
+          <a:xfrm>
+            <a:off x="6776411" y="2505075"/>
+            <a:ext cx="3974766" cy="3684588"/>
+          </a:xfrm>
+        </p:spPr>
+      </p:pic>
+      <p:sp>
+        <p:nvSpPr>
+          <p:cNvPr id="4" name="Marcador de número de diapositiva 3">
+            <a:extLst>
+              <a:ext uri="{FF2B5EF4-FFF2-40B4-BE49-F238E27FC236}">
+                <a16:creationId xmlns:a16="http://schemas.microsoft.com/office/drawing/2014/main" id="{DCC60300-8C8A-DFA0-D1FA-C9E33D2B88BF}"/>
+              </a:ext>
+            </a:extLst>
+          </p:cNvPr>
+          <p:cNvSpPr>
+            <a:spLocks noGrp="1"/>
+          </p:cNvSpPr>
+          <p:nvPr>
+            <p:ph type="sldNum" sz="quarter" idx="12"/>
+          </p:nvPr>
+        </p:nvSpPr>
+        <p:spPr/>
+        <p:txBody>
+          <a:bodyPr/>
+          <a:lstStyle/>
+          <a:p>
+            <a:fld id="{29B47543-ED2D-461E-8250-4200DFF84A65}" type="slidenum">
+              <a:rPr lang="es-CL" smtClean="0"/>
+              <a:t>9</a:t>
+            </a:fld>
+            <a:endParaRPr lang="es-CL"/>
+          </a:p>
+        </p:txBody>
+      </p:sp>
+    </p:spTree>
+    <p:extLst>
+      <p:ext uri="{BB962C8B-B14F-4D97-AF65-F5344CB8AC3E}">
+        <p14:creationId xmlns:p14="http://schemas.microsoft.com/office/powerpoint/2010/main" val="305514061"/>
+      </p:ext>
+    </p:extLst>
+  </p:cSld>
+  <p:clrMapOvr>
+    <a:masterClrMapping/>
+  </p:clrMapOvr>
+</p:sld>
+</file>
+
 <file path=ppt/theme/theme1.xml><?xml version="1.0" encoding="utf-8"?>
 <a:theme xmlns:a="http://schemas.openxmlformats.org/drawingml/2006/main" name="Tema de Office">
   <a:themeElements>
@@ -8089,20 +8285,20 @@
 </file>
 
 <file path=customXml/item1.xml><?xml version="1.0" encoding="utf-8"?>
-<p:properties xmlns:p="http://schemas.microsoft.com/office/2006/metadata/properties" xmlns:xsi="http://www.w3.org/2001/XMLSchema-instance" xmlns:pc="http://schemas.microsoft.com/office/infopath/2007/PartnerControls">
-  <documentManagement>
-    <_activity xmlns="1ca73e69-5c0b-48ea-a835-779e1875cab4" xsi:nil="true"/>
-  </documentManagement>
-</p:properties>
-</file>
-
-<file path=customXml/item2.xml><?xml version="1.0" encoding="utf-8"?>
 <?mso-contentType ?>
 <FormTemplates xmlns="http://schemas.microsoft.com/sharepoint/v3/contenttype/forms">
   <Display>DocumentLibraryForm</Display>
   <Edit>DocumentLibraryForm</Edit>
   <New>DocumentLibraryForm</New>
 </FormTemplates>
+</file>
+
+<file path=customXml/item2.xml><?xml version="1.0" encoding="utf-8"?>
+<p:properties xmlns:p="http://schemas.microsoft.com/office/2006/metadata/properties" xmlns:xsi="http://www.w3.org/2001/XMLSchema-instance" xmlns:pc="http://schemas.microsoft.com/office/infopath/2007/PartnerControls">
+  <documentManagement>
+    <_activity xmlns="1ca73e69-5c0b-48ea-a835-779e1875cab4" xsi:nil="true"/>
+  </documentManagement>
+</p:properties>
 </file>
 
 <file path=customXml/item3.xml><?xml version="1.0" encoding="utf-8"?>
@@ -8333,6 +8529,14 @@
 </file>
 
 <file path=customXml/itemProps1.xml><?xml version="1.0" encoding="utf-8"?>
+<ds:datastoreItem xmlns:ds="http://schemas.openxmlformats.org/officeDocument/2006/customXml" ds:itemID="{7C14A90D-02DD-47F0-BF02-A623F5D74365}">
+  <ds:schemaRefs>
+    <ds:schemaRef ds:uri="http://schemas.microsoft.com/sharepoint/v3/contenttype/forms"/>
+  </ds:schemaRefs>
+</ds:datastoreItem>
+</file>
+
+<file path=customXml/itemProps2.xml><?xml version="1.0" encoding="utf-8"?>
 <ds:datastoreItem xmlns:ds="http://schemas.openxmlformats.org/officeDocument/2006/customXml" ds:itemID="{64D3A0E1-0556-456A-B99D-21EE789AEAD0}">
   <ds:schemaRefs>
     <ds:schemaRef ds:uri="1ca73e69-5c0b-48ea-a835-779e1875cab4"/>
@@ -8345,14 +8549,6 @@
     <ds:schemaRef ds:uri="http://schemas.microsoft.com/office/infopath/2007/PartnerControls"/>
     <ds:schemaRef ds:uri="http://schemas.openxmlformats.org/package/2006/metadata/core-properties"/>
     <ds:schemaRef ds:uri="http://purl.org/dc/terms/"/>
-  </ds:schemaRefs>
-</ds:datastoreItem>
-</file>
-
-<file path=customXml/itemProps2.xml><?xml version="1.0" encoding="utf-8"?>
-<ds:datastoreItem xmlns:ds="http://schemas.openxmlformats.org/officeDocument/2006/customXml" ds:itemID="{7C14A90D-02DD-47F0-BF02-A623F5D74365}">
-  <ds:schemaRefs>
-    <ds:schemaRef ds:uri="http://schemas.microsoft.com/sharepoint/v3/contenttype/forms"/>
   </ds:schemaRefs>
 </ds:datastoreItem>
 </file>

</xml_diff>

<commit_message>
A little bit of code cleaning
</commit_message>
<xml_diff>
--- a/Edge Computing para Control Biónico con Señales Cerebrales.pptx
+++ b/Edge Computing para Control Biónico con Señales Cerebrales.pptx
@@ -5,7 +5,7 @@
     <p:sldMasterId id="2147483648" r:id="rId4"/>
   </p:sldMasterIdLst>
   <p:notesMasterIdLst>
-    <p:notesMasterId r:id="rId19"/>
+    <p:notesMasterId r:id="rId22"/>
   </p:notesMasterIdLst>
   <p:sldIdLst>
     <p:sldId id="256" r:id="rId5"/>
@@ -20,8 +20,11 @@
     <p:sldId id="291" r:id="rId14"/>
     <p:sldId id="293" r:id="rId15"/>
     <p:sldId id="294" r:id="rId16"/>
-    <p:sldId id="295" r:id="rId17"/>
-    <p:sldId id="296" r:id="rId18"/>
+    <p:sldId id="300" r:id="rId17"/>
+    <p:sldId id="295" r:id="rId18"/>
+    <p:sldId id="296" r:id="rId19"/>
+    <p:sldId id="298" r:id="rId20"/>
+    <p:sldId id="299" r:id="rId21"/>
   </p:sldIdLst>
   <p:sldSz cx="12192000" cy="6858000"/>
   <p:notesSz cx="6858000" cy="9144000"/>
@@ -2746,7 +2749,7 @@
           <a:p>
             <a:fld id="{9D46E1BC-9D70-4B9E-9845-30E6A0E439DE}" type="datetimeFigureOut">
               <a:rPr lang="es-CL" smtClean="0"/>
-              <a:t>17-06-2025</a:t>
+              <a:t>19-06-2025</a:t>
             </a:fld>
             <a:endParaRPr lang="es-CL"/>
           </a:p>
@@ -3262,7 +3265,7 @@
           <a:p>
             <a:fld id="{3057AFD2-2E50-47EA-8313-7EE0BF4DB844}" type="datetime1">
               <a:rPr lang="es-CL" smtClean="0"/>
-              <a:t>17-06-2025</a:t>
+              <a:t>19-06-2025</a:t>
             </a:fld>
             <a:endParaRPr lang="es-CL"/>
           </a:p>
@@ -3462,7 +3465,7 @@
           <a:p>
             <a:fld id="{9ABB4C2D-AC9D-4A03-9EA0-41CC1E8B638D}" type="datetime1">
               <a:rPr lang="es-CL" smtClean="0"/>
-              <a:t>17-06-2025</a:t>
+              <a:t>19-06-2025</a:t>
             </a:fld>
             <a:endParaRPr lang="es-CL"/>
           </a:p>
@@ -3672,7 +3675,7 @@
           <a:p>
             <a:fld id="{4491CB44-4C5E-4FE6-A739-2EEEC509E2E3}" type="datetime1">
               <a:rPr lang="es-CL" smtClean="0"/>
-              <a:t>17-06-2025</a:t>
+              <a:t>19-06-2025</a:t>
             </a:fld>
             <a:endParaRPr lang="es-CL"/>
           </a:p>
@@ -3872,7 +3875,7 @@
           <a:p>
             <a:fld id="{C635104C-855C-4B6C-890D-4AB2CA091A63}" type="datetime1">
               <a:rPr lang="es-CL" smtClean="0"/>
-              <a:t>17-06-2025</a:t>
+              <a:t>19-06-2025</a:t>
             </a:fld>
             <a:endParaRPr lang="es-CL"/>
           </a:p>
@@ -4148,7 +4151,7 @@
           <a:p>
             <a:fld id="{2CA4F56F-FFB5-4D4F-8157-A3F6E1208686}" type="datetime1">
               <a:rPr lang="es-CL" smtClean="0"/>
-              <a:t>17-06-2025</a:t>
+              <a:t>19-06-2025</a:t>
             </a:fld>
             <a:endParaRPr lang="es-CL"/>
           </a:p>
@@ -4416,7 +4419,7 @@
           <a:p>
             <a:fld id="{0FBFB81C-3238-4E55-BBDB-ABD3B47D33C3}" type="datetime1">
               <a:rPr lang="es-CL" smtClean="0"/>
-              <a:t>17-06-2025</a:t>
+              <a:t>19-06-2025</a:t>
             </a:fld>
             <a:endParaRPr lang="es-CL"/>
           </a:p>
@@ -4831,7 +4834,7 @@
           <a:p>
             <a:fld id="{9142CA42-5823-44DC-A2D8-66A69FC1D8A5}" type="datetime1">
               <a:rPr lang="es-CL" smtClean="0"/>
-              <a:t>17-06-2025</a:t>
+              <a:t>19-06-2025</a:t>
             </a:fld>
             <a:endParaRPr lang="es-CL"/>
           </a:p>
@@ -4973,7 +4976,7 @@
           <a:p>
             <a:fld id="{08679031-1A41-476F-B818-FB293F04499D}" type="datetime1">
               <a:rPr lang="es-CL" smtClean="0"/>
-              <a:t>17-06-2025</a:t>
+              <a:t>19-06-2025</a:t>
             </a:fld>
             <a:endParaRPr lang="es-CL"/>
           </a:p>
@@ -5086,7 +5089,7 @@
           <a:p>
             <a:fld id="{D8AE8DE8-1FED-46DA-9654-E74B4A7C5DEA}" type="datetime1">
               <a:rPr lang="es-CL" smtClean="0"/>
-              <a:t>17-06-2025</a:t>
+              <a:t>19-06-2025</a:t>
             </a:fld>
             <a:endParaRPr lang="es-CL"/>
           </a:p>
@@ -5399,7 +5402,7 @@
           <a:p>
             <a:fld id="{DC537023-F69E-4452-B72E-2DEE3AFB9C53}" type="datetime1">
               <a:rPr lang="es-CL" smtClean="0"/>
-              <a:t>17-06-2025</a:t>
+              <a:t>19-06-2025</a:t>
             </a:fld>
             <a:endParaRPr lang="es-CL"/>
           </a:p>
@@ -5688,7 +5691,7 @@
           <a:p>
             <a:fld id="{81819FF8-2823-4B85-80F1-6DE0C3C2B12E}" type="datetime1">
               <a:rPr lang="es-CL" smtClean="0"/>
-              <a:t>17-06-2025</a:t>
+              <a:t>19-06-2025</a:t>
             </a:fld>
             <a:endParaRPr lang="es-CL"/>
           </a:p>
@@ -5931,7 +5934,7 @@
           <a:p>
             <a:fld id="{A8AC9CAF-9571-4308-BC43-45FC52060C70}" type="datetime1">
               <a:rPr lang="es-CL" smtClean="0"/>
-              <a:t>17-06-2025</a:t>
+              <a:t>19-06-2025</a:t>
             </a:fld>
             <a:endParaRPr lang="es-CL"/>
           </a:p>
@@ -6791,7 +6794,7 @@
           <a:p>
             <a:pPr algn="ctr"/>
             <a:r>
-              <a:rPr lang="en-US" sz="5200" kern="1200">
+              <a:rPr lang="en-US" sz="5200" kern="1200" dirty="0" err="1">
                 <a:solidFill>
                   <a:schemeClr val="tx1"/>
                 </a:solidFill>
@@ -6801,6 +6804,14 @@
               </a:rPr>
               <a:t>FingerFlex</a:t>
             </a:r>
+            <a:endParaRPr lang="en-US" sz="5200" kern="1200" dirty="0">
+              <a:solidFill>
+                <a:schemeClr val="tx1"/>
+              </a:solidFill>
+              <a:latin typeface="+mj-lt"/>
+              <a:ea typeface="+mj-ea"/>
+              <a:cs typeface="+mj-cs"/>
+            </a:endParaRPr>
           </a:p>
         </p:txBody>
       </p:sp>
@@ -6979,6 +6990,188 @@
           <p:cNvPr id="2" name="Título 1">
             <a:extLst>
               <a:ext uri="{FF2B5EF4-FFF2-40B4-BE49-F238E27FC236}">
+                <a16:creationId xmlns:a16="http://schemas.microsoft.com/office/drawing/2014/main" id="{4553D3CA-7FC0-214C-AC3F-E66C1E005693}"/>
+              </a:ext>
+            </a:extLst>
+          </p:cNvPr>
+          <p:cNvSpPr>
+            <a:spLocks noGrp="1"/>
+          </p:cNvSpPr>
+          <p:nvPr>
+            <p:ph type="title"/>
+          </p:nvPr>
+        </p:nvSpPr>
+        <p:spPr>
+          <a:xfrm>
+            <a:off x="838200" y="365125"/>
+            <a:ext cx="8482445" cy="1325563"/>
+          </a:xfrm>
+        </p:spPr>
+        <p:txBody>
+          <a:bodyPr>
+            <a:normAutofit fontScale="90000"/>
+          </a:bodyPr>
+          <a:lstStyle/>
+          <a:p>
+            <a:r>
+              <a:rPr lang="en-US" sz="5200" dirty="0"/>
+              <a:t>Finger Flexion Detection using </a:t>
+            </a:r>
+            <a:r>
+              <a:rPr lang="en-US" sz="5200" dirty="0" err="1"/>
+              <a:t>ECoG</a:t>
+            </a:r>
+            <a:r>
+              <a:rPr lang="en-US" sz="5200" dirty="0"/>
+              <a:t> signals</a:t>
+            </a:r>
+            <a:endParaRPr lang="es-CL" sz="5200" dirty="0"/>
+          </a:p>
+        </p:txBody>
+      </p:sp>
+      <p:sp>
+        <p:nvSpPr>
+          <p:cNvPr id="4" name="Marcador de número de diapositiva 3">
+            <a:extLst>
+              <a:ext uri="{FF2B5EF4-FFF2-40B4-BE49-F238E27FC236}">
+                <a16:creationId xmlns:a16="http://schemas.microsoft.com/office/drawing/2014/main" id="{837A37C7-1DCF-B429-B3D4-7EAC422D2698}"/>
+              </a:ext>
+            </a:extLst>
+          </p:cNvPr>
+          <p:cNvSpPr>
+            <a:spLocks noGrp="1"/>
+          </p:cNvSpPr>
+          <p:nvPr>
+            <p:ph type="sldNum" sz="quarter" idx="12"/>
+          </p:nvPr>
+        </p:nvSpPr>
+        <p:spPr/>
+        <p:txBody>
+          <a:bodyPr/>
+          <a:lstStyle/>
+          <a:p>
+            <a:fld id="{29B47543-ED2D-461E-8250-4200DFF84A65}" type="slidenum">
+              <a:rPr lang="es-CL" smtClean="0"/>
+              <a:t>13</a:t>
+            </a:fld>
+            <a:endParaRPr lang="es-CL"/>
+          </a:p>
+        </p:txBody>
+      </p:sp>
+      <p:pic>
+        <p:nvPicPr>
+          <p:cNvPr id="1026" name="Picture 2">
+            <a:extLst>
+              <a:ext uri="{FF2B5EF4-FFF2-40B4-BE49-F238E27FC236}">
+                <a16:creationId xmlns:a16="http://schemas.microsoft.com/office/drawing/2014/main" id="{E4244C3B-5284-0F82-A6F9-63EB6AF6237C}"/>
+              </a:ext>
+            </a:extLst>
+          </p:cNvPr>
+          <p:cNvPicPr>
+            <a:picLocks noGrp="1" noChangeAspect="1" noChangeArrowheads="1"/>
+          </p:cNvPicPr>
+          <p:nvPr>
+            <p:ph idx="1"/>
+          </p:nvPr>
+        </p:nvPicPr>
+        <p:blipFill>
+          <a:blip r:embed="rId2">
+            <a:extLst>
+              <a:ext uri="{28A0092B-C50C-407E-A947-70E740481C1C}">
+                <a14:useLocalDpi xmlns:a14="http://schemas.microsoft.com/office/drawing/2010/main" val="0"/>
+              </a:ext>
+            </a:extLst>
+          </a:blip>
+          <a:srcRect/>
+          <a:stretch>
+            <a:fillRect/>
+          </a:stretch>
+        </p:blipFill>
+        <p:spPr bwMode="auto">
+          <a:xfrm>
+            <a:off x="1343667" y="1847850"/>
+            <a:ext cx="3789666" cy="4351338"/>
+          </a:xfrm>
+          <a:prstGeom prst="rect">
+            <a:avLst/>
+          </a:prstGeom>
+          <a:noFill/>
+          <a:extLst>
+            <a:ext uri="{909E8E84-426E-40DD-AFC4-6F175D3DCCD1}">
+              <a14:hiddenFill xmlns:a14="http://schemas.microsoft.com/office/drawing/2010/main">
+                <a:solidFill>
+                  <a:srgbClr val="FFFFFF"/>
+                </a:solidFill>
+              </a14:hiddenFill>
+            </a:ext>
+          </a:extLst>
+        </p:spPr>
+      </p:pic>
+      <p:pic>
+        <p:nvPicPr>
+          <p:cNvPr id="6" name="Imagen 5">
+            <a:extLst>
+              <a:ext uri="{FF2B5EF4-FFF2-40B4-BE49-F238E27FC236}">
+                <a16:creationId xmlns:a16="http://schemas.microsoft.com/office/drawing/2014/main" id="{B933A8FF-887C-7E24-05BA-60FF4E01EE33}"/>
+              </a:ext>
+            </a:extLst>
+          </p:cNvPr>
+          <p:cNvPicPr>
+            <a:picLocks noChangeAspect="1"/>
+          </p:cNvPicPr>
+          <p:nvPr/>
+        </p:nvPicPr>
+        <p:blipFill>
+          <a:blip r:embed="rId3"/>
+          <a:stretch>
+            <a:fillRect/>
+          </a:stretch>
+        </p:blipFill>
+        <p:spPr>
+          <a:xfrm>
+            <a:off x="9082675" y="0"/>
+            <a:ext cx="2006868" cy="6858000"/>
+          </a:xfrm>
+          <a:prstGeom prst="rect">
+            <a:avLst/>
+          </a:prstGeom>
+        </p:spPr>
+      </p:pic>
+    </p:spTree>
+    <p:extLst>
+      <p:ext uri="{BB962C8B-B14F-4D97-AF65-F5344CB8AC3E}">
+        <p14:creationId xmlns:p14="http://schemas.microsoft.com/office/powerpoint/2010/main" val="2441359970"/>
+      </p:ext>
+    </p:extLst>
+  </p:cSld>
+  <p:clrMapOvr>
+    <a:masterClrMapping/>
+  </p:clrMapOvr>
+</p:sld>
+</file>
+
+<file path=ppt/slides/slide14.xml><?xml version="1.0" encoding="utf-8"?>
+<p:sld xmlns:a="http://schemas.openxmlformats.org/drawingml/2006/main" xmlns:r="http://schemas.openxmlformats.org/officeDocument/2006/relationships" xmlns:p="http://schemas.openxmlformats.org/presentationml/2006/main">
+  <p:cSld>
+    <p:spTree>
+      <p:nvGrpSpPr>
+        <p:cNvPr id="1" name=""/>
+        <p:cNvGrpSpPr/>
+        <p:nvPr/>
+      </p:nvGrpSpPr>
+      <p:grpSpPr>
+        <a:xfrm>
+          <a:off x="0" y="0"/>
+          <a:ext cx="0" cy="0"/>
+          <a:chOff x="0" y="0"/>
+          <a:chExt cx="0" cy="0"/>
+        </a:xfrm>
+      </p:grpSpPr>
+      <p:sp>
+        <p:nvSpPr>
+          <p:cNvPr id="2" name="Título 1">
+            <a:extLst>
+              <a:ext uri="{FF2B5EF4-FFF2-40B4-BE49-F238E27FC236}">
                 <a16:creationId xmlns:a16="http://schemas.microsoft.com/office/drawing/2014/main" id="{0E97DE3A-30FE-11B7-A53F-B10ECD315D3F}"/>
               </a:ext>
             </a:extLst>
@@ -7055,7 +7248,7 @@
           <a:p>
             <a:fld id="{29B47543-ED2D-461E-8250-4200DFF84A65}" type="slidenum">
               <a:rPr lang="es-CL" smtClean="0"/>
-              <a:t>13</a:t>
+              <a:t>14</a:t>
             </a:fld>
             <a:endParaRPr lang="es-CL"/>
           </a:p>
@@ -7104,7 +7297,7 @@
 </p:sld>
 </file>
 
-<file path=ppt/slides/slide14.xml><?xml version="1.0" encoding="utf-8"?>
+<file path=ppt/slides/slide15.xml><?xml version="1.0" encoding="utf-8"?>
 <p:sld xmlns:a="http://schemas.openxmlformats.org/drawingml/2006/main" xmlns:r="http://schemas.openxmlformats.org/officeDocument/2006/relationships" xmlns:p="http://schemas.openxmlformats.org/presentationml/2006/main">
   <p:cSld>
     <p:spTree>
@@ -7202,7 +7395,7 @@
           <a:p>
             <a:fld id="{29B47543-ED2D-461E-8250-4200DFF84A65}" type="slidenum">
               <a:rPr lang="es-CL" smtClean="0"/>
-              <a:t>14</a:t>
+              <a:t>15</a:t>
             </a:fld>
             <a:endParaRPr lang="es-CL"/>
           </a:p>
@@ -7242,6 +7435,408 @@
     <p:extLst>
       <p:ext uri="{BB962C8B-B14F-4D97-AF65-F5344CB8AC3E}">
         <p14:creationId xmlns:p14="http://schemas.microsoft.com/office/powerpoint/2010/main" val="3600613726"/>
+      </p:ext>
+    </p:extLst>
+  </p:cSld>
+  <p:clrMapOvr>
+    <a:masterClrMapping/>
+  </p:clrMapOvr>
+</p:sld>
+</file>
+
+<file path=ppt/slides/slide16.xml><?xml version="1.0" encoding="utf-8"?>
+<p:sld xmlns:a="http://schemas.openxmlformats.org/drawingml/2006/main" xmlns:r="http://schemas.openxmlformats.org/officeDocument/2006/relationships" xmlns:p="http://schemas.openxmlformats.org/presentationml/2006/main">
+  <p:cSld>
+    <p:spTree>
+      <p:nvGrpSpPr>
+        <p:cNvPr id="1" name="">
+          <a:extLst>
+            <a:ext uri="{FF2B5EF4-FFF2-40B4-BE49-F238E27FC236}">
+              <a16:creationId xmlns:a16="http://schemas.microsoft.com/office/drawing/2014/main" id="{A1AB2C90-4093-2C44-F77E-13B0FFDE50FF}"/>
+            </a:ext>
+          </a:extLst>
+        </p:cNvPr>
+        <p:cNvGrpSpPr/>
+        <p:nvPr/>
+      </p:nvGrpSpPr>
+      <p:grpSpPr>
+        <a:xfrm>
+          <a:off x="0" y="0"/>
+          <a:ext cx="0" cy="0"/>
+          <a:chOff x="0" y="0"/>
+          <a:chExt cx="0" cy="0"/>
+        </a:xfrm>
+      </p:grpSpPr>
+      <p:sp>
+        <p:nvSpPr>
+          <p:cNvPr id="8" name="Título 7">
+            <a:extLst>
+              <a:ext uri="{FF2B5EF4-FFF2-40B4-BE49-F238E27FC236}">
+                <a16:creationId xmlns:a16="http://schemas.microsoft.com/office/drawing/2014/main" id="{04616302-BA73-D737-A8B1-F42AAC9FCED9}"/>
+              </a:ext>
+            </a:extLst>
+          </p:cNvPr>
+          <p:cNvSpPr>
+            <a:spLocks noGrp="1"/>
+          </p:cNvSpPr>
+          <p:nvPr>
+            <p:ph type="title"/>
+          </p:nvPr>
+        </p:nvSpPr>
+        <p:spPr/>
+        <p:txBody>
+          <a:bodyPr/>
+          <a:lstStyle/>
+          <a:p>
+            <a:r>
+              <a:rPr lang="es-MX" dirty="0"/>
+              <a:t>Comparación precisión completa y cuantizada</a:t>
+            </a:r>
+            <a:endParaRPr lang="es-CL" dirty="0"/>
+          </a:p>
+        </p:txBody>
+      </p:sp>
+      <p:sp>
+        <p:nvSpPr>
+          <p:cNvPr id="9" name="Marcador de texto 8">
+            <a:extLst>
+              <a:ext uri="{FF2B5EF4-FFF2-40B4-BE49-F238E27FC236}">
+                <a16:creationId xmlns:a16="http://schemas.microsoft.com/office/drawing/2014/main" id="{B672413E-D5F8-F5F1-B8E4-5E42CECEE1C0}"/>
+              </a:ext>
+            </a:extLst>
+          </p:cNvPr>
+          <p:cNvSpPr>
+            <a:spLocks noGrp="1"/>
+          </p:cNvSpPr>
+          <p:nvPr>
+            <p:ph type="body" idx="1"/>
+          </p:nvPr>
+        </p:nvSpPr>
+        <p:spPr/>
+        <p:txBody>
+          <a:bodyPr/>
+          <a:lstStyle/>
+          <a:p>
+            <a:r>
+              <a:rPr lang="es-MX" dirty="0"/>
+              <a:t>float32</a:t>
+            </a:r>
+            <a:endParaRPr lang="es-CL" dirty="0"/>
+          </a:p>
+        </p:txBody>
+      </p:sp>
+      <p:sp>
+        <p:nvSpPr>
+          <p:cNvPr id="10" name="Marcador de texto 9">
+            <a:extLst>
+              <a:ext uri="{FF2B5EF4-FFF2-40B4-BE49-F238E27FC236}">
+                <a16:creationId xmlns:a16="http://schemas.microsoft.com/office/drawing/2014/main" id="{29A407B7-CA8B-3B63-175D-C34004E0E8F7}"/>
+              </a:ext>
+            </a:extLst>
+          </p:cNvPr>
+          <p:cNvSpPr>
+            <a:spLocks noGrp="1"/>
+          </p:cNvSpPr>
+          <p:nvPr>
+            <p:ph type="body" sz="quarter" idx="3"/>
+          </p:nvPr>
+        </p:nvSpPr>
+        <p:spPr/>
+        <p:txBody>
+          <a:bodyPr/>
+          <a:lstStyle/>
+          <a:p>
+            <a:r>
+              <a:rPr lang="es-MX" dirty="0"/>
+              <a:t>int8 (solo pesos)</a:t>
+            </a:r>
+            <a:endParaRPr lang="es-CL" dirty="0"/>
+          </a:p>
+        </p:txBody>
+      </p:sp>
+      <p:sp>
+        <p:nvSpPr>
+          <p:cNvPr id="4" name="Marcador de número de diapositiva 3">
+            <a:extLst>
+              <a:ext uri="{FF2B5EF4-FFF2-40B4-BE49-F238E27FC236}">
+                <a16:creationId xmlns:a16="http://schemas.microsoft.com/office/drawing/2014/main" id="{58661D48-2CAD-4BD8-182E-C866F56550B5}"/>
+              </a:ext>
+            </a:extLst>
+          </p:cNvPr>
+          <p:cNvSpPr>
+            <a:spLocks noGrp="1"/>
+          </p:cNvSpPr>
+          <p:nvPr>
+            <p:ph type="sldNum" sz="quarter" idx="12"/>
+          </p:nvPr>
+        </p:nvSpPr>
+        <p:spPr/>
+        <p:txBody>
+          <a:bodyPr/>
+          <a:lstStyle/>
+          <a:p>
+            <a:fld id="{29B47543-ED2D-461E-8250-4200DFF84A65}" type="slidenum">
+              <a:rPr lang="es-CL" smtClean="0"/>
+              <a:t>16</a:t>
+            </a:fld>
+            <a:endParaRPr lang="es-CL"/>
+          </a:p>
+        </p:txBody>
+      </p:sp>
+      <p:pic>
+        <p:nvPicPr>
+          <p:cNvPr id="11" name="Marcador de contenido 5">
+            <a:extLst>
+              <a:ext uri="{FF2B5EF4-FFF2-40B4-BE49-F238E27FC236}">
+                <a16:creationId xmlns:a16="http://schemas.microsoft.com/office/drawing/2014/main" id="{03494B9A-3AF1-96FF-D1F9-75025CA29D9B}"/>
+              </a:ext>
+            </a:extLst>
+          </p:cNvPr>
+          <p:cNvPicPr>
+            <a:picLocks noGrp="1" noChangeAspect="1"/>
+          </p:cNvPicPr>
+          <p:nvPr>
+            <p:ph sz="half" idx="2"/>
+          </p:nvPr>
+        </p:nvPicPr>
+        <p:blipFill>
+          <a:blip r:embed="rId2"/>
+          <a:srcRect r="37265"/>
+          <a:stretch>
+            <a:fillRect/>
+          </a:stretch>
+        </p:blipFill>
+        <p:spPr>
+          <a:xfrm>
+            <a:off x="1320229" y="2505075"/>
+            <a:ext cx="4196904" cy="3684588"/>
+          </a:xfrm>
+          <a:prstGeom prst="rect">
+            <a:avLst/>
+          </a:prstGeom>
+        </p:spPr>
+      </p:pic>
+      <p:pic>
+        <p:nvPicPr>
+          <p:cNvPr id="16" name="Marcador de contenido 5">
+            <a:extLst>
+              <a:ext uri="{FF2B5EF4-FFF2-40B4-BE49-F238E27FC236}">
+                <a16:creationId xmlns:a16="http://schemas.microsoft.com/office/drawing/2014/main" id="{052A9977-CE41-1E28-9213-E9911AC0E201}"/>
+              </a:ext>
+            </a:extLst>
+          </p:cNvPr>
+          <p:cNvPicPr>
+            <a:picLocks noGrp="1" noChangeAspect="1"/>
+          </p:cNvPicPr>
+          <p:nvPr>
+            <p:ph sz="quarter" idx="4"/>
+          </p:nvPr>
+        </p:nvPicPr>
+        <p:blipFill>
+          <a:blip r:embed="rId3"/>
+          <a:srcRect r="40820"/>
+          <a:stretch>
+            <a:fillRect/>
+          </a:stretch>
+        </p:blipFill>
+        <p:spPr>
+          <a:xfrm>
+            <a:off x="6653228" y="2505075"/>
+            <a:ext cx="4221132" cy="3684588"/>
+          </a:xfrm>
+          <a:prstGeom prst="rect">
+            <a:avLst/>
+          </a:prstGeom>
+        </p:spPr>
+      </p:pic>
+    </p:spTree>
+    <p:extLst>
+      <p:ext uri="{BB962C8B-B14F-4D97-AF65-F5344CB8AC3E}">
+        <p14:creationId xmlns:p14="http://schemas.microsoft.com/office/powerpoint/2010/main" val="68517548"/>
+      </p:ext>
+    </p:extLst>
+  </p:cSld>
+  <p:clrMapOvr>
+    <a:masterClrMapping/>
+  </p:clrMapOvr>
+</p:sld>
+</file>
+
+<file path=ppt/slides/slide17.xml><?xml version="1.0" encoding="utf-8"?>
+<p:sld xmlns:a="http://schemas.openxmlformats.org/drawingml/2006/main" xmlns:r="http://schemas.openxmlformats.org/officeDocument/2006/relationships" xmlns:p="http://schemas.openxmlformats.org/presentationml/2006/main">
+  <p:cSld>
+    <p:spTree>
+      <p:nvGrpSpPr>
+        <p:cNvPr id="1" name=""/>
+        <p:cNvGrpSpPr/>
+        <p:nvPr/>
+      </p:nvGrpSpPr>
+      <p:grpSpPr>
+        <a:xfrm>
+          <a:off x="0" y="0"/>
+          <a:ext cx="0" cy="0"/>
+          <a:chOff x="0" y="0"/>
+          <a:chExt cx="0" cy="0"/>
+        </a:xfrm>
+      </p:grpSpPr>
+      <p:sp>
+        <p:nvSpPr>
+          <p:cNvPr id="2" name="Título 1">
+            <a:extLst>
+              <a:ext uri="{FF2B5EF4-FFF2-40B4-BE49-F238E27FC236}">
+                <a16:creationId xmlns:a16="http://schemas.microsoft.com/office/drawing/2014/main" id="{1E9AB0CD-461A-85CA-6D85-80D578ABE015}"/>
+              </a:ext>
+            </a:extLst>
+          </p:cNvPr>
+          <p:cNvSpPr>
+            <a:spLocks noGrp="1"/>
+          </p:cNvSpPr>
+          <p:nvPr>
+            <p:ph type="title"/>
+          </p:nvPr>
+        </p:nvSpPr>
+        <p:spPr/>
+        <p:txBody>
+          <a:bodyPr/>
+          <a:lstStyle/>
+          <a:p>
+            <a:endParaRPr lang="es-CL"/>
+          </a:p>
+        </p:txBody>
+      </p:sp>
+      <p:sp>
+        <p:nvSpPr>
+          <p:cNvPr id="3" name="Marcador de texto 2">
+            <a:extLst>
+              <a:ext uri="{FF2B5EF4-FFF2-40B4-BE49-F238E27FC236}">
+                <a16:creationId xmlns:a16="http://schemas.microsoft.com/office/drawing/2014/main" id="{5DA08BCD-E184-33F4-267B-6208FCAE658F}"/>
+              </a:ext>
+            </a:extLst>
+          </p:cNvPr>
+          <p:cNvSpPr>
+            <a:spLocks noGrp="1"/>
+          </p:cNvSpPr>
+          <p:nvPr>
+            <p:ph type="body" idx="1"/>
+          </p:nvPr>
+        </p:nvSpPr>
+        <p:spPr/>
+        <p:txBody>
+          <a:bodyPr/>
+          <a:lstStyle/>
+          <a:p>
+            <a:endParaRPr lang="es-CL"/>
+          </a:p>
+        </p:txBody>
+      </p:sp>
+      <p:sp>
+        <p:nvSpPr>
+          <p:cNvPr id="4" name="Marcador de contenido 3">
+            <a:extLst>
+              <a:ext uri="{FF2B5EF4-FFF2-40B4-BE49-F238E27FC236}">
+                <a16:creationId xmlns:a16="http://schemas.microsoft.com/office/drawing/2014/main" id="{2100754F-F9E1-21F8-26F7-6339562859CD}"/>
+              </a:ext>
+            </a:extLst>
+          </p:cNvPr>
+          <p:cNvSpPr>
+            <a:spLocks noGrp="1"/>
+          </p:cNvSpPr>
+          <p:nvPr>
+            <p:ph sz="half" idx="2"/>
+          </p:nvPr>
+        </p:nvSpPr>
+        <p:spPr/>
+        <p:txBody>
+          <a:bodyPr/>
+          <a:lstStyle/>
+          <a:p>
+            <a:endParaRPr lang="es-CL"/>
+          </a:p>
+        </p:txBody>
+      </p:sp>
+      <p:sp>
+        <p:nvSpPr>
+          <p:cNvPr id="5" name="Marcador de texto 4">
+            <a:extLst>
+              <a:ext uri="{FF2B5EF4-FFF2-40B4-BE49-F238E27FC236}">
+                <a16:creationId xmlns:a16="http://schemas.microsoft.com/office/drawing/2014/main" id="{417E75EA-8371-C63D-CF85-056D09749E86}"/>
+              </a:ext>
+            </a:extLst>
+          </p:cNvPr>
+          <p:cNvSpPr>
+            <a:spLocks noGrp="1"/>
+          </p:cNvSpPr>
+          <p:nvPr>
+            <p:ph type="body" sz="quarter" idx="3"/>
+          </p:nvPr>
+        </p:nvSpPr>
+        <p:spPr/>
+        <p:txBody>
+          <a:bodyPr/>
+          <a:lstStyle/>
+          <a:p>
+            <a:endParaRPr lang="es-CL"/>
+          </a:p>
+        </p:txBody>
+      </p:sp>
+      <p:sp>
+        <p:nvSpPr>
+          <p:cNvPr id="6" name="Marcador de contenido 5">
+            <a:extLst>
+              <a:ext uri="{FF2B5EF4-FFF2-40B4-BE49-F238E27FC236}">
+                <a16:creationId xmlns:a16="http://schemas.microsoft.com/office/drawing/2014/main" id="{F8451E4A-9747-69B0-D836-7849CC69617F}"/>
+              </a:ext>
+            </a:extLst>
+          </p:cNvPr>
+          <p:cNvSpPr>
+            <a:spLocks noGrp="1"/>
+          </p:cNvSpPr>
+          <p:nvPr>
+            <p:ph sz="quarter" idx="4"/>
+          </p:nvPr>
+        </p:nvSpPr>
+        <p:spPr/>
+        <p:txBody>
+          <a:bodyPr/>
+          <a:lstStyle/>
+          <a:p>
+            <a:endParaRPr lang="es-CL"/>
+          </a:p>
+        </p:txBody>
+      </p:sp>
+      <p:sp>
+        <p:nvSpPr>
+          <p:cNvPr id="7" name="Marcador de número de diapositiva 6">
+            <a:extLst>
+              <a:ext uri="{FF2B5EF4-FFF2-40B4-BE49-F238E27FC236}">
+                <a16:creationId xmlns:a16="http://schemas.microsoft.com/office/drawing/2014/main" id="{359E9C2D-5D10-900D-3E3F-9174CB9CB103}"/>
+              </a:ext>
+            </a:extLst>
+          </p:cNvPr>
+          <p:cNvSpPr>
+            <a:spLocks noGrp="1"/>
+          </p:cNvSpPr>
+          <p:nvPr>
+            <p:ph type="sldNum" sz="quarter" idx="12"/>
+          </p:nvPr>
+        </p:nvSpPr>
+        <p:spPr/>
+        <p:txBody>
+          <a:bodyPr/>
+          <a:lstStyle/>
+          <a:p>
+            <a:fld id="{29B47543-ED2D-461E-8250-4200DFF84A65}" type="slidenum">
+              <a:rPr lang="es-CL" smtClean="0"/>
+              <a:t>17</a:t>
+            </a:fld>
+            <a:endParaRPr lang="es-CL"/>
+          </a:p>
+        </p:txBody>
+      </p:sp>
+    </p:spTree>
+    <p:extLst>
+      <p:ext uri="{BB962C8B-B14F-4D97-AF65-F5344CB8AC3E}">
+        <p14:creationId xmlns:p14="http://schemas.microsoft.com/office/powerpoint/2010/main" val="3977960472"/>
       </p:ext>
     </p:extLst>
   </p:cSld>
@@ -7998,7 +8593,7 @@
           <a:p>
             <a:r>
               <a:rPr lang="es-MX" dirty="0"/>
-              <a:t>Comparación con y sin cuantizar</a:t>
+              <a:t>Comparación precisión completa y cuantizada</a:t>
             </a:r>
             <a:endParaRPr lang="es-CL" dirty="0"/>
           </a:p>
@@ -8324,8 +8919,8 @@
           </a:p>
         </p:txBody>
       </p:sp>
-      <mc:AlternateContent xmlns:mc="http://schemas.openxmlformats.org/markup-compatibility/2006">
-        <mc:Choice xmlns:a14="http://schemas.microsoft.com/office/drawing/2010/main" Requires="a14">
+      <mc:AlternateContent xmlns:mc="http://schemas.openxmlformats.org/markup-compatibility/2006" xmlns:a14="http://schemas.microsoft.com/office/drawing/2010/main">
+        <mc:Choice Requires="a14">
           <p:sp>
             <p:nvSpPr>
               <p:cNvPr id="9" name="Marcador de contenido 8">
@@ -8575,7 +9170,7 @@
             </p:txBody>
           </p:sp>
         </mc:Choice>
-        <mc:Fallback>
+        <mc:Fallback xmlns="">
           <p:sp>
             <p:nvSpPr>
               <p:cNvPr id="9" name="Marcador de contenido 8">
@@ -9268,20 +9863,20 @@
 </file>
 
 <file path=customXml/item1.xml><?xml version="1.0" encoding="utf-8"?>
+<p:properties xmlns:p="http://schemas.microsoft.com/office/2006/metadata/properties" xmlns:xsi="http://www.w3.org/2001/XMLSchema-instance" xmlns:pc="http://schemas.microsoft.com/office/infopath/2007/PartnerControls">
+  <documentManagement>
+    <_activity xmlns="1ca73e69-5c0b-48ea-a835-779e1875cab4" xsi:nil="true"/>
+  </documentManagement>
+</p:properties>
+</file>
+
+<file path=customXml/item2.xml><?xml version="1.0" encoding="utf-8"?>
 <?mso-contentType ?>
 <FormTemplates xmlns="http://schemas.microsoft.com/sharepoint/v3/contenttype/forms">
   <Display>DocumentLibraryForm</Display>
   <Edit>DocumentLibraryForm</Edit>
   <New>DocumentLibraryForm</New>
 </FormTemplates>
-</file>
-
-<file path=customXml/item2.xml><?xml version="1.0" encoding="utf-8"?>
-<p:properties xmlns:p="http://schemas.microsoft.com/office/2006/metadata/properties" xmlns:xsi="http://www.w3.org/2001/XMLSchema-instance" xmlns:pc="http://schemas.microsoft.com/office/infopath/2007/PartnerControls">
-  <documentManagement>
-    <_activity xmlns="1ca73e69-5c0b-48ea-a835-779e1875cab4" xsi:nil="true"/>
-  </documentManagement>
-</p:properties>
 </file>
 
 <file path=customXml/item3.xml><?xml version="1.0" encoding="utf-8"?>
@@ -9512,14 +10107,6 @@
 </file>
 
 <file path=customXml/itemProps1.xml><?xml version="1.0" encoding="utf-8"?>
-<ds:datastoreItem xmlns:ds="http://schemas.openxmlformats.org/officeDocument/2006/customXml" ds:itemID="{7C14A90D-02DD-47F0-BF02-A623F5D74365}">
-  <ds:schemaRefs>
-    <ds:schemaRef ds:uri="http://schemas.microsoft.com/sharepoint/v3/contenttype/forms"/>
-  </ds:schemaRefs>
-</ds:datastoreItem>
-</file>
-
-<file path=customXml/itemProps2.xml><?xml version="1.0" encoding="utf-8"?>
 <ds:datastoreItem xmlns:ds="http://schemas.openxmlformats.org/officeDocument/2006/customXml" ds:itemID="{64D3A0E1-0556-456A-B99D-21EE789AEAD0}">
   <ds:schemaRefs>
     <ds:schemaRef ds:uri="1ca73e69-5c0b-48ea-a835-779e1875cab4"/>
@@ -9532,6 +10119,14 @@
     <ds:schemaRef ds:uri="http://schemas.microsoft.com/office/infopath/2007/PartnerControls"/>
     <ds:schemaRef ds:uri="http://schemas.openxmlformats.org/package/2006/metadata/core-properties"/>
     <ds:schemaRef ds:uri="http://purl.org/dc/terms/"/>
+  </ds:schemaRefs>
+</ds:datastoreItem>
+</file>
+
+<file path=customXml/itemProps2.xml><?xml version="1.0" encoding="utf-8"?>
+<ds:datastoreItem xmlns:ds="http://schemas.openxmlformats.org/officeDocument/2006/customXml" ds:itemID="{7C14A90D-02DD-47F0-BF02-A623F5D74365}">
+  <ds:schemaRefs>
+    <ds:schemaRef ds:uri="http://schemas.microsoft.com/sharepoint/v3/contenttype/forms"/>
   </ds:schemaRefs>
 </ds:datastoreItem>
 </file>

</xml_diff>

<commit_message>
Subject 2, 5 fingers in .ioc
</commit_message>
<xml_diff>
--- a/Edge Computing para Control Biónico con Señales Cerebrales.pptx
+++ b/Edge Computing para Control Biónico con Señales Cerebrales.pptx
@@ -5,7 +5,7 @@
     <p:sldMasterId id="2147483648" r:id="rId4"/>
   </p:sldMasterIdLst>
   <p:notesMasterIdLst>
-    <p:notesMasterId r:id="rId22"/>
+    <p:notesMasterId r:id="rId28"/>
   </p:notesMasterIdLst>
   <p:sldIdLst>
     <p:sldId id="256" r:id="rId5"/>
@@ -24,7 +24,13 @@
     <p:sldId id="295" r:id="rId18"/>
     <p:sldId id="296" r:id="rId19"/>
     <p:sldId id="298" r:id="rId20"/>
-    <p:sldId id="299" r:id="rId21"/>
+    <p:sldId id="301" r:id="rId21"/>
+    <p:sldId id="302" r:id="rId22"/>
+    <p:sldId id="303" r:id="rId23"/>
+    <p:sldId id="306" r:id="rId24"/>
+    <p:sldId id="307" r:id="rId25"/>
+    <p:sldId id="305" r:id="rId26"/>
+    <p:sldId id="299" r:id="rId27"/>
   </p:sldIdLst>
   <p:sldSz cx="12192000" cy="6858000"/>
   <p:notesSz cx="6858000" cy="9144000"/>
@@ -2749,7 +2755,7 @@
           <a:p>
             <a:fld id="{9D46E1BC-9D70-4B9E-9845-30E6A0E439DE}" type="datetimeFigureOut">
               <a:rPr lang="es-CL" smtClean="0"/>
-              <a:t>19-06-2025</a:t>
+              <a:t>30-06-2025</a:t>
             </a:fld>
             <a:endParaRPr lang="es-CL"/>
           </a:p>
@@ -3265,7 +3271,7 @@
           <a:p>
             <a:fld id="{3057AFD2-2E50-47EA-8313-7EE0BF4DB844}" type="datetime1">
               <a:rPr lang="es-CL" smtClean="0"/>
-              <a:t>19-06-2025</a:t>
+              <a:t>30-06-2025</a:t>
             </a:fld>
             <a:endParaRPr lang="es-CL"/>
           </a:p>
@@ -3465,7 +3471,7 @@
           <a:p>
             <a:fld id="{9ABB4C2D-AC9D-4A03-9EA0-41CC1E8B638D}" type="datetime1">
               <a:rPr lang="es-CL" smtClean="0"/>
-              <a:t>19-06-2025</a:t>
+              <a:t>30-06-2025</a:t>
             </a:fld>
             <a:endParaRPr lang="es-CL"/>
           </a:p>
@@ -3675,7 +3681,7 @@
           <a:p>
             <a:fld id="{4491CB44-4C5E-4FE6-A739-2EEEC509E2E3}" type="datetime1">
               <a:rPr lang="es-CL" smtClean="0"/>
-              <a:t>19-06-2025</a:t>
+              <a:t>30-06-2025</a:t>
             </a:fld>
             <a:endParaRPr lang="es-CL"/>
           </a:p>
@@ -3875,7 +3881,7 @@
           <a:p>
             <a:fld id="{C635104C-855C-4B6C-890D-4AB2CA091A63}" type="datetime1">
               <a:rPr lang="es-CL" smtClean="0"/>
-              <a:t>19-06-2025</a:t>
+              <a:t>30-06-2025</a:t>
             </a:fld>
             <a:endParaRPr lang="es-CL"/>
           </a:p>
@@ -4151,7 +4157,7 @@
           <a:p>
             <a:fld id="{2CA4F56F-FFB5-4D4F-8157-A3F6E1208686}" type="datetime1">
               <a:rPr lang="es-CL" smtClean="0"/>
-              <a:t>19-06-2025</a:t>
+              <a:t>30-06-2025</a:t>
             </a:fld>
             <a:endParaRPr lang="es-CL"/>
           </a:p>
@@ -4419,7 +4425,7 @@
           <a:p>
             <a:fld id="{0FBFB81C-3238-4E55-BBDB-ABD3B47D33C3}" type="datetime1">
               <a:rPr lang="es-CL" smtClean="0"/>
-              <a:t>19-06-2025</a:t>
+              <a:t>30-06-2025</a:t>
             </a:fld>
             <a:endParaRPr lang="es-CL"/>
           </a:p>
@@ -4834,7 +4840,7 @@
           <a:p>
             <a:fld id="{9142CA42-5823-44DC-A2D8-66A69FC1D8A5}" type="datetime1">
               <a:rPr lang="es-CL" smtClean="0"/>
-              <a:t>19-06-2025</a:t>
+              <a:t>30-06-2025</a:t>
             </a:fld>
             <a:endParaRPr lang="es-CL"/>
           </a:p>
@@ -4976,7 +4982,7 @@
           <a:p>
             <a:fld id="{08679031-1A41-476F-B818-FB293F04499D}" type="datetime1">
               <a:rPr lang="es-CL" smtClean="0"/>
-              <a:t>19-06-2025</a:t>
+              <a:t>30-06-2025</a:t>
             </a:fld>
             <a:endParaRPr lang="es-CL"/>
           </a:p>
@@ -5089,7 +5095,7 @@
           <a:p>
             <a:fld id="{D8AE8DE8-1FED-46DA-9654-E74B4A7C5DEA}" type="datetime1">
               <a:rPr lang="es-CL" smtClean="0"/>
-              <a:t>19-06-2025</a:t>
+              <a:t>30-06-2025</a:t>
             </a:fld>
             <a:endParaRPr lang="es-CL"/>
           </a:p>
@@ -5402,7 +5408,7 @@
           <a:p>
             <a:fld id="{DC537023-F69E-4452-B72E-2DEE3AFB9C53}" type="datetime1">
               <a:rPr lang="es-CL" smtClean="0"/>
-              <a:t>19-06-2025</a:t>
+              <a:t>30-06-2025</a:t>
             </a:fld>
             <a:endParaRPr lang="es-CL"/>
           </a:p>
@@ -5691,7 +5697,7 @@
           <a:p>
             <a:fld id="{81819FF8-2823-4B85-80F1-6DE0C3C2B12E}" type="datetime1">
               <a:rPr lang="es-CL" smtClean="0"/>
-              <a:t>19-06-2025</a:t>
+              <a:t>30-06-2025</a:t>
             </a:fld>
             <a:endParaRPr lang="es-CL"/>
           </a:p>
@@ -5934,7 +5940,7 @@
           <a:p>
             <a:fld id="{A8AC9CAF-9571-4308-BC43-45FC52060C70}" type="datetime1">
               <a:rPr lang="es-CL" smtClean="0"/>
-              <a:t>19-06-2025</a:t>
+              <a:t>30-06-2025</a:t>
             </a:fld>
             <a:endParaRPr lang="es-CL"/>
           </a:p>
@@ -7667,7 +7673,13 @@
   <p:cSld>
     <p:spTree>
       <p:nvGrpSpPr>
-        <p:cNvPr id="1" name=""/>
+        <p:cNvPr id="1" name="">
+          <a:extLst>
+            <a:ext uri="{FF2B5EF4-FFF2-40B4-BE49-F238E27FC236}">
+              <a16:creationId xmlns:a16="http://schemas.microsoft.com/office/drawing/2014/main" id="{55F34B0D-2DD5-9427-6E4A-460A36A7AB14}"/>
+            </a:ext>
+          </a:extLst>
+        </p:cNvPr>
         <p:cNvGrpSpPr/>
         <p:nvPr/>
       </p:nvGrpSpPr>
@@ -7684,7 +7696,7 @@
           <p:cNvPr id="2" name="Título 1">
             <a:extLst>
               <a:ext uri="{FF2B5EF4-FFF2-40B4-BE49-F238E27FC236}">
-                <a16:creationId xmlns:a16="http://schemas.microsoft.com/office/drawing/2014/main" id="{1E9AB0CD-461A-85CA-6D85-80D578ABE015}"/>
+                <a16:creationId xmlns:a16="http://schemas.microsoft.com/office/drawing/2014/main" id="{D3DE5A06-2365-5D4B-E3C2-AF15ABBA429F}"/>
               </a:ext>
             </a:extLst>
           </p:cNvPr>
@@ -7695,121 +7707,40 @@
             <p:ph type="title"/>
           </p:nvPr>
         </p:nvSpPr>
-        <p:spPr/>
-        <p:txBody>
-          <a:bodyPr/>
-          <a:lstStyle/>
-          <a:p>
-            <a:endParaRPr lang="es-CL"/>
-          </a:p>
-        </p:txBody>
-      </p:sp>
-      <p:sp>
-        <p:nvSpPr>
-          <p:cNvPr id="3" name="Marcador de texto 2">
-            <a:extLst>
-              <a:ext uri="{FF2B5EF4-FFF2-40B4-BE49-F238E27FC236}">
-                <a16:creationId xmlns:a16="http://schemas.microsoft.com/office/drawing/2014/main" id="{5DA08BCD-E184-33F4-267B-6208FCAE658F}"/>
-              </a:ext>
-            </a:extLst>
-          </p:cNvPr>
-          <p:cNvSpPr>
-            <a:spLocks noGrp="1"/>
-          </p:cNvSpPr>
-          <p:nvPr>
-            <p:ph type="body" idx="1"/>
-          </p:nvPr>
-        </p:nvSpPr>
-        <p:spPr/>
-        <p:txBody>
-          <a:bodyPr/>
-          <a:lstStyle/>
-          <a:p>
-            <a:endParaRPr lang="es-CL"/>
-          </a:p>
-        </p:txBody>
-      </p:sp>
-      <p:sp>
-        <p:nvSpPr>
-          <p:cNvPr id="4" name="Marcador de contenido 3">
-            <a:extLst>
-              <a:ext uri="{FF2B5EF4-FFF2-40B4-BE49-F238E27FC236}">
-                <a16:creationId xmlns:a16="http://schemas.microsoft.com/office/drawing/2014/main" id="{2100754F-F9E1-21F8-26F7-6339562859CD}"/>
-              </a:ext>
-            </a:extLst>
-          </p:cNvPr>
-          <p:cNvSpPr>
-            <a:spLocks noGrp="1"/>
-          </p:cNvSpPr>
-          <p:nvPr>
-            <p:ph sz="half" idx="2"/>
-          </p:nvPr>
-        </p:nvSpPr>
-        <p:spPr/>
-        <p:txBody>
-          <a:bodyPr/>
-          <a:lstStyle/>
-          <a:p>
-            <a:endParaRPr lang="es-CL"/>
-          </a:p>
-        </p:txBody>
-      </p:sp>
-      <p:sp>
-        <p:nvSpPr>
-          <p:cNvPr id="5" name="Marcador de texto 4">
-            <a:extLst>
-              <a:ext uri="{FF2B5EF4-FFF2-40B4-BE49-F238E27FC236}">
-                <a16:creationId xmlns:a16="http://schemas.microsoft.com/office/drawing/2014/main" id="{417E75EA-8371-C63D-CF85-056D09749E86}"/>
-              </a:ext>
-            </a:extLst>
-          </p:cNvPr>
-          <p:cNvSpPr>
-            <a:spLocks noGrp="1"/>
-          </p:cNvSpPr>
-          <p:nvPr>
-            <p:ph type="body" sz="quarter" idx="3"/>
-          </p:nvPr>
-        </p:nvSpPr>
-        <p:spPr/>
-        <p:txBody>
-          <a:bodyPr/>
-          <a:lstStyle/>
-          <a:p>
-            <a:endParaRPr lang="es-CL"/>
-          </a:p>
-        </p:txBody>
-      </p:sp>
-      <p:sp>
-        <p:nvSpPr>
-          <p:cNvPr id="6" name="Marcador de contenido 5">
-            <a:extLst>
-              <a:ext uri="{FF2B5EF4-FFF2-40B4-BE49-F238E27FC236}">
-                <a16:creationId xmlns:a16="http://schemas.microsoft.com/office/drawing/2014/main" id="{F8451E4A-9747-69B0-D836-7849CC69617F}"/>
-              </a:ext>
-            </a:extLst>
-          </p:cNvPr>
-          <p:cNvSpPr>
-            <a:spLocks noGrp="1"/>
-          </p:cNvSpPr>
-          <p:nvPr>
-            <p:ph sz="quarter" idx="4"/>
-          </p:nvPr>
-        </p:nvSpPr>
-        <p:spPr/>
-        <p:txBody>
-          <a:bodyPr/>
-          <a:lstStyle/>
-          <a:p>
-            <a:endParaRPr lang="es-CL"/>
-          </a:p>
-        </p:txBody>
-      </p:sp>
-      <p:sp>
-        <p:nvSpPr>
-          <p:cNvPr id="7" name="Marcador de número de diapositiva 6">
-            <a:extLst>
-              <a:ext uri="{FF2B5EF4-FFF2-40B4-BE49-F238E27FC236}">
-                <a16:creationId xmlns:a16="http://schemas.microsoft.com/office/drawing/2014/main" id="{359E9C2D-5D10-900D-3E3F-9174CB9CB103}"/>
+        <p:spPr>
+          <a:xfrm>
+            <a:off x="838200" y="365125"/>
+            <a:ext cx="8482445" cy="1325563"/>
+          </a:xfrm>
+        </p:spPr>
+        <p:txBody>
+          <a:bodyPr>
+            <a:normAutofit fontScale="90000"/>
+          </a:bodyPr>
+          <a:lstStyle/>
+          <a:p>
+            <a:r>
+              <a:rPr lang="en-US" sz="5200" dirty="0"/>
+              <a:t>Finger Flexion Detection using </a:t>
+            </a:r>
+            <a:r>
+              <a:rPr lang="en-US" sz="5200" dirty="0" err="1"/>
+              <a:t>ECoG</a:t>
+            </a:r>
+            <a:r>
+              <a:rPr lang="en-US" sz="5200" dirty="0"/>
+              <a:t> signals</a:t>
+            </a:r>
+            <a:endParaRPr lang="es-CL" sz="5200" dirty="0"/>
+          </a:p>
+        </p:txBody>
+      </p:sp>
+      <p:sp>
+        <p:nvSpPr>
+          <p:cNvPr id="4" name="Marcador de número de diapositiva 3">
+            <a:extLst>
+              <a:ext uri="{FF2B5EF4-FFF2-40B4-BE49-F238E27FC236}">
+                <a16:creationId xmlns:a16="http://schemas.microsoft.com/office/drawing/2014/main" id="{5FC93749-528B-2F19-3EE8-FD233DB55874}"/>
               </a:ext>
             </a:extLst>
           </p:cNvPr>
@@ -7833,10 +7764,519 @@
           </a:p>
         </p:txBody>
       </p:sp>
+      <p:pic>
+        <p:nvPicPr>
+          <p:cNvPr id="1026" name="Picture 2">
+            <a:extLst>
+              <a:ext uri="{FF2B5EF4-FFF2-40B4-BE49-F238E27FC236}">
+                <a16:creationId xmlns:a16="http://schemas.microsoft.com/office/drawing/2014/main" id="{65C8AE12-33A0-66F8-591D-B2768CD21F24}"/>
+              </a:ext>
+            </a:extLst>
+          </p:cNvPr>
+          <p:cNvPicPr>
+            <a:picLocks noGrp="1" noChangeAspect="1" noChangeArrowheads="1"/>
+          </p:cNvPicPr>
+          <p:nvPr>
+            <p:ph idx="1"/>
+          </p:nvPr>
+        </p:nvPicPr>
+        <p:blipFill>
+          <a:blip r:embed="rId2">
+            <a:extLst>
+              <a:ext uri="{28A0092B-C50C-407E-A947-70E740481C1C}">
+                <a14:useLocalDpi xmlns:a14="http://schemas.microsoft.com/office/drawing/2010/main" val="0"/>
+              </a:ext>
+            </a:extLst>
+          </a:blip>
+          <a:srcRect/>
+          <a:stretch>
+            <a:fillRect/>
+          </a:stretch>
+        </p:blipFill>
+        <p:spPr bwMode="auto">
+          <a:xfrm>
+            <a:off x="1343667" y="1847850"/>
+            <a:ext cx="3789666" cy="4351338"/>
+          </a:xfrm>
+          <a:prstGeom prst="rect">
+            <a:avLst/>
+          </a:prstGeom>
+          <a:noFill/>
+          <a:extLst>
+            <a:ext uri="{909E8E84-426E-40DD-AFC4-6F175D3DCCD1}">
+              <a14:hiddenFill xmlns:a14="http://schemas.microsoft.com/office/drawing/2010/main">
+                <a:solidFill>
+                  <a:srgbClr val="FFFFFF"/>
+                </a:solidFill>
+              </a14:hiddenFill>
+            </a:ext>
+          </a:extLst>
+        </p:spPr>
+      </p:pic>
+      <p:pic>
+        <p:nvPicPr>
+          <p:cNvPr id="5" name="Imagen 4">
+            <a:extLst>
+              <a:ext uri="{FF2B5EF4-FFF2-40B4-BE49-F238E27FC236}">
+                <a16:creationId xmlns:a16="http://schemas.microsoft.com/office/drawing/2014/main" id="{15CD958F-74C4-509F-5FD1-1DCF4DED5A2A}"/>
+              </a:ext>
+            </a:extLst>
+          </p:cNvPr>
+          <p:cNvPicPr>
+            <a:picLocks noChangeAspect="1"/>
+          </p:cNvPicPr>
+          <p:nvPr/>
+        </p:nvPicPr>
+        <p:blipFill>
+          <a:blip r:embed="rId3"/>
+          <a:stretch>
+            <a:fillRect/>
+          </a:stretch>
+        </p:blipFill>
+        <p:spPr>
+          <a:xfrm>
+            <a:off x="8610600" y="0"/>
+            <a:ext cx="3034358" cy="6858000"/>
+          </a:xfrm>
+          <a:prstGeom prst="rect">
+            <a:avLst/>
+          </a:prstGeom>
+        </p:spPr>
+      </p:pic>
     </p:spTree>
     <p:extLst>
       <p:ext uri="{BB962C8B-B14F-4D97-AF65-F5344CB8AC3E}">
-        <p14:creationId xmlns:p14="http://schemas.microsoft.com/office/powerpoint/2010/main" val="3977960472"/>
+        <p14:creationId xmlns:p14="http://schemas.microsoft.com/office/powerpoint/2010/main" val="2867618799"/>
+      </p:ext>
+    </p:extLst>
+  </p:cSld>
+  <p:clrMapOvr>
+    <a:masterClrMapping/>
+  </p:clrMapOvr>
+</p:sld>
+</file>
+
+<file path=ppt/slides/slide18.xml><?xml version="1.0" encoding="utf-8"?>
+<p:sld xmlns:a="http://schemas.openxmlformats.org/drawingml/2006/main" xmlns:r="http://schemas.openxmlformats.org/officeDocument/2006/relationships" xmlns:p="http://schemas.openxmlformats.org/presentationml/2006/main">
+  <p:cSld>
+    <p:spTree>
+      <p:nvGrpSpPr>
+        <p:cNvPr id="1" name="">
+          <a:extLst>
+            <a:ext uri="{FF2B5EF4-FFF2-40B4-BE49-F238E27FC236}">
+              <a16:creationId xmlns:a16="http://schemas.microsoft.com/office/drawing/2014/main" id="{0B17B36D-BD76-80BB-0410-718AF8DCEACF}"/>
+            </a:ext>
+          </a:extLst>
+        </p:cNvPr>
+        <p:cNvGrpSpPr/>
+        <p:nvPr/>
+      </p:nvGrpSpPr>
+      <p:grpSpPr>
+        <a:xfrm>
+          <a:off x="0" y="0"/>
+          <a:ext cx="0" cy="0"/>
+          <a:chOff x="0" y="0"/>
+          <a:chExt cx="0" cy="0"/>
+        </a:xfrm>
+      </p:grpSpPr>
+      <p:sp>
+        <p:nvSpPr>
+          <p:cNvPr id="8" name="Título 7">
+            <a:extLst>
+              <a:ext uri="{FF2B5EF4-FFF2-40B4-BE49-F238E27FC236}">
+                <a16:creationId xmlns:a16="http://schemas.microsoft.com/office/drawing/2014/main" id="{7A3F51C2-4D27-3496-B110-43EBD395BC99}"/>
+              </a:ext>
+            </a:extLst>
+          </p:cNvPr>
+          <p:cNvSpPr>
+            <a:spLocks noGrp="1"/>
+          </p:cNvSpPr>
+          <p:nvPr>
+            <p:ph type="title"/>
+          </p:nvPr>
+        </p:nvSpPr>
+        <p:spPr/>
+        <p:txBody>
+          <a:bodyPr/>
+          <a:lstStyle/>
+          <a:p>
+            <a:r>
+              <a:rPr lang="es-MX" dirty="0"/>
+              <a:t>Comparación modelo anterior y modelo nuevo</a:t>
+            </a:r>
+            <a:endParaRPr lang="es-CL" dirty="0"/>
+          </a:p>
+        </p:txBody>
+      </p:sp>
+      <p:sp>
+        <p:nvSpPr>
+          <p:cNvPr id="9" name="Marcador de texto 8">
+            <a:extLst>
+              <a:ext uri="{FF2B5EF4-FFF2-40B4-BE49-F238E27FC236}">
+                <a16:creationId xmlns:a16="http://schemas.microsoft.com/office/drawing/2014/main" id="{09D92CBD-FDCD-00AF-29BE-605169C9A9C1}"/>
+              </a:ext>
+            </a:extLst>
+          </p:cNvPr>
+          <p:cNvSpPr>
+            <a:spLocks noGrp="1"/>
+          </p:cNvSpPr>
+          <p:nvPr>
+            <p:ph type="body" idx="1"/>
+          </p:nvPr>
+        </p:nvSpPr>
+        <p:spPr/>
+        <p:txBody>
+          <a:bodyPr/>
+          <a:lstStyle/>
+          <a:p>
+            <a:r>
+              <a:rPr lang="es-MX" dirty="0"/>
+              <a:t>Modelo anterior (float32)</a:t>
+            </a:r>
+            <a:endParaRPr lang="es-CL" dirty="0"/>
+          </a:p>
+        </p:txBody>
+      </p:sp>
+      <p:sp>
+        <p:nvSpPr>
+          <p:cNvPr id="10" name="Marcador de texto 9">
+            <a:extLst>
+              <a:ext uri="{FF2B5EF4-FFF2-40B4-BE49-F238E27FC236}">
+                <a16:creationId xmlns:a16="http://schemas.microsoft.com/office/drawing/2014/main" id="{3F7E67E4-33CF-51A4-6F7E-E60CCBFF9811}"/>
+              </a:ext>
+            </a:extLst>
+          </p:cNvPr>
+          <p:cNvSpPr>
+            <a:spLocks noGrp="1"/>
+          </p:cNvSpPr>
+          <p:nvPr>
+            <p:ph type="body" sz="quarter" idx="3"/>
+          </p:nvPr>
+        </p:nvSpPr>
+        <p:spPr/>
+        <p:txBody>
+          <a:bodyPr/>
+          <a:lstStyle/>
+          <a:p>
+            <a:r>
+              <a:rPr lang="es-MX" dirty="0"/>
+              <a:t>Modelo nuevo (float32)</a:t>
+            </a:r>
+            <a:endParaRPr lang="es-CL" dirty="0"/>
+          </a:p>
+        </p:txBody>
+      </p:sp>
+      <p:sp>
+        <p:nvSpPr>
+          <p:cNvPr id="4" name="Marcador de número de diapositiva 3">
+            <a:extLst>
+              <a:ext uri="{FF2B5EF4-FFF2-40B4-BE49-F238E27FC236}">
+                <a16:creationId xmlns:a16="http://schemas.microsoft.com/office/drawing/2014/main" id="{A459F788-753D-ECB9-1B14-988B3C7FF5D9}"/>
+              </a:ext>
+            </a:extLst>
+          </p:cNvPr>
+          <p:cNvSpPr>
+            <a:spLocks noGrp="1"/>
+          </p:cNvSpPr>
+          <p:nvPr>
+            <p:ph type="sldNum" sz="quarter" idx="12"/>
+          </p:nvPr>
+        </p:nvSpPr>
+        <p:spPr/>
+        <p:txBody>
+          <a:bodyPr/>
+          <a:lstStyle/>
+          <a:p>
+            <a:fld id="{29B47543-ED2D-461E-8250-4200DFF84A65}" type="slidenum">
+              <a:rPr lang="es-CL" smtClean="0"/>
+              <a:t>18</a:t>
+            </a:fld>
+            <a:endParaRPr lang="es-CL"/>
+          </a:p>
+        </p:txBody>
+      </p:sp>
+      <p:pic>
+        <p:nvPicPr>
+          <p:cNvPr id="11" name="Marcador de contenido 5">
+            <a:extLst>
+              <a:ext uri="{FF2B5EF4-FFF2-40B4-BE49-F238E27FC236}">
+                <a16:creationId xmlns:a16="http://schemas.microsoft.com/office/drawing/2014/main" id="{84E549F1-BAEB-D338-F609-B3AB5094C4F0}"/>
+              </a:ext>
+            </a:extLst>
+          </p:cNvPr>
+          <p:cNvPicPr>
+            <a:picLocks noGrp="1" noChangeAspect="1"/>
+          </p:cNvPicPr>
+          <p:nvPr>
+            <p:ph sz="half" idx="2"/>
+          </p:nvPr>
+        </p:nvPicPr>
+        <p:blipFill>
+          <a:blip r:embed="rId2"/>
+          <a:srcRect r="37265"/>
+          <a:stretch>
+            <a:fillRect/>
+          </a:stretch>
+        </p:blipFill>
+        <p:spPr>
+          <a:xfrm>
+            <a:off x="1320229" y="2505075"/>
+            <a:ext cx="4196904" cy="3684588"/>
+          </a:xfrm>
+          <a:prstGeom prst="rect">
+            <a:avLst/>
+          </a:prstGeom>
+        </p:spPr>
+      </p:pic>
+      <p:pic>
+        <p:nvPicPr>
+          <p:cNvPr id="7" name="Marcador de contenido 6">
+            <a:extLst>
+              <a:ext uri="{FF2B5EF4-FFF2-40B4-BE49-F238E27FC236}">
+                <a16:creationId xmlns:a16="http://schemas.microsoft.com/office/drawing/2014/main" id="{DA793555-CB18-4697-FC66-6705AA5CD938}"/>
+              </a:ext>
+            </a:extLst>
+          </p:cNvPr>
+          <p:cNvPicPr>
+            <a:picLocks noGrp="1" noChangeAspect="1"/>
+          </p:cNvPicPr>
+          <p:nvPr>
+            <p:ph sz="quarter" idx="4"/>
+          </p:nvPr>
+        </p:nvPicPr>
+        <p:blipFill>
+          <a:blip r:embed="rId3"/>
+          <a:stretch>
+            <a:fillRect/>
+          </a:stretch>
+        </p:blipFill>
+        <p:spPr>
+          <a:xfrm>
+            <a:off x="6658710" y="2505075"/>
+            <a:ext cx="4210167" cy="3684588"/>
+          </a:xfrm>
+          <a:prstGeom prst="rect">
+            <a:avLst/>
+          </a:prstGeom>
+        </p:spPr>
+      </p:pic>
+    </p:spTree>
+    <p:extLst>
+      <p:ext uri="{BB962C8B-B14F-4D97-AF65-F5344CB8AC3E}">
+        <p14:creationId xmlns:p14="http://schemas.microsoft.com/office/powerpoint/2010/main" val="1745490712"/>
+      </p:ext>
+    </p:extLst>
+  </p:cSld>
+  <p:clrMapOvr>
+    <a:masterClrMapping/>
+  </p:clrMapOvr>
+</p:sld>
+</file>
+
+<file path=ppt/slides/slide19.xml><?xml version="1.0" encoding="utf-8"?>
+<p:sld xmlns:a="http://schemas.openxmlformats.org/drawingml/2006/main" xmlns:r="http://schemas.openxmlformats.org/officeDocument/2006/relationships" xmlns:p="http://schemas.openxmlformats.org/presentationml/2006/main">
+  <p:cSld>
+    <p:spTree>
+      <p:nvGrpSpPr>
+        <p:cNvPr id="1" name="">
+          <a:extLst>
+            <a:ext uri="{FF2B5EF4-FFF2-40B4-BE49-F238E27FC236}">
+              <a16:creationId xmlns:a16="http://schemas.microsoft.com/office/drawing/2014/main" id="{73F78C09-0241-3EB1-1DF6-67F39B65049E}"/>
+            </a:ext>
+          </a:extLst>
+        </p:cNvPr>
+        <p:cNvGrpSpPr/>
+        <p:nvPr/>
+      </p:nvGrpSpPr>
+      <p:grpSpPr>
+        <a:xfrm>
+          <a:off x="0" y="0"/>
+          <a:ext cx="0" cy="0"/>
+          <a:chOff x="0" y="0"/>
+          <a:chExt cx="0" cy="0"/>
+        </a:xfrm>
+      </p:grpSpPr>
+      <p:sp>
+        <p:nvSpPr>
+          <p:cNvPr id="8" name="Título 7">
+            <a:extLst>
+              <a:ext uri="{FF2B5EF4-FFF2-40B4-BE49-F238E27FC236}">
+                <a16:creationId xmlns:a16="http://schemas.microsoft.com/office/drawing/2014/main" id="{98F19548-4E49-E79C-F153-7A051891B373}"/>
+              </a:ext>
+            </a:extLst>
+          </p:cNvPr>
+          <p:cNvSpPr>
+            <a:spLocks noGrp="1"/>
+          </p:cNvSpPr>
+          <p:nvPr>
+            <p:ph type="title"/>
+          </p:nvPr>
+        </p:nvSpPr>
+        <p:spPr/>
+        <p:txBody>
+          <a:bodyPr/>
+          <a:lstStyle/>
+          <a:p>
+            <a:r>
+              <a:rPr lang="es-MX" dirty="0"/>
+              <a:t>Comparación precisión completa y cuantizada del modelo nuevo</a:t>
+            </a:r>
+            <a:endParaRPr lang="es-CL" dirty="0"/>
+          </a:p>
+        </p:txBody>
+      </p:sp>
+      <p:sp>
+        <p:nvSpPr>
+          <p:cNvPr id="9" name="Marcador de texto 8">
+            <a:extLst>
+              <a:ext uri="{FF2B5EF4-FFF2-40B4-BE49-F238E27FC236}">
+                <a16:creationId xmlns:a16="http://schemas.microsoft.com/office/drawing/2014/main" id="{8E5A968B-9D33-38AA-76E9-9FFA9022D06C}"/>
+              </a:ext>
+            </a:extLst>
+          </p:cNvPr>
+          <p:cNvSpPr>
+            <a:spLocks noGrp="1"/>
+          </p:cNvSpPr>
+          <p:nvPr>
+            <p:ph type="body" idx="1"/>
+          </p:nvPr>
+        </p:nvSpPr>
+        <p:spPr/>
+        <p:txBody>
+          <a:bodyPr/>
+          <a:lstStyle/>
+          <a:p>
+            <a:r>
+              <a:rPr lang="es-MX" dirty="0"/>
+              <a:t>float32 (nuevo)</a:t>
+            </a:r>
+            <a:endParaRPr lang="es-CL" dirty="0"/>
+          </a:p>
+        </p:txBody>
+      </p:sp>
+      <p:sp>
+        <p:nvSpPr>
+          <p:cNvPr id="10" name="Marcador de texto 9">
+            <a:extLst>
+              <a:ext uri="{FF2B5EF4-FFF2-40B4-BE49-F238E27FC236}">
+                <a16:creationId xmlns:a16="http://schemas.microsoft.com/office/drawing/2014/main" id="{65C13AE6-97B2-9770-5867-8D4E0FB4877A}"/>
+              </a:ext>
+            </a:extLst>
+          </p:cNvPr>
+          <p:cNvSpPr>
+            <a:spLocks noGrp="1"/>
+          </p:cNvSpPr>
+          <p:nvPr>
+            <p:ph type="body" sz="quarter" idx="3"/>
+          </p:nvPr>
+        </p:nvSpPr>
+        <p:spPr/>
+        <p:txBody>
+          <a:bodyPr/>
+          <a:lstStyle/>
+          <a:p>
+            <a:r>
+              <a:rPr lang="es-MX" dirty="0"/>
+              <a:t>int8 (nuevo)</a:t>
+            </a:r>
+            <a:endParaRPr lang="es-CL" dirty="0"/>
+          </a:p>
+        </p:txBody>
+      </p:sp>
+      <p:sp>
+        <p:nvSpPr>
+          <p:cNvPr id="4" name="Marcador de número de diapositiva 3">
+            <a:extLst>
+              <a:ext uri="{FF2B5EF4-FFF2-40B4-BE49-F238E27FC236}">
+                <a16:creationId xmlns:a16="http://schemas.microsoft.com/office/drawing/2014/main" id="{BE6B9BF5-042F-4691-E3CD-7EEDA3F57829}"/>
+              </a:ext>
+            </a:extLst>
+          </p:cNvPr>
+          <p:cNvSpPr>
+            <a:spLocks noGrp="1"/>
+          </p:cNvSpPr>
+          <p:nvPr>
+            <p:ph type="sldNum" sz="quarter" idx="12"/>
+          </p:nvPr>
+        </p:nvSpPr>
+        <p:spPr/>
+        <p:txBody>
+          <a:bodyPr/>
+          <a:lstStyle/>
+          <a:p>
+            <a:fld id="{29B47543-ED2D-461E-8250-4200DFF84A65}" type="slidenum">
+              <a:rPr lang="es-CL" smtClean="0"/>
+              <a:t>19</a:t>
+            </a:fld>
+            <a:endParaRPr lang="es-CL"/>
+          </a:p>
+        </p:txBody>
+      </p:sp>
+      <p:pic>
+        <p:nvPicPr>
+          <p:cNvPr id="6" name="Marcador de contenido 5">
+            <a:extLst>
+              <a:ext uri="{FF2B5EF4-FFF2-40B4-BE49-F238E27FC236}">
+                <a16:creationId xmlns:a16="http://schemas.microsoft.com/office/drawing/2014/main" id="{1931B3EE-A5D8-AA60-C5AF-C49D8A32C2A3}"/>
+              </a:ext>
+            </a:extLst>
+          </p:cNvPr>
+          <p:cNvPicPr>
+            <a:picLocks noGrp="1" noChangeAspect="1"/>
+          </p:cNvPicPr>
+          <p:nvPr>
+            <p:ph sz="half" idx="2"/>
+          </p:nvPr>
+        </p:nvPicPr>
+        <p:blipFill>
+          <a:blip r:embed="rId2"/>
+          <a:stretch>
+            <a:fillRect/>
+          </a:stretch>
+        </p:blipFill>
+        <p:spPr>
+          <a:xfrm>
+            <a:off x="1313598" y="2505075"/>
+            <a:ext cx="4210167" cy="3684588"/>
+          </a:xfrm>
+          <a:prstGeom prst="rect">
+            <a:avLst/>
+          </a:prstGeom>
+        </p:spPr>
+      </p:pic>
+      <p:pic>
+        <p:nvPicPr>
+          <p:cNvPr id="14" name="Marcador de contenido 13">
+            <a:extLst>
+              <a:ext uri="{FF2B5EF4-FFF2-40B4-BE49-F238E27FC236}">
+                <a16:creationId xmlns:a16="http://schemas.microsoft.com/office/drawing/2014/main" id="{75951500-FE11-C5BF-0E1D-9124EA1AC79E}"/>
+              </a:ext>
+            </a:extLst>
+          </p:cNvPr>
+          <p:cNvPicPr>
+            <a:picLocks noGrp="1" noChangeAspect="1"/>
+          </p:cNvPicPr>
+          <p:nvPr>
+            <p:ph sz="quarter" idx="4"/>
+          </p:nvPr>
+        </p:nvPicPr>
+        <p:blipFill>
+          <a:blip r:embed="rId3"/>
+          <a:stretch>
+            <a:fillRect/>
+          </a:stretch>
+        </p:blipFill>
+        <p:spPr>
+          <a:xfrm>
+            <a:off x="6769265" y="2505075"/>
+            <a:ext cx="3989057" cy="3684588"/>
+          </a:xfrm>
+        </p:spPr>
+      </p:pic>
+    </p:spTree>
+    <p:extLst>
+      <p:ext uri="{BB962C8B-B14F-4D97-AF65-F5344CB8AC3E}">
+        <p14:creationId xmlns:p14="http://schemas.microsoft.com/office/powerpoint/2010/main" val="3707186878"/>
       </p:ext>
     </p:extLst>
   </p:cSld>
@@ -7966,6 +8406,1052 @@
     <p:extLst>
       <p:ext uri="{BB962C8B-B14F-4D97-AF65-F5344CB8AC3E}">
         <p14:creationId xmlns:p14="http://schemas.microsoft.com/office/powerpoint/2010/main" val="3654672290"/>
+      </p:ext>
+    </p:extLst>
+  </p:cSld>
+  <p:clrMapOvr>
+    <a:masterClrMapping/>
+  </p:clrMapOvr>
+</p:sld>
+</file>
+
+<file path=ppt/slides/slide20.xml><?xml version="1.0" encoding="utf-8"?>
+<p:sld xmlns:a="http://schemas.openxmlformats.org/drawingml/2006/main" xmlns:r="http://schemas.openxmlformats.org/officeDocument/2006/relationships" xmlns:p="http://schemas.openxmlformats.org/presentationml/2006/main">
+  <p:cSld>
+    <p:spTree>
+      <p:nvGrpSpPr>
+        <p:cNvPr id="1" name="">
+          <a:extLst>
+            <a:ext uri="{FF2B5EF4-FFF2-40B4-BE49-F238E27FC236}">
+              <a16:creationId xmlns:a16="http://schemas.microsoft.com/office/drawing/2014/main" id="{71279801-3D4A-6063-824A-2FFFA37B6832}"/>
+            </a:ext>
+          </a:extLst>
+        </p:cNvPr>
+        <p:cNvGrpSpPr/>
+        <p:nvPr/>
+      </p:nvGrpSpPr>
+      <p:grpSpPr>
+        <a:xfrm>
+          <a:off x="0" y="0"/>
+          <a:ext cx="0" cy="0"/>
+          <a:chOff x="0" y="0"/>
+          <a:chExt cx="0" cy="0"/>
+        </a:xfrm>
+      </p:grpSpPr>
+      <p:sp>
+        <p:nvSpPr>
+          <p:cNvPr id="8" name="Título 7">
+            <a:extLst>
+              <a:ext uri="{FF2B5EF4-FFF2-40B4-BE49-F238E27FC236}">
+                <a16:creationId xmlns:a16="http://schemas.microsoft.com/office/drawing/2014/main" id="{6C477922-27A7-2EEC-4144-75AAE5F80D46}"/>
+              </a:ext>
+            </a:extLst>
+          </p:cNvPr>
+          <p:cNvSpPr>
+            <a:spLocks noGrp="1"/>
+          </p:cNvSpPr>
+          <p:nvPr>
+            <p:ph type="title"/>
+          </p:nvPr>
+        </p:nvSpPr>
+        <p:spPr/>
+        <p:txBody>
+          <a:bodyPr/>
+          <a:lstStyle/>
+          <a:p>
+            <a:r>
+              <a:rPr lang="es-MX" dirty="0"/>
+              <a:t>Comparación modelo para sujeto 1 y 2</a:t>
+            </a:r>
+            <a:endParaRPr lang="es-CL" dirty="0"/>
+          </a:p>
+        </p:txBody>
+      </p:sp>
+      <p:sp>
+        <p:nvSpPr>
+          <p:cNvPr id="9" name="Marcador de texto 8">
+            <a:extLst>
+              <a:ext uri="{FF2B5EF4-FFF2-40B4-BE49-F238E27FC236}">
+                <a16:creationId xmlns:a16="http://schemas.microsoft.com/office/drawing/2014/main" id="{B8191424-F87B-9288-9C74-E8422518D743}"/>
+              </a:ext>
+            </a:extLst>
+          </p:cNvPr>
+          <p:cNvSpPr>
+            <a:spLocks noGrp="1"/>
+          </p:cNvSpPr>
+          <p:nvPr>
+            <p:ph type="body" idx="1"/>
+          </p:nvPr>
+        </p:nvSpPr>
+        <p:spPr/>
+        <p:txBody>
+          <a:bodyPr/>
+          <a:lstStyle/>
+          <a:p>
+            <a:r>
+              <a:rPr lang="es-MX" dirty="0"/>
+              <a:t>Sujeto 1 (int8)</a:t>
+            </a:r>
+            <a:endParaRPr lang="es-CL" dirty="0"/>
+          </a:p>
+        </p:txBody>
+      </p:sp>
+      <p:sp>
+        <p:nvSpPr>
+          <p:cNvPr id="10" name="Marcador de texto 9">
+            <a:extLst>
+              <a:ext uri="{FF2B5EF4-FFF2-40B4-BE49-F238E27FC236}">
+                <a16:creationId xmlns:a16="http://schemas.microsoft.com/office/drawing/2014/main" id="{C84B2838-67D8-519F-5797-7279ECB2A090}"/>
+              </a:ext>
+            </a:extLst>
+          </p:cNvPr>
+          <p:cNvSpPr>
+            <a:spLocks noGrp="1"/>
+          </p:cNvSpPr>
+          <p:nvPr>
+            <p:ph type="body" sz="quarter" idx="3"/>
+          </p:nvPr>
+        </p:nvSpPr>
+        <p:spPr/>
+        <p:txBody>
+          <a:bodyPr/>
+          <a:lstStyle/>
+          <a:p>
+            <a:r>
+              <a:rPr lang="es-MX" dirty="0"/>
+              <a:t>int8 (nuevo)</a:t>
+            </a:r>
+            <a:endParaRPr lang="es-CL" dirty="0"/>
+          </a:p>
+        </p:txBody>
+      </p:sp>
+      <p:sp>
+        <p:nvSpPr>
+          <p:cNvPr id="4" name="Marcador de número de diapositiva 3">
+            <a:extLst>
+              <a:ext uri="{FF2B5EF4-FFF2-40B4-BE49-F238E27FC236}">
+                <a16:creationId xmlns:a16="http://schemas.microsoft.com/office/drawing/2014/main" id="{31B924EA-E9EA-724A-1141-1EF38F4F7963}"/>
+              </a:ext>
+            </a:extLst>
+          </p:cNvPr>
+          <p:cNvSpPr>
+            <a:spLocks noGrp="1"/>
+          </p:cNvSpPr>
+          <p:nvPr>
+            <p:ph type="sldNum" sz="quarter" idx="12"/>
+          </p:nvPr>
+        </p:nvSpPr>
+        <p:spPr/>
+        <p:txBody>
+          <a:bodyPr/>
+          <a:lstStyle/>
+          <a:p>
+            <a:fld id="{29B47543-ED2D-461E-8250-4200DFF84A65}" type="slidenum">
+              <a:rPr lang="es-CL" smtClean="0"/>
+              <a:t>20</a:t>
+            </a:fld>
+            <a:endParaRPr lang="es-CL"/>
+          </a:p>
+        </p:txBody>
+      </p:sp>
+      <p:pic>
+        <p:nvPicPr>
+          <p:cNvPr id="13" name="Marcador de contenido 12">
+            <a:extLst>
+              <a:ext uri="{FF2B5EF4-FFF2-40B4-BE49-F238E27FC236}">
+                <a16:creationId xmlns:a16="http://schemas.microsoft.com/office/drawing/2014/main" id="{1B0A4F5B-10F6-1012-0DEA-607EAFD86233}"/>
+              </a:ext>
+            </a:extLst>
+          </p:cNvPr>
+          <p:cNvPicPr>
+            <a:picLocks noGrp="1" noChangeAspect="1"/>
+          </p:cNvPicPr>
+          <p:nvPr>
+            <p:ph sz="quarter" idx="4"/>
+          </p:nvPr>
+        </p:nvPicPr>
+        <p:blipFill>
+          <a:blip r:embed="rId2"/>
+          <a:stretch>
+            <a:fillRect/>
+          </a:stretch>
+        </p:blipFill>
+        <p:spPr>
+          <a:xfrm>
+            <a:off x="6765553" y="2505075"/>
+            <a:ext cx="3996482" cy="3684588"/>
+          </a:xfrm>
+        </p:spPr>
+      </p:pic>
+      <p:pic>
+        <p:nvPicPr>
+          <p:cNvPr id="11" name="Marcador de contenido 13">
+            <a:extLst>
+              <a:ext uri="{FF2B5EF4-FFF2-40B4-BE49-F238E27FC236}">
+                <a16:creationId xmlns:a16="http://schemas.microsoft.com/office/drawing/2014/main" id="{282D7FC7-7702-9004-8761-1EEF87186CFE}"/>
+              </a:ext>
+            </a:extLst>
+          </p:cNvPr>
+          <p:cNvPicPr>
+            <a:picLocks noGrp="1" noChangeAspect="1"/>
+          </p:cNvPicPr>
+          <p:nvPr>
+            <p:ph sz="half" idx="2"/>
+          </p:nvPr>
+        </p:nvPicPr>
+        <p:blipFill>
+          <a:blip r:embed="rId3"/>
+          <a:stretch>
+            <a:fillRect/>
+          </a:stretch>
+        </p:blipFill>
+        <p:spPr>
+          <a:xfrm>
+            <a:off x="1424153" y="2505075"/>
+            <a:ext cx="3989057" cy="3684588"/>
+          </a:xfrm>
+        </p:spPr>
+      </p:pic>
+    </p:spTree>
+    <p:extLst>
+      <p:ext uri="{BB962C8B-B14F-4D97-AF65-F5344CB8AC3E}">
+        <p14:creationId xmlns:p14="http://schemas.microsoft.com/office/powerpoint/2010/main" val="2551349221"/>
+      </p:ext>
+    </p:extLst>
+  </p:cSld>
+  <p:clrMapOvr>
+    <a:masterClrMapping/>
+  </p:clrMapOvr>
+</p:sld>
+</file>
+
+<file path=ppt/slides/slide21.xml><?xml version="1.0" encoding="utf-8"?>
+<p:sld xmlns:a="http://schemas.openxmlformats.org/drawingml/2006/main" xmlns:r="http://schemas.openxmlformats.org/officeDocument/2006/relationships" xmlns:p="http://schemas.openxmlformats.org/presentationml/2006/main">
+  <p:cSld>
+    <p:spTree>
+      <p:nvGrpSpPr>
+        <p:cNvPr id="1" name="">
+          <a:extLst>
+            <a:ext uri="{FF2B5EF4-FFF2-40B4-BE49-F238E27FC236}">
+              <a16:creationId xmlns:a16="http://schemas.microsoft.com/office/drawing/2014/main" id="{E2E81392-82CB-18B4-3AC7-E4DB3E96F3DB}"/>
+            </a:ext>
+          </a:extLst>
+        </p:cNvPr>
+        <p:cNvGrpSpPr/>
+        <p:nvPr/>
+      </p:nvGrpSpPr>
+      <p:grpSpPr>
+        <a:xfrm>
+          <a:off x="0" y="0"/>
+          <a:ext cx="0" cy="0"/>
+          <a:chOff x="0" y="0"/>
+          <a:chExt cx="0" cy="0"/>
+        </a:xfrm>
+      </p:grpSpPr>
+      <p:sp>
+        <p:nvSpPr>
+          <p:cNvPr id="8" name="Título 7">
+            <a:extLst>
+              <a:ext uri="{FF2B5EF4-FFF2-40B4-BE49-F238E27FC236}">
+                <a16:creationId xmlns:a16="http://schemas.microsoft.com/office/drawing/2014/main" id="{0C8EE0DD-B3C7-5F6C-1946-DB93037514D5}"/>
+              </a:ext>
+            </a:extLst>
+          </p:cNvPr>
+          <p:cNvSpPr>
+            <a:spLocks noGrp="1"/>
+          </p:cNvSpPr>
+          <p:nvPr>
+            <p:ph type="title"/>
+          </p:nvPr>
+        </p:nvSpPr>
+        <p:spPr>
+          <a:xfrm>
+            <a:off x="838200" y="5555"/>
+            <a:ext cx="10515600" cy="1325563"/>
+          </a:xfrm>
+        </p:spPr>
+        <p:txBody>
+          <a:bodyPr/>
+          <a:lstStyle/>
+          <a:p>
+            <a:r>
+              <a:rPr lang="es-MX" dirty="0"/>
+              <a:t>Comparación modelo para sujeto 1 y 2</a:t>
+            </a:r>
+            <a:endParaRPr lang="es-CL" dirty="0"/>
+          </a:p>
+        </p:txBody>
+      </p:sp>
+      <p:sp>
+        <p:nvSpPr>
+          <p:cNvPr id="9" name="Marcador de texto 8">
+            <a:extLst>
+              <a:ext uri="{FF2B5EF4-FFF2-40B4-BE49-F238E27FC236}">
+                <a16:creationId xmlns:a16="http://schemas.microsoft.com/office/drawing/2014/main" id="{150D8D82-D5AC-5BFB-3BF0-1734AD99204E}"/>
+              </a:ext>
+            </a:extLst>
+          </p:cNvPr>
+          <p:cNvSpPr>
+            <a:spLocks noGrp="1"/>
+          </p:cNvSpPr>
+          <p:nvPr>
+            <p:ph type="body" idx="1"/>
+          </p:nvPr>
+        </p:nvSpPr>
+        <p:spPr>
+          <a:xfrm>
+            <a:off x="278679" y="1024876"/>
+            <a:ext cx="5157787" cy="823912"/>
+          </a:xfrm>
+        </p:spPr>
+        <p:txBody>
+          <a:bodyPr/>
+          <a:lstStyle/>
+          <a:p>
+            <a:r>
+              <a:rPr lang="es-MX" dirty="0"/>
+              <a:t>Sujeto 1</a:t>
+            </a:r>
+            <a:endParaRPr lang="es-CL" dirty="0"/>
+          </a:p>
+        </p:txBody>
+      </p:sp>
+      <p:sp>
+        <p:nvSpPr>
+          <p:cNvPr id="10" name="Marcador de texto 9">
+            <a:extLst>
+              <a:ext uri="{FF2B5EF4-FFF2-40B4-BE49-F238E27FC236}">
+                <a16:creationId xmlns:a16="http://schemas.microsoft.com/office/drawing/2014/main" id="{5FE81B83-AAFC-F33E-6074-062B2C09B9F3}"/>
+              </a:ext>
+            </a:extLst>
+          </p:cNvPr>
+          <p:cNvSpPr>
+            <a:spLocks noGrp="1"/>
+          </p:cNvSpPr>
+          <p:nvPr>
+            <p:ph type="body" sz="quarter" idx="3"/>
+          </p:nvPr>
+        </p:nvSpPr>
+        <p:spPr>
+          <a:xfrm>
+            <a:off x="6170612" y="1024876"/>
+            <a:ext cx="5183188" cy="823912"/>
+          </a:xfrm>
+        </p:spPr>
+        <p:txBody>
+          <a:bodyPr/>
+          <a:lstStyle/>
+          <a:p>
+            <a:r>
+              <a:rPr lang="es-MX" dirty="0"/>
+              <a:t>Sujeto 2</a:t>
+            </a:r>
+          </a:p>
+        </p:txBody>
+      </p:sp>
+      <p:sp>
+        <p:nvSpPr>
+          <p:cNvPr id="4" name="Marcador de número de diapositiva 3">
+            <a:extLst>
+              <a:ext uri="{FF2B5EF4-FFF2-40B4-BE49-F238E27FC236}">
+                <a16:creationId xmlns:a16="http://schemas.microsoft.com/office/drawing/2014/main" id="{1672182D-2A8D-36CC-DE2D-C9C6336D5031}"/>
+              </a:ext>
+            </a:extLst>
+          </p:cNvPr>
+          <p:cNvSpPr>
+            <a:spLocks noGrp="1"/>
+          </p:cNvSpPr>
+          <p:nvPr>
+            <p:ph type="sldNum" sz="quarter" idx="12"/>
+          </p:nvPr>
+        </p:nvSpPr>
+        <p:spPr/>
+        <p:txBody>
+          <a:bodyPr/>
+          <a:lstStyle/>
+          <a:p>
+            <a:fld id="{29B47543-ED2D-461E-8250-4200DFF84A65}" type="slidenum">
+              <a:rPr lang="es-CL" smtClean="0"/>
+              <a:t>21</a:t>
+            </a:fld>
+            <a:endParaRPr lang="es-CL"/>
+          </a:p>
+        </p:txBody>
+      </p:sp>
+      <p:pic>
+        <p:nvPicPr>
+          <p:cNvPr id="5" name="Marcador de contenido 4">
+            <a:extLst>
+              <a:ext uri="{FF2B5EF4-FFF2-40B4-BE49-F238E27FC236}">
+                <a16:creationId xmlns:a16="http://schemas.microsoft.com/office/drawing/2014/main" id="{31DB2360-3636-EBFD-7B25-27C3A9AD0C5B}"/>
+              </a:ext>
+            </a:extLst>
+          </p:cNvPr>
+          <p:cNvPicPr>
+            <a:picLocks noGrp="1" noChangeAspect="1"/>
+          </p:cNvPicPr>
+          <p:nvPr>
+            <p:ph sz="half" idx="2"/>
+          </p:nvPr>
+        </p:nvPicPr>
+        <p:blipFill>
+          <a:blip r:embed="rId2"/>
+          <a:stretch>
+            <a:fillRect/>
+          </a:stretch>
+        </p:blipFill>
+        <p:spPr>
+          <a:xfrm>
+            <a:off x="1652154" y="1217064"/>
+            <a:ext cx="2435455" cy="5504411"/>
+          </a:xfrm>
+          <a:prstGeom prst="rect">
+            <a:avLst/>
+          </a:prstGeom>
+        </p:spPr>
+      </p:pic>
+      <p:pic>
+        <p:nvPicPr>
+          <p:cNvPr id="14" name="Imagen 13">
+            <a:extLst>
+              <a:ext uri="{FF2B5EF4-FFF2-40B4-BE49-F238E27FC236}">
+                <a16:creationId xmlns:a16="http://schemas.microsoft.com/office/drawing/2014/main" id="{BBF280F4-9026-F40A-3C92-D28018FD8E44}"/>
+              </a:ext>
+            </a:extLst>
+          </p:cNvPr>
+          <p:cNvPicPr>
+            <a:picLocks noChangeAspect="1"/>
+          </p:cNvPicPr>
+          <p:nvPr/>
+        </p:nvPicPr>
+        <p:blipFill>
+          <a:blip r:embed="rId3"/>
+          <a:stretch>
+            <a:fillRect/>
+          </a:stretch>
+        </p:blipFill>
+        <p:spPr>
+          <a:xfrm>
+            <a:off x="8111320" y="1217064"/>
+            <a:ext cx="2509133" cy="5504411"/>
+          </a:xfrm>
+          <a:prstGeom prst="rect">
+            <a:avLst/>
+          </a:prstGeom>
+        </p:spPr>
+      </p:pic>
+    </p:spTree>
+    <p:extLst>
+      <p:ext uri="{BB962C8B-B14F-4D97-AF65-F5344CB8AC3E}">
+        <p14:creationId xmlns:p14="http://schemas.microsoft.com/office/powerpoint/2010/main" val="2822932569"/>
+      </p:ext>
+    </p:extLst>
+  </p:cSld>
+  <p:clrMapOvr>
+    <a:masterClrMapping/>
+  </p:clrMapOvr>
+</p:sld>
+</file>
+
+<file path=ppt/slides/slide22.xml><?xml version="1.0" encoding="utf-8"?>
+<p:sld xmlns:a="http://schemas.openxmlformats.org/drawingml/2006/main" xmlns:r="http://schemas.openxmlformats.org/officeDocument/2006/relationships" xmlns:p="http://schemas.openxmlformats.org/presentationml/2006/main">
+  <p:cSld>
+    <p:spTree>
+      <p:nvGrpSpPr>
+        <p:cNvPr id="1" name="">
+          <a:extLst>
+            <a:ext uri="{FF2B5EF4-FFF2-40B4-BE49-F238E27FC236}">
+              <a16:creationId xmlns:a16="http://schemas.microsoft.com/office/drawing/2014/main" id="{F2432BE6-05B4-09BD-5C70-4E0BFEC3F7A8}"/>
+            </a:ext>
+          </a:extLst>
+        </p:cNvPr>
+        <p:cNvGrpSpPr/>
+        <p:nvPr/>
+      </p:nvGrpSpPr>
+      <p:grpSpPr>
+        <a:xfrm>
+          <a:off x="0" y="0"/>
+          <a:ext cx="0" cy="0"/>
+          <a:chOff x="0" y="0"/>
+          <a:chExt cx="0" cy="0"/>
+        </a:xfrm>
+      </p:grpSpPr>
+      <p:sp>
+        <p:nvSpPr>
+          <p:cNvPr id="8" name="Título 7">
+            <a:extLst>
+              <a:ext uri="{FF2B5EF4-FFF2-40B4-BE49-F238E27FC236}">
+                <a16:creationId xmlns:a16="http://schemas.microsoft.com/office/drawing/2014/main" id="{797B61BB-D8E7-502B-3B06-BD3574382589}"/>
+              </a:ext>
+            </a:extLst>
+          </p:cNvPr>
+          <p:cNvSpPr>
+            <a:spLocks noGrp="1"/>
+          </p:cNvSpPr>
+          <p:nvPr>
+            <p:ph type="title"/>
+          </p:nvPr>
+        </p:nvSpPr>
+        <p:spPr/>
+        <p:txBody>
+          <a:bodyPr>
+            <a:normAutofit fontScale="90000"/>
+          </a:bodyPr>
+          <a:lstStyle/>
+          <a:p>
+            <a:r>
+              <a:rPr lang="es-MX" dirty="0"/>
+              <a:t>Uso de memoria para los 5 dedos del sujeto 1 y 2</a:t>
+            </a:r>
+            <a:br>
+              <a:rPr lang="es-MX" dirty="0"/>
+            </a:br>
+            <a:endParaRPr lang="es-CL" dirty="0"/>
+          </a:p>
+        </p:txBody>
+      </p:sp>
+      <p:sp>
+        <p:nvSpPr>
+          <p:cNvPr id="9" name="Marcador de texto 8">
+            <a:extLst>
+              <a:ext uri="{FF2B5EF4-FFF2-40B4-BE49-F238E27FC236}">
+                <a16:creationId xmlns:a16="http://schemas.microsoft.com/office/drawing/2014/main" id="{745D5F53-452E-BE09-45EF-C345172DF7BF}"/>
+              </a:ext>
+            </a:extLst>
+          </p:cNvPr>
+          <p:cNvSpPr>
+            <a:spLocks noGrp="1"/>
+          </p:cNvSpPr>
+          <p:nvPr>
+            <p:ph type="body" idx="1"/>
+          </p:nvPr>
+        </p:nvSpPr>
+        <p:spPr/>
+        <p:txBody>
+          <a:bodyPr/>
+          <a:lstStyle/>
+          <a:p>
+            <a:r>
+              <a:rPr lang="es-MX" dirty="0"/>
+              <a:t>Sujeto 1</a:t>
+            </a:r>
+            <a:endParaRPr lang="es-CL" dirty="0"/>
+          </a:p>
+        </p:txBody>
+      </p:sp>
+      <p:sp>
+        <p:nvSpPr>
+          <p:cNvPr id="10" name="Marcador de texto 9">
+            <a:extLst>
+              <a:ext uri="{FF2B5EF4-FFF2-40B4-BE49-F238E27FC236}">
+                <a16:creationId xmlns:a16="http://schemas.microsoft.com/office/drawing/2014/main" id="{B3FAD54D-A1ED-1A93-6B9A-51061EF6100B}"/>
+              </a:ext>
+            </a:extLst>
+          </p:cNvPr>
+          <p:cNvSpPr>
+            <a:spLocks noGrp="1"/>
+          </p:cNvSpPr>
+          <p:nvPr>
+            <p:ph type="body" sz="quarter" idx="3"/>
+          </p:nvPr>
+        </p:nvSpPr>
+        <p:spPr/>
+        <p:txBody>
+          <a:bodyPr/>
+          <a:lstStyle/>
+          <a:p>
+            <a:r>
+              <a:rPr lang="es-MX" dirty="0"/>
+              <a:t>Sujeto 2</a:t>
+            </a:r>
+            <a:endParaRPr lang="es-CL" dirty="0"/>
+          </a:p>
+        </p:txBody>
+      </p:sp>
+      <p:sp>
+        <p:nvSpPr>
+          <p:cNvPr id="4" name="Marcador de número de diapositiva 3">
+            <a:extLst>
+              <a:ext uri="{FF2B5EF4-FFF2-40B4-BE49-F238E27FC236}">
+                <a16:creationId xmlns:a16="http://schemas.microsoft.com/office/drawing/2014/main" id="{F903B364-57CF-8247-A9AB-93115DA9E8DF}"/>
+              </a:ext>
+            </a:extLst>
+          </p:cNvPr>
+          <p:cNvSpPr>
+            <a:spLocks noGrp="1"/>
+          </p:cNvSpPr>
+          <p:nvPr>
+            <p:ph type="sldNum" sz="quarter" idx="12"/>
+          </p:nvPr>
+        </p:nvSpPr>
+        <p:spPr/>
+        <p:txBody>
+          <a:bodyPr/>
+          <a:lstStyle/>
+          <a:p>
+            <a:fld id="{29B47543-ED2D-461E-8250-4200DFF84A65}" type="slidenum">
+              <a:rPr lang="es-CL" smtClean="0"/>
+              <a:t>22</a:t>
+            </a:fld>
+            <a:endParaRPr lang="es-CL"/>
+          </a:p>
+        </p:txBody>
+      </p:sp>
+      <p:pic>
+        <p:nvPicPr>
+          <p:cNvPr id="7" name="Marcador de contenido 5">
+            <a:extLst>
+              <a:ext uri="{FF2B5EF4-FFF2-40B4-BE49-F238E27FC236}">
+                <a16:creationId xmlns:a16="http://schemas.microsoft.com/office/drawing/2014/main" id="{863B68F4-9B5F-4250-A4E3-08DF7176768A}"/>
+              </a:ext>
+            </a:extLst>
+          </p:cNvPr>
+          <p:cNvPicPr>
+            <a:picLocks noGrp="1" noChangeAspect="1"/>
+          </p:cNvPicPr>
+          <p:nvPr>
+            <p:ph sz="half" idx="2"/>
+          </p:nvPr>
+        </p:nvPicPr>
+        <p:blipFill>
+          <a:blip r:embed="rId2"/>
+          <a:stretch>
+            <a:fillRect/>
+          </a:stretch>
+        </p:blipFill>
+        <p:spPr>
+          <a:xfrm>
+            <a:off x="735879" y="3265769"/>
+            <a:ext cx="4960541" cy="2030720"/>
+          </a:xfrm>
+          <a:prstGeom prst="rect">
+            <a:avLst/>
+          </a:prstGeom>
+        </p:spPr>
+      </p:pic>
+      <p:pic>
+        <p:nvPicPr>
+          <p:cNvPr id="15" name="Marcador de contenido 14">
+            <a:extLst>
+              <a:ext uri="{FF2B5EF4-FFF2-40B4-BE49-F238E27FC236}">
+                <a16:creationId xmlns:a16="http://schemas.microsoft.com/office/drawing/2014/main" id="{721FD691-39AF-7CD2-4C07-244152E3D7DE}"/>
+              </a:ext>
+            </a:extLst>
+          </p:cNvPr>
+          <p:cNvPicPr>
+            <a:picLocks noGrp="1" noChangeAspect="1"/>
+          </p:cNvPicPr>
+          <p:nvPr>
+            <p:ph sz="quarter" idx="4"/>
+          </p:nvPr>
+        </p:nvPicPr>
+        <p:blipFill>
+          <a:blip r:embed="rId3"/>
+          <a:stretch>
+            <a:fillRect/>
+          </a:stretch>
+        </p:blipFill>
+        <p:spPr>
+          <a:xfrm>
+            <a:off x="5986264" y="3317500"/>
+            <a:ext cx="5555059" cy="1978989"/>
+          </a:xfrm>
+        </p:spPr>
+      </p:pic>
+      <p:sp>
+        <p:nvSpPr>
+          <p:cNvPr id="16" name="Marcador de texto 8">
+            <a:extLst>
+              <a:ext uri="{FF2B5EF4-FFF2-40B4-BE49-F238E27FC236}">
+                <a16:creationId xmlns:a16="http://schemas.microsoft.com/office/drawing/2014/main" id="{7CD5436A-033D-F7D1-3AF8-EE7D8A1835B4}"/>
+              </a:ext>
+            </a:extLst>
+          </p:cNvPr>
+          <p:cNvSpPr txBox="1">
+            <a:spLocks/>
+          </p:cNvSpPr>
+          <p:nvPr/>
+        </p:nvSpPr>
+        <p:spPr>
+          <a:xfrm>
+            <a:off x="4324820" y="5668963"/>
+            <a:ext cx="2743200" cy="823912"/>
+          </a:xfrm>
+          <a:prstGeom prst="rect">
+            <a:avLst/>
+          </a:prstGeom>
+        </p:spPr>
+        <p:txBody>
+          <a:bodyPr vert="horz" lIns="91440" tIns="45720" rIns="91440" bIns="45720" rtlCol="0" anchor="b">
+            <a:normAutofit lnSpcReduction="10000"/>
+          </a:bodyPr>
+          <a:lstStyle>
+            <a:lvl1pPr marL="0" indent="0" algn="l" defTabSz="914400" rtl="0" eaLnBrk="1" latinLnBrk="0" hangingPunct="1">
+              <a:lnSpc>
+                <a:spcPct val="90000"/>
+              </a:lnSpc>
+              <a:spcBef>
+                <a:spcPts val="1000"/>
+              </a:spcBef>
+              <a:buFont typeface="Arial" panose="020B0604020202020204" pitchFamily="34" charset="0"/>
+              <a:buNone/>
+              <a:defRPr sz="2400" b="1" kern="1200">
+                <a:solidFill>
+                  <a:schemeClr val="tx1"/>
+                </a:solidFill>
+                <a:latin typeface="+mn-lt"/>
+                <a:ea typeface="+mn-ea"/>
+                <a:cs typeface="+mn-cs"/>
+              </a:defRPr>
+            </a:lvl1pPr>
+            <a:lvl2pPr marL="457200" indent="0" algn="l" defTabSz="914400" rtl="0" eaLnBrk="1" latinLnBrk="0" hangingPunct="1">
+              <a:lnSpc>
+                <a:spcPct val="90000"/>
+              </a:lnSpc>
+              <a:spcBef>
+                <a:spcPts val="500"/>
+              </a:spcBef>
+              <a:buFont typeface="Arial" panose="020B0604020202020204" pitchFamily="34" charset="0"/>
+              <a:buNone/>
+              <a:defRPr sz="2000" b="1" kern="1200">
+                <a:solidFill>
+                  <a:schemeClr val="tx1"/>
+                </a:solidFill>
+                <a:latin typeface="+mn-lt"/>
+                <a:ea typeface="+mn-ea"/>
+                <a:cs typeface="+mn-cs"/>
+              </a:defRPr>
+            </a:lvl2pPr>
+            <a:lvl3pPr marL="914400" indent="0" algn="l" defTabSz="914400" rtl="0" eaLnBrk="1" latinLnBrk="0" hangingPunct="1">
+              <a:lnSpc>
+                <a:spcPct val="90000"/>
+              </a:lnSpc>
+              <a:spcBef>
+                <a:spcPts val="500"/>
+              </a:spcBef>
+              <a:buFont typeface="Arial" panose="020B0604020202020204" pitchFamily="34" charset="0"/>
+              <a:buNone/>
+              <a:defRPr sz="1800" b="1" kern="1200">
+                <a:solidFill>
+                  <a:schemeClr val="tx1"/>
+                </a:solidFill>
+                <a:latin typeface="+mn-lt"/>
+                <a:ea typeface="+mn-ea"/>
+                <a:cs typeface="+mn-cs"/>
+              </a:defRPr>
+            </a:lvl3pPr>
+            <a:lvl4pPr marL="1371600" indent="0" algn="l" defTabSz="914400" rtl="0" eaLnBrk="1" latinLnBrk="0" hangingPunct="1">
+              <a:lnSpc>
+                <a:spcPct val="90000"/>
+              </a:lnSpc>
+              <a:spcBef>
+                <a:spcPts val="500"/>
+              </a:spcBef>
+              <a:buFont typeface="Arial" panose="020B0604020202020204" pitchFamily="34" charset="0"/>
+              <a:buNone/>
+              <a:defRPr sz="1600" b="1" kern="1200">
+                <a:solidFill>
+                  <a:schemeClr val="tx1"/>
+                </a:solidFill>
+                <a:latin typeface="+mn-lt"/>
+                <a:ea typeface="+mn-ea"/>
+                <a:cs typeface="+mn-cs"/>
+              </a:defRPr>
+            </a:lvl4pPr>
+            <a:lvl5pPr marL="1828800" indent="0" algn="l" defTabSz="914400" rtl="0" eaLnBrk="1" latinLnBrk="0" hangingPunct="1">
+              <a:lnSpc>
+                <a:spcPct val="90000"/>
+              </a:lnSpc>
+              <a:spcBef>
+                <a:spcPts val="500"/>
+              </a:spcBef>
+              <a:buFont typeface="Arial" panose="020B0604020202020204" pitchFamily="34" charset="0"/>
+              <a:buNone/>
+              <a:defRPr sz="1600" b="1" kern="1200">
+                <a:solidFill>
+                  <a:schemeClr val="tx1"/>
+                </a:solidFill>
+                <a:latin typeface="+mn-lt"/>
+                <a:ea typeface="+mn-ea"/>
+                <a:cs typeface="+mn-cs"/>
+              </a:defRPr>
+            </a:lvl5pPr>
+            <a:lvl6pPr marL="2286000" indent="0" algn="l" defTabSz="914400" rtl="0" eaLnBrk="1" latinLnBrk="0" hangingPunct="1">
+              <a:lnSpc>
+                <a:spcPct val="90000"/>
+              </a:lnSpc>
+              <a:spcBef>
+                <a:spcPts val="500"/>
+              </a:spcBef>
+              <a:buFont typeface="Arial" panose="020B0604020202020204" pitchFamily="34" charset="0"/>
+              <a:buNone/>
+              <a:defRPr sz="1600" b="1" kern="1200">
+                <a:solidFill>
+                  <a:schemeClr val="tx1"/>
+                </a:solidFill>
+                <a:latin typeface="+mn-lt"/>
+                <a:ea typeface="+mn-ea"/>
+                <a:cs typeface="+mn-cs"/>
+              </a:defRPr>
+            </a:lvl6pPr>
+            <a:lvl7pPr marL="2743200" indent="0" algn="l" defTabSz="914400" rtl="0" eaLnBrk="1" latinLnBrk="0" hangingPunct="1">
+              <a:lnSpc>
+                <a:spcPct val="90000"/>
+              </a:lnSpc>
+              <a:spcBef>
+                <a:spcPts val="500"/>
+              </a:spcBef>
+              <a:buFont typeface="Arial" panose="020B0604020202020204" pitchFamily="34" charset="0"/>
+              <a:buNone/>
+              <a:defRPr sz="1600" b="1" kern="1200">
+                <a:solidFill>
+                  <a:schemeClr val="tx1"/>
+                </a:solidFill>
+                <a:latin typeface="+mn-lt"/>
+                <a:ea typeface="+mn-ea"/>
+                <a:cs typeface="+mn-cs"/>
+              </a:defRPr>
+            </a:lvl7pPr>
+            <a:lvl8pPr marL="3200400" indent="0" algn="l" defTabSz="914400" rtl="0" eaLnBrk="1" latinLnBrk="0" hangingPunct="1">
+              <a:lnSpc>
+                <a:spcPct val="90000"/>
+              </a:lnSpc>
+              <a:spcBef>
+                <a:spcPts val="500"/>
+              </a:spcBef>
+              <a:buFont typeface="Arial" panose="020B0604020202020204" pitchFamily="34" charset="0"/>
+              <a:buNone/>
+              <a:defRPr sz="1600" b="1" kern="1200">
+                <a:solidFill>
+                  <a:schemeClr val="tx1"/>
+                </a:solidFill>
+                <a:latin typeface="+mn-lt"/>
+                <a:ea typeface="+mn-ea"/>
+                <a:cs typeface="+mn-cs"/>
+              </a:defRPr>
+            </a:lvl8pPr>
+            <a:lvl9pPr marL="3657600" indent="0" algn="l" defTabSz="914400" rtl="0" eaLnBrk="1" latinLnBrk="0" hangingPunct="1">
+              <a:lnSpc>
+                <a:spcPct val="90000"/>
+              </a:lnSpc>
+              <a:spcBef>
+                <a:spcPts val="500"/>
+              </a:spcBef>
+              <a:buFont typeface="Arial" panose="020B0604020202020204" pitchFamily="34" charset="0"/>
+              <a:buNone/>
+              <a:defRPr sz="1600" b="1" kern="1200">
+                <a:solidFill>
+                  <a:schemeClr val="tx1"/>
+                </a:solidFill>
+                <a:latin typeface="+mn-lt"/>
+                <a:ea typeface="+mn-ea"/>
+                <a:cs typeface="+mn-cs"/>
+              </a:defRPr>
+            </a:lvl9pPr>
+          </a:lstStyle>
+          <a:p>
+            <a:r>
+              <a:rPr lang="es-MX" dirty="0"/>
+              <a:t>RAM total: 128KiB</a:t>
+            </a:r>
+          </a:p>
+          <a:p>
+            <a:r>
+              <a:rPr lang="es-MX" dirty="0"/>
+              <a:t>Flash total: 1024KiB</a:t>
+            </a:r>
+            <a:endParaRPr lang="es-CL" dirty="0"/>
+          </a:p>
+        </p:txBody>
+      </p:sp>
+    </p:spTree>
+    <p:extLst>
+      <p:ext uri="{BB962C8B-B14F-4D97-AF65-F5344CB8AC3E}">
+        <p14:creationId xmlns:p14="http://schemas.microsoft.com/office/powerpoint/2010/main" val="852339818"/>
+      </p:ext>
+    </p:extLst>
+  </p:cSld>
+  <p:clrMapOvr>
+    <a:masterClrMapping/>
+  </p:clrMapOvr>
+</p:sld>
+</file>
+
+<file path=ppt/slides/slide23.xml><?xml version="1.0" encoding="utf-8"?>
+<p:sld xmlns:a="http://schemas.openxmlformats.org/drawingml/2006/main" xmlns:r="http://schemas.openxmlformats.org/officeDocument/2006/relationships" xmlns:p="http://schemas.openxmlformats.org/presentationml/2006/main">
+  <p:cSld>
+    <p:spTree>
+      <p:nvGrpSpPr>
+        <p:cNvPr id="1" name=""/>
+        <p:cNvGrpSpPr/>
+        <p:nvPr/>
+      </p:nvGrpSpPr>
+      <p:grpSpPr>
+        <a:xfrm>
+          <a:off x="0" y="0"/>
+          <a:ext cx="0" cy="0"/>
+          <a:chOff x="0" y="0"/>
+          <a:chExt cx="0" cy="0"/>
+        </a:xfrm>
+      </p:grpSpPr>
+      <p:sp>
+        <p:nvSpPr>
+          <p:cNvPr id="2" name="Título 1">
+            <a:extLst>
+              <a:ext uri="{FF2B5EF4-FFF2-40B4-BE49-F238E27FC236}">
+                <a16:creationId xmlns:a16="http://schemas.microsoft.com/office/drawing/2014/main" id="{1E9AB0CD-461A-85CA-6D85-80D578ABE015}"/>
+              </a:ext>
+            </a:extLst>
+          </p:cNvPr>
+          <p:cNvSpPr>
+            <a:spLocks noGrp="1"/>
+          </p:cNvSpPr>
+          <p:nvPr>
+            <p:ph type="title"/>
+          </p:nvPr>
+        </p:nvSpPr>
+        <p:spPr/>
+        <p:txBody>
+          <a:bodyPr/>
+          <a:lstStyle/>
+          <a:p>
+            <a:endParaRPr lang="es-CL" dirty="0"/>
+          </a:p>
+        </p:txBody>
+      </p:sp>
+      <p:sp>
+        <p:nvSpPr>
+          <p:cNvPr id="3" name="Marcador de texto 2">
+            <a:extLst>
+              <a:ext uri="{FF2B5EF4-FFF2-40B4-BE49-F238E27FC236}">
+                <a16:creationId xmlns:a16="http://schemas.microsoft.com/office/drawing/2014/main" id="{5DA08BCD-E184-33F4-267B-6208FCAE658F}"/>
+              </a:ext>
+            </a:extLst>
+          </p:cNvPr>
+          <p:cNvSpPr>
+            <a:spLocks noGrp="1"/>
+          </p:cNvSpPr>
+          <p:nvPr>
+            <p:ph type="body" idx="1"/>
+          </p:nvPr>
+        </p:nvSpPr>
+        <p:spPr/>
+        <p:txBody>
+          <a:bodyPr/>
+          <a:lstStyle/>
+          <a:p>
+            <a:endParaRPr lang="es-CL"/>
+          </a:p>
+        </p:txBody>
+      </p:sp>
+      <p:sp>
+        <p:nvSpPr>
+          <p:cNvPr id="4" name="Marcador de contenido 3">
+            <a:extLst>
+              <a:ext uri="{FF2B5EF4-FFF2-40B4-BE49-F238E27FC236}">
+                <a16:creationId xmlns:a16="http://schemas.microsoft.com/office/drawing/2014/main" id="{2100754F-F9E1-21F8-26F7-6339562859CD}"/>
+              </a:ext>
+            </a:extLst>
+          </p:cNvPr>
+          <p:cNvSpPr>
+            <a:spLocks noGrp="1"/>
+          </p:cNvSpPr>
+          <p:nvPr>
+            <p:ph sz="half" idx="2"/>
+          </p:nvPr>
+        </p:nvSpPr>
+        <p:spPr/>
+        <p:txBody>
+          <a:bodyPr/>
+          <a:lstStyle/>
+          <a:p>
+            <a:endParaRPr lang="es-CL"/>
+          </a:p>
+        </p:txBody>
+      </p:sp>
+      <p:sp>
+        <p:nvSpPr>
+          <p:cNvPr id="5" name="Marcador de texto 4">
+            <a:extLst>
+              <a:ext uri="{FF2B5EF4-FFF2-40B4-BE49-F238E27FC236}">
+                <a16:creationId xmlns:a16="http://schemas.microsoft.com/office/drawing/2014/main" id="{417E75EA-8371-C63D-CF85-056D09749E86}"/>
+              </a:ext>
+            </a:extLst>
+          </p:cNvPr>
+          <p:cNvSpPr>
+            <a:spLocks noGrp="1"/>
+          </p:cNvSpPr>
+          <p:nvPr>
+            <p:ph type="body" sz="quarter" idx="3"/>
+          </p:nvPr>
+        </p:nvSpPr>
+        <p:spPr/>
+        <p:txBody>
+          <a:bodyPr/>
+          <a:lstStyle/>
+          <a:p>
+            <a:endParaRPr lang="es-CL"/>
+          </a:p>
+        </p:txBody>
+      </p:sp>
+      <p:sp>
+        <p:nvSpPr>
+          <p:cNvPr id="6" name="Marcador de contenido 5">
+            <a:extLst>
+              <a:ext uri="{FF2B5EF4-FFF2-40B4-BE49-F238E27FC236}">
+                <a16:creationId xmlns:a16="http://schemas.microsoft.com/office/drawing/2014/main" id="{F8451E4A-9747-69B0-D836-7849CC69617F}"/>
+              </a:ext>
+            </a:extLst>
+          </p:cNvPr>
+          <p:cNvSpPr>
+            <a:spLocks noGrp="1"/>
+          </p:cNvSpPr>
+          <p:nvPr>
+            <p:ph sz="quarter" idx="4"/>
+          </p:nvPr>
+        </p:nvSpPr>
+        <p:spPr/>
+        <p:txBody>
+          <a:bodyPr/>
+          <a:lstStyle/>
+          <a:p>
+            <a:endParaRPr lang="es-CL"/>
+          </a:p>
+        </p:txBody>
+      </p:sp>
+      <p:sp>
+        <p:nvSpPr>
+          <p:cNvPr id="7" name="Marcador de número de diapositiva 6">
+            <a:extLst>
+              <a:ext uri="{FF2B5EF4-FFF2-40B4-BE49-F238E27FC236}">
+                <a16:creationId xmlns:a16="http://schemas.microsoft.com/office/drawing/2014/main" id="{359E9C2D-5D10-900D-3E3F-9174CB9CB103}"/>
+              </a:ext>
+            </a:extLst>
+          </p:cNvPr>
+          <p:cNvSpPr>
+            <a:spLocks noGrp="1"/>
+          </p:cNvSpPr>
+          <p:nvPr>
+            <p:ph type="sldNum" sz="quarter" idx="12"/>
+          </p:nvPr>
+        </p:nvSpPr>
+        <p:spPr/>
+        <p:txBody>
+          <a:bodyPr/>
+          <a:lstStyle/>
+          <a:p>
+            <a:fld id="{29B47543-ED2D-461E-8250-4200DFF84A65}" type="slidenum">
+              <a:rPr lang="es-CL" smtClean="0"/>
+              <a:t>23</a:t>
+            </a:fld>
+            <a:endParaRPr lang="es-CL"/>
+          </a:p>
+        </p:txBody>
+      </p:sp>
+    </p:spTree>
+    <p:extLst>
+      <p:ext uri="{BB962C8B-B14F-4D97-AF65-F5344CB8AC3E}">
+        <p14:creationId xmlns:p14="http://schemas.microsoft.com/office/powerpoint/2010/main" val="3977960472"/>
       </p:ext>
     </p:extLst>
   </p:cSld>
@@ -9863,20 +11349,20 @@
 </file>
 
 <file path=customXml/item1.xml><?xml version="1.0" encoding="utf-8"?>
-<p:properties xmlns:p="http://schemas.microsoft.com/office/2006/metadata/properties" xmlns:xsi="http://www.w3.org/2001/XMLSchema-instance" xmlns:pc="http://schemas.microsoft.com/office/infopath/2007/PartnerControls">
-  <documentManagement>
-    <_activity xmlns="1ca73e69-5c0b-48ea-a835-779e1875cab4" xsi:nil="true"/>
-  </documentManagement>
-</p:properties>
-</file>
-
-<file path=customXml/item2.xml><?xml version="1.0" encoding="utf-8"?>
 <?mso-contentType ?>
 <FormTemplates xmlns="http://schemas.microsoft.com/sharepoint/v3/contenttype/forms">
   <Display>DocumentLibraryForm</Display>
   <Edit>DocumentLibraryForm</Edit>
   <New>DocumentLibraryForm</New>
 </FormTemplates>
+</file>
+
+<file path=customXml/item2.xml><?xml version="1.0" encoding="utf-8"?>
+<p:properties xmlns:p="http://schemas.microsoft.com/office/2006/metadata/properties" xmlns:xsi="http://www.w3.org/2001/XMLSchema-instance" xmlns:pc="http://schemas.microsoft.com/office/infopath/2007/PartnerControls">
+  <documentManagement>
+    <_activity xmlns="1ca73e69-5c0b-48ea-a835-779e1875cab4" xsi:nil="true"/>
+  </documentManagement>
+</p:properties>
 </file>
 
 <file path=customXml/item3.xml><?xml version="1.0" encoding="utf-8"?>
@@ -10107,6 +11593,14 @@
 </file>
 
 <file path=customXml/itemProps1.xml><?xml version="1.0" encoding="utf-8"?>
+<ds:datastoreItem xmlns:ds="http://schemas.openxmlformats.org/officeDocument/2006/customXml" ds:itemID="{7C14A90D-02DD-47F0-BF02-A623F5D74365}">
+  <ds:schemaRefs>
+    <ds:schemaRef ds:uri="http://schemas.microsoft.com/sharepoint/v3/contenttype/forms"/>
+  </ds:schemaRefs>
+</ds:datastoreItem>
+</file>
+
+<file path=customXml/itemProps2.xml><?xml version="1.0" encoding="utf-8"?>
 <ds:datastoreItem xmlns:ds="http://schemas.openxmlformats.org/officeDocument/2006/customXml" ds:itemID="{64D3A0E1-0556-456A-B99D-21EE789AEAD0}">
   <ds:schemaRefs>
     <ds:schemaRef ds:uri="1ca73e69-5c0b-48ea-a835-779e1875cab4"/>
@@ -10119,14 +11613,6 @@
     <ds:schemaRef ds:uri="http://schemas.microsoft.com/office/infopath/2007/PartnerControls"/>
     <ds:schemaRef ds:uri="http://schemas.openxmlformats.org/package/2006/metadata/core-properties"/>
     <ds:schemaRef ds:uri="http://purl.org/dc/terms/"/>
-  </ds:schemaRefs>
-</ds:datastoreItem>
-</file>
-
-<file path=customXml/itemProps2.xml><?xml version="1.0" encoding="utf-8"?>
-<ds:datastoreItem xmlns:ds="http://schemas.openxmlformats.org/officeDocument/2006/customXml" ds:itemID="{7C14A90D-02DD-47F0-BF02-A623F5D74365}">
-  <ds:schemaRefs>
-    <ds:schemaRef ds:uri="http://schemas.microsoft.com/sharepoint/v3/contenttype/forms"/>
   </ds:schemaRefs>
 </ds:datastoreItem>
 </file>

</xml_diff>

<commit_message>
Funcionando con 5 dedos, pero s2f5 está raro
</commit_message>
<xml_diff>
--- a/Edge Computing para Control Biónico con Señales Cerebrales.pptx
+++ b/Edge Computing para Control Biónico con Señales Cerebrales.pptx
@@ -2755,7 +2755,7 @@
           <a:p>
             <a:fld id="{9D46E1BC-9D70-4B9E-9845-30E6A0E439DE}" type="datetimeFigureOut">
               <a:rPr lang="es-CL" smtClean="0"/>
-              <a:t>30-06-2025</a:t>
+              <a:t>01-07-2025</a:t>
             </a:fld>
             <a:endParaRPr lang="es-CL"/>
           </a:p>
@@ -3271,7 +3271,7 @@
           <a:p>
             <a:fld id="{3057AFD2-2E50-47EA-8313-7EE0BF4DB844}" type="datetime1">
               <a:rPr lang="es-CL" smtClean="0"/>
-              <a:t>30-06-2025</a:t>
+              <a:t>01-07-2025</a:t>
             </a:fld>
             <a:endParaRPr lang="es-CL"/>
           </a:p>
@@ -3471,7 +3471,7 @@
           <a:p>
             <a:fld id="{9ABB4C2D-AC9D-4A03-9EA0-41CC1E8B638D}" type="datetime1">
               <a:rPr lang="es-CL" smtClean="0"/>
-              <a:t>30-06-2025</a:t>
+              <a:t>01-07-2025</a:t>
             </a:fld>
             <a:endParaRPr lang="es-CL"/>
           </a:p>
@@ -3681,7 +3681,7 @@
           <a:p>
             <a:fld id="{4491CB44-4C5E-4FE6-A739-2EEEC509E2E3}" type="datetime1">
               <a:rPr lang="es-CL" smtClean="0"/>
-              <a:t>30-06-2025</a:t>
+              <a:t>01-07-2025</a:t>
             </a:fld>
             <a:endParaRPr lang="es-CL"/>
           </a:p>
@@ -3881,7 +3881,7 @@
           <a:p>
             <a:fld id="{C635104C-855C-4B6C-890D-4AB2CA091A63}" type="datetime1">
               <a:rPr lang="es-CL" smtClean="0"/>
-              <a:t>30-06-2025</a:t>
+              <a:t>01-07-2025</a:t>
             </a:fld>
             <a:endParaRPr lang="es-CL"/>
           </a:p>
@@ -4157,7 +4157,7 @@
           <a:p>
             <a:fld id="{2CA4F56F-FFB5-4D4F-8157-A3F6E1208686}" type="datetime1">
               <a:rPr lang="es-CL" smtClean="0"/>
-              <a:t>30-06-2025</a:t>
+              <a:t>01-07-2025</a:t>
             </a:fld>
             <a:endParaRPr lang="es-CL"/>
           </a:p>
@@ -4425,7 +4425,7 @@
           <a:p>
             <a:fld id="{0FBFB81C-3238-4E55-BBDB-ABD3B47D33C3}" type="datetime1">
               <a:rPr lang="es-CL" smtClean="0"/>
-              <a:t>30-06-2025</a:t>
+              <a:t>01-07-2025</a:t>
             </a:fld>
             <a:endParaRPr lang="es-CL"/>
           </a:p>
@@ -4840,7 +4840,7 @@
           <a:p>
             <a:fld id="{9142CA42-5823-44DC-A2D8-66A69FC1D8A5}" type="datetime1">
               <a:rPr lang="es-CL" smtClean="0"/>
-              <a:t>30-06-2025</a:t>
+              <a:t>01-07-2025</a:t>
             </a:fld>
             <a:endParaRPr lang="es-CL"/>
           </a:p>
@@ -4982,7 +4982,7 @@
           <a:p>
             <a:fld id="{08679031-1A41-476F-B818-FB293F04499D}" type="datetime1">
               <a:rPr lang="es-CL" smtClean="0"/>
-              <a:t>30-06-2025</a:t>
+              <a:t>01-07-2025</a:t>
             </a:fld>
             <a:endParaRPr lang="es-CL"/>
           </a:p>
@@ -5095,7 +5095,7 @@
           <a:p>
             <a:fld id="{D8AE8DE8-1FED-46DA-9654-E74B4A7C5DEA}" type="datetime1">
               <a:rPr lang="es-CL" smtClean="0"/>
-              <a:t>30-06-2025</a:t>
+              <a:t>01-07-2025</a:t>
             </a:fld>
             <a:endParaRPr lang="es-CL"/>
           </a:p>
@@ -5408,7 +5408,7 @@
           <a:p>
             <a:fld id="{DC537023-F69E-4452-B72E-2DEE3AFB9C53}" type="datetime1">
               <a:rPr lang="es-CL" smtClean="0"/>
-              <a:t>30-06-2025</a:t>
+              <a:t>01-07-2025</a:t>
             </a:fld>
             <a:endParaRPr lang="es-CL"/>
           </a:p>
@@ -5697,7 +5697,7 @@
           <a:p>
             <a:fld id="{81819FF8-2823-4B85-80F1-6DE0C3C2B12E}" type="datetime1">
               <a:rPr lang="es-CL" smtClean="0"/>
-              <a:t>30-06-2025</a:t>
+              <a:t>01-07-2025</a:t>
             </a:fld>
             <a:endParaRPr lang="es-CL"/>
           </a:p>
@@ -5940,7 +5940,7 @@
           <a:p>
             <a:fld id="{A8AC9CAF-9571-4308-BC43-45FC52060C70}" type="datetime1">
               <a:rPr lang="es-CL" smtClean="0"/>
-              <a:t>30-06-2025</a:t>
+              <a:t>01-07-2025</a:t>
             </a:fld>
             <a:endParaRPr lang="es-CL"/>
           </a:p>
@@ -11349,20 +11349,20 @@
 </file>
 
 <file path=customXml/item1.xml><?xml version="1.0" encoding="utf-8"?>
+<p:properties xmlns:p="http://schemas.microsoft.com/office/2006/metadata/properties" xmlns:xsi="http://www.w3.org/2001/XMLSchema-instance" xmlns:pc="http://schemas.microsoft.com/office/infopath/2007/PartnerControls">
+  <documentManagement>
+    <_activity xmlns="1ca73e69-5c0b-48ea-a835-779e1875cab4" xsi:nil="true"/>
+  </documentManagement>
+</p:properties>
+</file>
+
+<file path=customXml/item2.xml><?xml version="1.0" encoding="utf-8"?>
 <?mso-contentType ?>
 <FormTemplates xmlns="http://schemas.microsoft.com/sharepoint/v3/contenttype/forms">
   <Display>DocumentLibraryForm</Display>
   <Edit>DocumentLibraryForm</Edit>
   <New>DocumentLibraryForm</New>
 </FormTemplates>
-</file>
-
-<file path=customXml/item2.xml><?xml version="1.0" encoding="utf-8"?>
-<p:properties xmlns:p="http://schemas.microsoft.com/office/2006/metadata/properties" xmlns:xsi="http://www.w3.org/2001/XMLSchema-instance" xmlns:pc="http://schemas.microsoft.com/office/infopath/2007/PartnerControls">
-  <documentManagement>
-    <_activity xmlns="1ca73e69-5c0b-48ea-a835-779e1875cab4" xsi:nil="true"/>
-  </documentManagement>
-</p:properties>
 </file>
 
 <file path=customXml/item3.xml><?xml version="1.0" encoding="utf-8"?>
@@ -11593,14 +11593,6 @@
 </file>
 
 <file path=customXml/itemProps1.xml><?xml version="1.0" encoding="utf-8"?>
-<ds:datastoreItem xmlns:ds="http://schemas.openxmlformats.org/officeDocument/2006/customXml" ds:itemID="{7C14A90D-02DD-47F0-BF02-A623F5D74365}">
-  <ds:schemaRefs>
-    <ds:schemaRef ds:uri="http://schemas.microsoft.com/sharepoint/v3/contenttype/forms"/>
-  </ds:schemaRefs>
-</ds:datastoreItem>
-</file>
-
-<file path=customXml/itemProps2.xml><?xml version="1.0" encoding="utf-8"?>
 <ds:datastoreItem xmlns:ds="http://schemas.openxmlformats.org/officeDocument/2006/customXml" ds:itemID="{64D3A0E1-0556-456A-B99D-21EE789AEAD0}">
   <ds:schemaRefs>
     <ds:schemaRef ds:uri="1ca73e69-5c0b-48ea-a835-779e1875cab4"/>
@@ -11613,6 +11605,14 @@
     <ds:schemaRef ds:uri="http://schemas.microsoft.com/office/infopath/2007/PartnerControls"/>
     <ds:schemaRef ds:uri="http://schemas.openxmlformats.org/package/2006/metadata/core-properties"/>
     <ds:schemaRef ds:uri="http://purl.org/dc/terms/"/>
+  </ds:schemaRefs>
+</ds:datastoreItem>
+</file>
+
+<file path=customXml/itemProps2.xml><?xml version="1.0" encoding="utf-8"?>
+<ds:datastoreItem xmlns:ds="http://schemas.openxmlformats.org/officeDocument/2006/customXml" ds:itemID="{7C14A90D-02DD-47F0-BF02-A623F5D74365}">
+  <ds:schemaRefs>
+    <ds:schemaRef ds:uri="http://schemas.microsoft.com/sharepoint/v3/contenttype/forms"/>
   </ds:schemaRefs>
 </ds:datastoreItem>
 </file>

</xml_diff>

<commit_message>
MSE => MAE, y se arreglan los códigos de evaluación
</commit_message>
<xml_diff>
--- a/Edge Computing para Control Biónico con Señales Cerebrales.pptx
+++ b/Edge Computing para Control Biónico con Señales Cerebrales.pptx
@@ -2755,7 +2755,7 @@
           <a:p>
             <a:fld id="{9D46E1BC-9D70-4B9E-9845-30E6A0E439DE}" type="datetimeFigureOut">
               <a:rPr lang="es-CL" smtClean="0"/>
-              <a:t>01-07-2025</a:t>
+              <a:t>04-07-2025</a:t>
             </a:fld>
             <a:endParaRPr lang="es-CL"/>
           </a:p>
@@ -3271,7 +3271,7 @@
           <a:p>
             <a:fld id="{3057AFD2-2E50-47EA-8313-7EE0BF4DB844}" type="datetime1">
               <a:rPr lang="es-CL" smtClean="0"/>
-              <a:t>01-07-2025</a:t>
+              <a:t>04-07-2025</a:t>
             </a:fld>
             <a:endParaRPr lang="es-CL"/>
           </a:p>
@@ -3471,7 +3471,7 @@
           <a:p>
             <a:fld id="{9ABB4C2D-AC9D-4A03-9EA0-41CC1E8B638D}" type="datetime1">
               <a:rPr lang="es-CL" smtClean="0"/>
-              <a:t>01-07-2025</a:t>
+              <a:t>04-07-2025</a:t>
             </a:fld>
             <a:endParaRPr lang="es-CL"/>
           </a:p>
@@ -3681,7 +3681,7 @@
           <a:p>
             <a:fld id="{4491CB44-4C5E-4FE6-A739-2EEEC509E2E3}" type="datetime1">
               <a:rPr lang="es-CL" smtClean="0"/>
-              <a:t>01-07-2025</a:t>
+              <a:t>04-07-2025</a:t>
             </a:fld>
             <a:endParaRPr lang="es-CL"/>
           </a:p>
@@ -3881,7 +3881,7 @@
           <a:p>
             <a:fld id="{C635104C-855C-4B6C-890D-4AB2CA091A63}" type="datetime1">
               <a:rPr lang="es-CL" smtClean="0"/>
-              <a:t>01-07-2025</a:t>
+              <a:t>04-07-2025</a:t>
             </a:fld>
             <a:endParaRPr lang="es-CL"/>
           </a:p>
@@ -4157,7 +4157,7 @@
           <a:p>
             <a:fld id="{2CA4F56F-FFB5-4D4F-8157-A3F6E1208686}" type="datetime1">
               <a:rPr lang="es-CL" smtClean="0"/>
-              <a:t>01-07-2025</a:t>
+              <a:t>04-07-2025</a:t>
             </a:fld>
             <a:endParaRPr lang="es-CL"/>
           </a:p>
@@ -4425,7 +4425,7 @@
           <a:p>
             <a:fld id="{0FBFB81C-3238-4E55-BBDB-ABD3B47D33C3}" type="datetime1">
               <a:rPr lang="es-CL" smtClean="0"/>
-              <a:t>01-07-2025</a:t>
+              <a:t>04-07-2025</a:t>
             </a:fld>
             <a:endParaRPr lang="es-CL"/>
           </a:p>
@@ -4840,7 +4840,7 @@
           <a:p>
             <a:fld id="{9142CA42-5823-44DC-A2D8-66A69FC1D8A5}" type="datetime1">
               <a:rPr lang="es-CL" smtClean="0"/>
-              <a:t>01-07-2025</a:t>
+              <a:t>04-07-2025</a:t>
             </a:fld>
             <a:endParaRPr lang="es-CL"/>
           </a:p>
@@ -4982,7 +4982,7 @@
           <a:p>
             <a:fld id="{08679031-1A41-476F-B818-FB293F04499D}" type="datetime1">
               <a:rPr lang="es-CL" smtClean="0"/>
-              <a:t>01-07-2025</a:t>
+              <a:t>04-07-2025</a:t>
             </a:fld>
             <a:endParaRPr lang="es-CL"/>
           </a:p>
@@ -5095,7 +5095,7 @@
           <a:p>
             <a:fld id="{D8AE8DE8-1FED-46DA-9654-E74B4A7C5DEA}" type="datetime1">
               <a:rPr lang="es-CL" smtClean="0"/>
-              <a:t>01-07-2025</a:t>
+              <a:t>04-07-2025</a:t>
             </a:fld>
             <a:endParaRPr lang="es-CL"/>
           </a:p>
@@ -5408,7 +5408,7 @@
           <a:p>
             <a:fld id="{DC537023-F69E-4452-B72E-2DEE3AFB9C53}" type="datetime1">
               <a:rPr lang="es-CL" smtClean="0"/>
-              <a:t>01-07-2025</a:t>
+              <a:t>04-07-2025</a:t>
             </a:fld>
             <a:endParaRPr lang="es-CL"/>
           </a:p>
@@ -5697,7 +5697,7 @@
           <a:p>
             <a:fld id="{81819FF8-2823-4B85-80F1-6DE0C3C2B12E}" type="datetime1">
               <a:rPr lang="es-CL" smtClean="0"/>
-              <a:t>01-07-2025</a:t>
+              <a:t>04-07-2025</a:t>
             </a:fld>
             <a:endParaRPr lang="es-CL"/>
           </a:p>
@@ -5940,7 +5940,7 @@
           <a:p>
             <a:fld id="{A8AC9CAF-9571-4308-BC43-45FC52060C70}" type="datetime1">
               <a:rPr lang="es-CL" smtClean="0"/>
-              <a:t>01-07-2025</a:t>
+              <a:t>04-07-2025</a:t>
             </a:fld>
             <a:endParaRPr lang="es-CL"/>
           </a:p>
@@ -11357,15 +11357,6 @@
 </file>
 
 <file path=customXml/item2.xml><?xml version="1.0" encoding="utf-8"?>
-<?mso-contentType ?>
-<FormTemplates xmlns="http://schemas.microsoft.com/sharepoint/v3/contenttype/forms">
-  <Display>DocumentLibraryForm</Display>
-  <Edit>DocumentLibraryForm</Edit>
-  <New>DocumentLibraryForm</New>
-</FormTemplates>
-</file>
-
-<file path=customXml/item3.xml><?xml version="1.0" encoding="utf-8"?>
 <ct:contentTypeSchema xmlns:ct="http://schemas.microsoft.com/office/2006/metadata/contentType" xmlns:ma="http://schemas.microsoft.com/office/2006/metadata/properties/metaAttributes" ct:_="" ma:_="" ma:contentTypeName="Documento" ma:contentTypeID="0x0101000350BC36331587468FC1264AE40710EA" ma:contentTypeVersion="14" ma:contentTypeDescription="Crear nuevo documento." ma:contentTypeScope="" ma:versionID="87be5154aa1b102034f80a264d154dfa">
   <xsd:schema xmlns:xsd="http://www.w3.org/2001/XMLSchema" xmlns:xs="http://www.w3.org/2001/XMLSchema" xmlns:p="http://schemas.microsoft.com/office/2006/metadata/properties" xmlns:ns3="1ca73e69-5c0b-48ea-a835-779e1875cab4" xmlns:ns4="73f6c764-4f9c-4529-97a4-e6108ddfe422" targetNamespace="http://schemas.microsoft.com/office/2006/metadata/properties" ma:root="true" ma:fieldsID="37624e3746ebb616b7d5e7f6a525cb5b" ns3:_="" ns4:_="">
     <xsd:import namespace="1ca73e69-5c0b-48ea-a835-779e1875cab4"/>
@@ -11592,6 +11583,15 @@
 </ct:contentTypeSchema>
 </file>
 
+<file path=customXml/item3.xml><?xml version="1.0" encoding="utf-8"?>
+<?mso-contentType ?>
+<FormTemplates xmlns="http://schemas.microsoft.com/sharepoint/v3/contenttype/forms">
+  <Display>DocumentLibraryForm</Display>
+  <Edit>DocumentLibraryForm</Edit>
+  <New>DocumentLibraryForm</New>
+</FormTemplates>
+</file>
+
 <file path=customXml/itemProps1.xml><?xml version="1.0" encoding="utf-8"?>
 <ds:datastoreItem xmlns:ds="http://schemas.openxmlformats.org/officeDocument/2006/customXml" ds:itemID="{64D3A0E1-0556-456A-B99D-21EE789AEAD0}">
   <ds:schemaRefs>
@@ -11610,14 +11610,6 @@
 </file>
 
 <file path=customXml/itemProps2.xml><?xml version="1.0" encoding="utf-8"?>
-<ds:datastoreItem xmlns:ds="http://schemas.openxmlformats.org/officeDocument/2006/customXml" ds:itemID="{7C14A90D-02DD-47F0-BF02-A623F5D74365}">
-  <ds:schemaRefs>
-    <ds:schemaRef ds:uri="http://schemas.microsoft.com/sharepoint/v3/contenttype/forms"/>
-  </ds:schemaRefs>
-</ds:datastoreItem>
-</file>
-
-<file path=customXml/itemProps3.xml><?xml version="1.0" encoding="utf-8"?>
 <ds:datastoreItem xmlns:ds="http://schemas.openxmlformats.org/officeDocument/2006/customXml" ds:itemID="{3DF8B472-1F73-4C42-A139-622080E0BEA1}">
   <ds:schemaRefs>
     <ds:schemaRef ds:uri="1ca73e69-5c0b-48ea-a835-779e1875cab4"/>
@@ -11634,4 +11626,12 @@
     <ds:schemaRef ds:uri="http://www.w3.org/2001/XMLSchema"/>
   </ds:schemaRefs>
 </ds:datastoreItem>
+</file>
+
+<file path=customXml/itemProps3.xml><?xml version="1.0" encoding="utf-8"?>
+<ds:datastoreItem xmlns:ds="http://schemas.openxmlformats.org/officeDocument/2006/customXml" ds:itemID="{7C14A90D-02DD-47F0-BF02-A623F5D74365}">
+  <ds:schemaRefs>
+    <ds:schemaRef ds:uri="http://schemas.microsoft.com/sharepoint/v3/contenttype/forms"/>
+  </ds:schemaRefs>
+</ds:datastoreItem>
 </file>
</xml_diff>